<commit_message>
fix(security): add requireBroker auth guard to 6 unprotected broker API routes
- ideal-buyer-persona: blocked unauthenticated LLM calls (30s→90ms)
- studio/ai-comment: blocked unauthenticated callLLM
- reports/owner: blocked unauthenticated DB+AI report generation
- pitch: blocked unauthenticated pitch generation
- share-link: added auth to POST+GET handlers
- share-link/revoke: blocked unauthenticated link revocation

Also adds MECE 24-pipeline E2E test suite (62 vitest + 32 runner tests)
and fixes test API contract mismatches (scorePct, extractKeyFacts, RiskStatus)
</commit_message>
<xml_diff>
--- a/docs/test/stress/e2e-outputs/development_case12_yeoksam_dev_basic.pptx
+++ b/docs/test/stress/e2e-outputs/development_case12_yeoksam_dev_basic.pptx
@@ -4221,6 +4221,45 @@
         <p:spPr>
           <a:xfrm>
             <a:off x="6053328" y="1481328"/>
+            <a:ext cx="5571439" cy="237744"/>
+          </a:xfrm>
+          <a:prstGeom prst="rect">
+            <a:avLst/>
+          </a:prstGeom>
+          <a:noFill/>
+          <a:ln/>
+        </p:spPr>
+        <p:txBody>
+          <a:bodyPr wrap="square" lIns="0" tIns="0" rIns="0" bIns="0" rtlCol="0" anchor="ctr"/>
+          <a:lstStyle/>
+          <a:p>
+            <a:pPr indent="0" marL="0">
+              <a:buNone/>
+            </a:pPr>
+            <a:r>
+              <a:rPr lang="en-US" sz="1100" b="1" dirty="0">
+                <a:solidFill>
+                  <a:srgbClr val="0F172A"/>
+                </a:solidFill>
+                <a:latin typeface="Pretendard" pitchFamily="34" charset="0"/>
+                <a:ea typeface="Pretendard" pitchFamily="34" charset="-122"/>
+                <a:cs typeface="Pretendard" pitchFamily="34" charset="-120"/>
+              </a:rPr>
+              <a:t>교통 및 도로 접근성</a:t>
+            </a:r>
+            <a:endParaRPr lang="en-US" sz="1100" dirty="0"/>
+          </a:p>
+        </p:txBody>
+      </p:sp>
+      <p:sp>
+        <p:nvSpPr>
+          <p:cNvPr id="7" name="Text 4"/>
+          <p:cNvSpPr/>
+          <p:nvPr/>
+        </p:nvSpPr>
+        <p:spPr>
+          <a:xfrm>
+            <a:off x="6053328" y="1801368"/>
             <a:ext cx="2117147" cy="438912"/>
           </a:xfrm>
           <a:prstGeom prst="rect">
@@ -4248,7 +4287,7 @@
                 <a:ea typeface="Pretendard" pitchFamily="34" charset="-122"/>
                 <a:cs typeface="Pretendard" pitchFamily="34" charset="-120"/>
               </a:rPr>
-              <a:t>교통 접근성</a:t>
+              <a:t>지하철 접근성</a:t>
             </a:r>
             <a:endParaRPr lang="en-US" sz="1400" dirty="0"/>
           </a:p>
@@ -4256,13 +4295,13 @@
       </p:sp>
       <p:sp>
         <p:nvSpPr>
-          <p:cNvPr id="7" name="Text 4"/>
-          <p:cNvSpPr/>
-          <p:nvPr/>
-        </p:nvSpPr>
-        <p:spPr>
-          <a:xfrm>
-            <a:off x="8170475" y="1481328"/>
+          <p:cNvPr id="8" name="Text 5"/>
+          <p:cNvSpPr/>
+          <p:nvPr/>
+        </p:nvSpPr>
+        <p:spPr>
+          <a:xfrm>
+            <a:off x="8170475" y="1801368"/>
             <a:ext cx="3454292" cy="438912"/>
           </a:xfrm>
           <a:prstGeom prst="rect">
@@ -4290,7 +4329,7 @@
                 <a:ea typeface="Pretendard" pitchFamily="34" charset="-122"/>
                 <a:cs typeface="Pretendard" pitchFamily="34" charset="-120"/>
               </a:rPr>
-              <a:t>{"ok":true,"mocked":true,"extractedFields":{"area_signal":"역…</a:t>
+              <a:t>강남역(2호선·신분당선) 및 양재역(3호선) 더블역세권 도보 4분</a:t>
             </a:r>
             <a:endParaRPr lang="en-US" sz="1400" dirty="0"/>
           </a:p>
@@ -4298,7 +4337,542 @@
       </p:sp>
       <p:sp>
         <p:nvSpPr>
-          <p:cNvPr id="8" name="Text 5"/>
+          <p:cNvPr id="9" name="Shape 6"/>
+          <p:cNvSpPr/>
+          <p:nvPr/>
+        </p:nvSpPr>
+        <p:spPr>
+          <a:xfrm>
+            <a:off x="6053328" y="2240280"/>
+            <a:ext cx="5571439" cy="0"/>
+          </a:xfrm>
+          <a:prstGeom prst="line">
+            <a:avLst/>
+          </a:prstGeom>
+          <a:noFill/>
+          <a:ln w="3810">
+            <a:solidFill>
+              <a:srgbClr val="CBD5E1"/>
+            </a:solidFill>
+            <a:prstDash val="solid"/>
+          </a:ln>
+        </p:spPr>
+      </p:sp>
+      <p:sp>
+        <p:nvSpPr>
+          <p:cNvPr id="10" name="Text 7"/>
+          <p:cNvSpPr/>
+          <p:nvPr/>
+        </p:nvSpPr>
+        <p:spPr>
+          <a:xfrm>
+            <a:off x="6053328" y="2240280"/>
+            <a:ext cx="2117147" cy="438912"/>
+          </a:xfrm>
+          <a:prstGeom prst="rect">
+            <a:avLst/>
+          </a:prstGeom>
+          <a:noFill/>
+          <a:ln/>
+        </p:spPr>
+        <p:txBody>
+          <a:bodyPr wrap="square" lIns="0" tIns="0" rIns="0" bIns="0" rtlCol="0" anchor="ctr"/>
+          <a:lstStyle/>
+          <a:p>
+            <a:pPr indent="0" marL="0">
+              <a:lnSpc>
+                <a:spcPct val="120000"/>
+              </a:lnSpc>
+              <a:buNone/>
+            </a:pPr>
+            <a:r>
+              <a:rPr lang="en-US" sz="1400" dirty="0">
+                <a:solidFill>
+                  <a:srgbClr val="64748B"/>
+                </a:solidFill>
+                <a:latin typeface="Pretendard" pitchFamily="34" charset="0"/>
+                <a:ea typeface="Pretendard" pitchFamily="34" charset="-122"/>
+                <a:cs typeface="Pretendard" pitchFamily="34" charset="-120"/>
+              </a:rPr>
+              <a:t>도로 접면 조건</a:t>
+            </a:r>
+            <a:endParaRPr lang="en-US" sz="1400" dirty="0"/>
+          </a:p>
+        </p:txBody>
+      </p:sp>
+      <p:sp>
+        <p:nvSpPr>
+          <p:cNvPr id="11" name="Text 8"/>
+          <p:cNvSpPr/>
+          <p:nvPr/>
+        </p:nvSpPr>
+        <p:spPr>
+          <a:xfrm>
+            <a:off x="8170475" y="2240280"/>
+            <a:ext cx="3454292" cy="438912"/>
+          </a:xfrm>
+          <a:prstGeom prst="rect">
+            <a:avLst/>
+          </a:prstGeom>
+          <a:noFill/>
+          <a:ln/>
+        </p:spPr>
+        <p:txBody>
+          <a:bodyPr wrap="square" lIns="0" tIns="0" rIns="0" bIns="0" rtlCol="0" anchor="ctr"/>
+          <a:lstStyle/>
+          <a:p>
+            <a:pPr indent="0" marL="0">
+              <a:lnSpc>
+                <a:spcPct val="120000"/>
+              </a:lnSpc>
+              <a:buNone/>
+            </a:pPr>
+            <a:r>
+              <a:rPr lang="en-US" sz="1400" b="1" dirty="0">
+                <a:solidFill>
+                  <a:srgbClr val="0F172A"/>
+                </a:solidFill>
+                <a:latin typeface="Pretendard" pitchFamily="34" charset="0"/>
+                <a:ea typeface="Pretendard" pitchFamily="34" charset="-122"/>
+                <a:cs typeface="Pretendard" pitchFamily="34" charset="-120"/>
+              </a:rPr>
+              <a:t>서초대로 25m 메인 대로변 접면</a:t>
+            </a:r>
+            <a:endParaRPr lang="en-US" sz="1400" dirty="0"/>
+          </a:p>
+        </p:txBody>
+      </p:sp>
+      <p:sp>
+        <p:nvSpPr>
+          <p:cNvPr id="12" name="Shape 9"/>
+          <p:cNvSpPr/>
+          <p:nvPr/>
+        </p:nvSpPr>
+        <p:spPr>
+          <a:xfrm>
+            <a:off x="6053328" y="2679192"/>
+            <a:ext cx="5571439" cy="0"/>
+          </a:xfrm>
+          <a:prstGeom prst="line">
+            <a:avLst/>
+          </a:prstGeom>
+          <a:noFill/>
+          <a:ln w="3810">
+            <a:solidFill>
+              <a:srgbClr val="CBD5E1"/>
+            </a:solidFill>
+            <a:prstDash val="solid"/>
+          </a:ln>
+        </p:spPr>
+      </p:sp>
+      <p:sp>
+        <p:nvSpPr>
+          <p:cNvPr id="13" name="Text 10"/>
+          <p:cNvSpPr/>
+          <p:nvPr/>
+        </p:nvSpPr>
+        <p:spPr>
+          <a:xfrm>
+            <a:off x="6053328" y="2679192"/>
+            <a:ext cx="2117147" cy="438912"/>
+          </a:xfrm>
+          <a:prstGeom prst="rect">
+            <a:avLst/>
+          </a:prstGeom>
+          <a:noFill/>
+          <a:ln/>
+        </p:spPr>
+        <p:txBody>
+          <a:bodyPr wrap="square" lIns="0" tIns="0" rIns="0" bIns="0" rtlCol="0" anchor="ctr"/>
+          <a:lstStyle/>
+          <a:p>
+            <a:pPr indent="0" marL="0">
+              <a:lnSpc>
+                <a:spcPct val="120000"/>
+              </a:lnSpc>
+              <a:buNone/>
+            </a:pPr>
+            <a:r>
+              <a:rPr lang="en-US" sz="1400" dirty="0">
+                <a:solidFill>
+                  <a:srgbClr val="64748B"/>
+                </a:solidFill>
+                <a:latin typeface="Pretendard" pitchFamily="34" charset="0"/>
+                <a:ea typeface="Pretendard" pitchFamily="34" charset="-122"/>
+                <a:cs typeface="Pretendard" pitchFamily="34" charset="-120"/>
+              </a:rPr>
+              <a:t>차량 진출입</a:t>
+            </a:r>
+            <a:endParaRPr lang="en-US" sz="1400" dirty="0"/>
+          </a:p>
+        </p:txBody>
+      </p:sp>
+      <p:sp>
+        <p:nvSpPr>
+          <p:cNvPr id="14" name="Text 11"/>
+          <p:cNvSpPr/>
+          <p:nvPr/>
+        </p:nvSpPr>
+        <p:spPr>
+          <a:xfrm>
+            <a:off x="8170475" y="2679192"/>
+            <a:ext cx="3454292" cy="438912"/>
+          </a:xfrm>
+          <a:prstGeom prst="rect">
+            <a:avLst/>
+          </a:prstGeom>
+          <a:noFill/>
+          <a:ln/>
+        </p:spPr>
+        <p:txBody>
+          <a:bodyPr wrap="square" lIns="0" tIns="0" rIns="0" bIns="0" rtlCol="0" anchor="ctr"/>
+          <a:lstStyle/>
+          <a:p>
+            <a:pPr indent="0" marL="0">
+              <a:lnSpc>
+                <a:spcPct val="120000"/>
+              </a:lnSpc>
+              <a:buNone/>
+            </a:pPr>
+            <a:r>
+              <a:rPr lang="en-US" sz="1400" b="1" dirty="0">
+                <a:solidFill>
+                  <a:srgbClr val="0F172A"/>
+                </a:solidFill>
+                <a:latin typeface="Pretendard" pitchFamily="34" charset="0"/>
+                <a:ea typeface="Pretendard" pitchFamily="34" charset="-122"/>
+                <a:cs typeface="Pretendard" pitchFamily="34" charset="-120"/>
+              </a:rPr>
+              <a:t>경부고속도로 서초IC 및 테헤란로 3분 내 진입 가능</a:t>
+            </a:r>
+            <a:endParaRPr lang="en-US" sz="1400" dirty="0"/>
+          </a:p>
+        </p:txBody>
+      </p:sp>
+      <p:sp>
+        <p:nvSpPr>
+          <p:cNvPr id="15" name="Shape 12"/>
+          <p:cNvSpPr/>
+          <p:nvPr/>
+        </p:nvSpPr>
+        <p:spPr>
+          <a:xfrm>
+            <a:off x="6053328" y="3118104"/>
+            <a:ext cx="5571439" cy="0"/>
+          </a:xfrm>
+          <a:prstGeom prst="line">
+            <a:avLst/>
+          </a:prstGeom>
+          <a:noFill/>
+          <a:ln w="3810">
+            <a:solidFill>
+              <a:srgbClr val="CBD5E1"/>
+            </a:solidFill>
+            <a:prstDash val="solid"/>
+          </a:ln>
+        </p:spPr>
+      </p:sp>
+      <p:sp>
+        <p:nvSpPr>
+          <p:cNvPr id="16" name="Text 13"/>
+          <p:cNvSpPr/>
+          <p:nvPr/>
+        </p:nvSpPr>
+        <p:spPr>
+          <a:xfrm>
+            <a:off x="6053328" y="3118104"/>
+            <a:ext cx="2117147" cy="438912"/>
+          </a:xfrm>
+          <a:prstGeom prst="rect">
+            <a:avLst/>
+          </a:prstGeom>
+          <a:noFill/>
+          <a:ln/>
+        </p:spPr>
+        <p:txBody>
+          <a:bodyPr wrap="square" lIns="0" tIns="0" rIns="0" bIns="0" rtlCol="0" anchor="ctr"/>
+          <a:lstStyle/>
+          <a:p>
+            <a:pPr indent="0" marL="0">
+              <a:lnSpc>
+                <a:spcPct val="120000"/>
+              </a:lnSpc>
+              <a:buNone/>
+            </a:pPr>
+            <a:r>
+              <a:rPr lang="en-US" sz="1400" dirty="0">
+                <a:solidFill>
+                  <a:srgbClr val="64748B"/>
+                </a:solidFill>
+                <a:latin typeface="Pretendard" pitchFamily="34" charset="0"/>
+                <a:ea typeface="Pretendard" pitchFamily="34" charset="-122"/>
+                <a:cs typeface="Pretendard" pitchFamily="34" charset="-120"/>
+              </a:rPr>
+              <a:t>배후 수요</a:t>
+            </a:r>
+            <a:endParaRPr lang="en-US" sz="1400" dirty="0"/>
+          </a:p>
+        </p:txBody>
+      </p:sp>
+      <p:sp>
+        <p:nvSpPr>
+          <p:cNvPr id="17" name="Text 14"/>
+          <p:cNvSpPr/>
+          <p:nvPr/>
+        </p:nvSpPr>
+        <p:spPr>
+          <a:xfrm>
+            <a:off x="8170475" y="3118104"/>
+            <a:ext cx="3454292" cy="438912"/>
+          </a:xfrm>
+          <a:prstGeom prst="rect">
+            <a:avLst/>
+          </a:prstGeom>
+          <a:noFill/>
+          <a:ln/>
+        </p:spPr>
+        <p:txBody>
+          <a:bodyPr wrap="square" lIns="0" tIns="0" rIns="0" bIns="0" rtlCol="0" anchor="ctr"/>
+          <a:lstStyle/>
+          <a:p>
+            <a:pPr indent="0" marL="0">
+              <a:lnSpc>
+                <a:spcPct val="120000"/>
+              </a:lnSpc>
+              <a:buNone/>
+            </a:pPr>
+            <a:r>
+              <a:rPr lang="en-US" sz="1400" b="1" dirty="0">
+                <a:solidFill>
+                  <a:srgbClr val="0F172A"/>
+                </a:solidFill>
+                <a:latin typeface="Pretendard" pitchFamily="34" charset="0"/>
+                <a:ea typeface="Pretendard" pitchFamily="34" charset="-122"/>
+                <a:cs typeface="Pretendard" pitchFamily="34" charset="-120"/>
+              </a:rPr>
+              <a:t>강남 테헤란로 IT밸리 및 서초 법조타운 오피스 상주인구 30만 배후</a:t>
+            </a:r>
+            <a:endParaRPr lang="en-US" sz="1400" dirty="0"/>
+          </a:p>
+        </p:txBody>
+      </p:sp>
+      <p:sp>
+        <p:nvSpPr>
+          <p:cNvPr id="18" name="Shape 15"/>
+          <p:cNvSpPr/>
+          <p:nvPr/>
+        </p:nvSpPr>
+        <p:spPr>
+          <a:xfrm>
+            <a:off x="6053328" y="3557016"/>
+            <a:ext cx="5571439" cy="0"/>
+          </a:xfrm>
+          <a:prstGeom prst="line">
+            <a:avLst/>
+          </a:prstGeom>
+          <a:noFill/>
+          <a:ln w="3810">
+            <a:solidFill>
+              <a:srgbClr val="CBD5E1"/>
+            </a:solidFill>
+            <a:prstDash val="solid"/>
+          </a:ln>
+        </p:spPr>
+      </p:sp>
+      <p:sp>
+        <p:nvSpPr>
+          <p:cNvPr id="19" name="Text 16"/>
+          <p:cNvSpPr/>
+          <p:nvPr/>
+        </p:nvSpPr>
+        <p:spPr>
+          <a:xfrm>
+            <a:off x="6053328" y="3557016"/>
+            <a:ext cx="2117147" cy="438912"/>
+          </a:xfrm>
+          <a:prstGeom prst="rect">
+            <a:avLst/>
+          </a:prstGeom>
+          <a:noFill/>
+          <a:ln/>
+        </p:spPr>
+        <p:txBody>
+          <a:bodyPr wrap="square" lIns="0" tIns="0" rIns="0" bIns="0" rtlCol="0" anchor="ctr"/>
+          <a:lstStyle/>
+          <a:p>
+            <a:pPr indent="0" marL="0">
+              <a:lnSpc>
+                <a:spcPct val="120000"/>
+              </a:lnSpc>
+              <a:buNone/>
+            </a:pPr>
+            <a:r>
+              <a:rPr lang="en-US" sz="1400" dirty="0">
+                <a:solidFill>
+                  <a:srgbClr val="64748B"/>
+                </a:solidFill>
+                <a:latin typeface="Pretendard" pitchFamily="34" charset="0"/>
+                <a:ea typeface="Pretendard" pitchFamily="34" charset="-122"/>
+                <a:cs typeface="Pretendard" pitchFamily="34" charset="-120"/>
+              </a:rPr>
+              <a:t>의료 상권</a:t>
+            </a:r>
+            <a:endParaRPr lang="en-US" sz="1400" dirty="0"/>
+          </a:p>
+        </p:txBody>
+      </p:sp>
+      <p:sp>
+        <p:nvSpPr>
+          <p:cNvPr id="20" name="Text 17"/>
+          <p:cNvSpPr/>
+          <p:nvPr/>
+        </p:nvSpPr>
+        <p:spPr>
+          <a:xfrm>
+            <a:off x="8170475" y="3557016"/>
+            <a:ext cx="3454292" cy="438912"/>
+          </a:xfrm>
+          <a:prstGeom prst="rect">
+            <a:avLst/>
+          </a:prstGeom>
+          <a:noFill/>
+          <a:ln/>
+        </p:spPr>
+        <p:txBody>
+          <a:bodyPr wrap="square" lIns="0" tIns="0" rIns="0" bIns="0" rtlCol="0" anchor="ctr"/>
+          <a:lstStyle/>
+          <a:p>
+            <a:pPr indent="0" marL="0">
+              <a:lnSpc>
+                <a:spcPct val="120000"/>
+              </a:lnSpc>
+              <a:buNone/>
+            </a:pPr>
+            <a:r>
+              <a:rPr lang="en-US" sz="1400" b="1" dirty="0">
+                <a:solidFill>
+                  <a:srgbClr val="0F172A"/>
+                </a:solidFill>
+                <a:latin typeface="Pretendard" pitchFamily="34" charset="0"/>
+                <a:ea typeface="Pretendard" pitchFamily="34" charset="-122"/>
+                <a:cs typeface="Pretendard" pitchFamily="34" charset="-120"/>
+              </a:rPr>
+              <a:t>1층 약국 및 상층부 안과·피부과 전문의원 집적 의료 특화 상권</a:t>
+            </a:r>
+            <a:endParaRPr lang="en-US" sz="1400" dirty="0"/>
+          </a:p>
+        </p:txBody>
+      </p:sp>
+      <p:sp>
+        <p:nvSpPr>
+          <p:cNvPr id="21" name="Shape 18"/>
+          <p:cNvSpPr/>
+          <p:nvPr/>
+        </p:nvSpPr>
+        <p:spPr>
+          <a:xfrm>
+            <a:off x="6053328" y="3995928"/>
+            <a:ext cx="5571439" cy="0"/>
+          </a:xfrm>
+          <a:prstGeom prst="line">
+            <a:avLst/>
+          </a:prstGeom>
+          <a:noFill/>
+          <a:ln w="3810">
+            <a:solidFill>
+              <a:srgbClr val="CBD5E1"/>
+            </a:solidFill>
+            <a:prstDash val="solid"/>
+          </a:ln>
+        </p:spPr>
+      </p:sp>
+      <p:sp>
+        <p:nvSpPr>
+          <p:cNvPr id="22" name="Text 19"/>
+          <p:cNvSpPr/>
+          <p:nvPr/>
+        </p:nvSpPr>
+        <p:spPr>
+          <a:xfrm>
+            <a:off x="6053328" y="3995928"/>
+            <a:ext cx="2117147" cy="438912"/>
+          </a:xfrm>
+          <a:prstGeom prst="rect">
+            <a:avLst/>
+          </a:prstGeom>
+          <a:noFill/>
+          <a:ln/>
+        </p:spPr>
+        <p:txBody>
+          <a:bodyPr wrap="square" lIns="0" tIns="0" rIns="0" bIns="0" rtlCol="0" anchor="ctr"/>
+          <a:lstStyle/>
+          <a:p>
+            <a:pPr indent="0" marL="0">
+              <a:lnSpc>
+                <a:spcPct val="120000"/>
+              </a:lnSpc>
+              <a:buNone/>
+            </a:pPr>
+            <a:r>
+              <a:rPr lang="en-US" sz="1400" dirty="0">
+                <a:solidFill>
+                  <a:srgbClr val="64748B"/>
+                </a:solidFill>
+                <a:latin typeface="Pretendard" pitchFamily="34" charset="0"/>
+                <a:ea typeface="Pretendard" pitchFamily="34" charset="-122"/>
+                <a:cs typeface="Pretendard" pitchFamily="34" charset="-120"/>
+              </a:rPr>
+              <a:t>편의 인프라</a:t>
+            </a:r>
+            <a:endParaRPr lang="en-US" sz="1400" dirty="0"/>
+          </a:p>
+        </p:txBody>
+      </p:sp>
+      <p:sp>
+        <p:nvSpPr>
+          <p:cNvPr id="23" name="Text 20"/>
+          <p:cNvSpPr/>
+          <p:nvPr/>
+        </p:nvSpPr>
+        <p:spPr>
+          <a:xfrm>
+            <a:off x="8170475" y="3995928"/>
+            <a:ext cx="3454292" cy="438912"/>
+          </a:xfrm>
+          <a:prstGeom prst="rect">
+            <a:avLst/>
+          </a:prstGeom>
+          <a:noFill/>
+          <a:ln/>
+        </p:spPr>
+        <p:txBody>
+          <a:bodyPr wrap="square" lIns="0" tIns="0" rIns="0" bIns="0" rtlCol="0" anchor="ctr"/>
+          <a:lstStyle/>
+          <a:p>
+            <a:pPr indent="0" marL="0">
+              <a:lnSpc>
+                <a:spcPct val="120000"/>
+              </a:lnSpc>
+              <a:buNone/>
+            </a:pPr>
+            <a:r>
+              <a:rPr lang="en-US" sz="1400" b="1" dirty="0">
+                <a:solidFill>
+                  <a:srgbClr val="0F172A"/>
+                </a:solidFill>
+                <a:latin typeface="Pretendard" pitchFamily="34" charset="0"/>
+                <a:ea typeface="Pretendard" pitchFamily="34" charset="-122"/>
+                <a:cs typeface="Pretendard" pitchFamily="34" charset="-120"/>
+              </a:rPr>
+              <a:t>반경 300m 내 주요 임차 업종, 은행, 대형 베이커리 밀집</a:t>
+            </a:r>
+            <a:endParaRPr lang="en-US" sz="1400" dirty="0"/>
+          </a:p>
+        </p:txBody>
+      </p:sp>
+      <p:sp>
+        <p:nvSpPr>
+          <p:cNvPr id="24" name="Text 21"/>
           <p:cNvSpPr/>
           <p:nvPr/>
         </p:nvSpPr>
@@ -4337,7 +4911,7 @@
       </p:sp>
       <p:sp>
         <p:nvSpPr>
-          <p:cNvPr id="9" name="Shape 6"/>
+          <p:cNvPr id="25" name="Shape 22"/>
           <p:cNvSpPr/>
           <p:nvPr/>
         </p:nvSpPr>
@@ -4357,45 +4931,6 @@
             <a:prstDash val="solid"/>
           </a:ln>
         </p:spPr>
-      </p:sp>
-      <p:sp>
-        <p:nvSpPr>
-          <p:cNvPr id="10" name="Text 7"/>
-          <p:cNvSpPr/>
-          <p:nvPr/>
-        </p:nvSpPr>
-        <p:spPr>
-          <a:xfrm>
-            <a:off x="566928" y="1481328"/>
-            <a:ext cx="11057839" cy="9692640"/>
-          </a:xfrm>
-          <a:prstGeom prst="rect">
-            <a:avLst/>
-          </a:prstGeom>
-          <a:noFill/>
-          <a:ln/>
-        </p:spPr>
-        <p:txBody>
-          <a:bodyPr wrap="square" lIns="0" tIns="0" rIns="0" bIns="0" rtlCol="0" anchor="t"/>
-          <a:lstStyle/>
-          <a:p>
-            <a:pPr indent="0" marL="0">
-              <a:buNone/>
-            </a:pPr>
-            <a:r>
-              <a:rPr lang="en-US" sz="1000" dirty="0">
-                <a:solidFill>
-                  <a:srgbClr val="0F172A"/>
-                </a:solidFill>
-                <a:latin typeface="Pretendard" pitchFamily="34" charset="0"/>
-                <a:ea typeface="Pretendard" pitchFamily="34" charset="-122"/>
-                <a:cs typeface="Pretendard" pitchFamily="34" charset="-120"/>
-              </a:rPr>
-              <a:t>{"ok":true,"mocked":true,"extractedFields":{"area_signal":"역삼","asset_type":"오피스빌딩","price_band":"300억","size_signal":"3000평(약 9917.4㎡)"},"extractedFacts":{"region":"역삼","exactAddressCandidate":"역삼동 742-1","assetType":"오피스빌딩","priceText":"300억","sizeText":"3000평(약 9917.4㎡)","currentUse":"오피스","currentUseSignal":"근린생활시설","leaseSignal":"임대중","vacancySignal":"공실없음","tenantNames":["쿠팡","네이버"],"unitRentTexts":["301호: 1500만"],"sellerMotivationText":"자산 효율화","brokerNotes":["초역세권 매물"]},"detectedSensitiveFields":["exact_address","tenant_name"],"ambiguousFields":[],"warnings":[],"areaSignal":"역삼","assetType":"오피스빌딩","priceBand":"300억","sizeSignal":"3000평(약 9917.4㎡)","dealType":"매각","buildingName":"역삼 센트럴타워","exactAddress":"역삼동 742-1","totalFloorArea":9917.3,"buildYear":2015,"currentUseSignal":"근린생활시설","vacancySignal":"공실 없음","fitSummary":"초역세권 근생 빌딩으로 시행/사옥 매입에 최적화","cautionSummary":"주요 임차 업종 만기 조율 필요","hiddenFields":["exact_address","seller_motivation"],"confidence":{"areaSignal":"confirmed","assetType":"confirmed","priceBand":"ai_hypothesis","fitSummary":"ai_hypothesis"},"missingData":["sizeSignal"],"boundaryNote":"본 자료는 실거래 통계 기반 참고치입니다.","buyerType":"법인 사옥형","budgetRange":{"min":50,"max":80,"display":"50억~80억"},"preferredRegions":["강남","성수"],"assetTypes":["꼬마빌딩","사옥용"],"purchasePurpose":"사옥용 매입","mustHave":["초역세권","주차"],"niceToHave":["테라스","루프탑"],"riskTolerance":"medium","financingNote":"자본금 50% 준비","missingQuestions":["구체적인 입주 시기가 언제인가요?","선호하는 수익률이 있나요?"],"privacyNotes":["연락처 비공개"],"fitReasons":["매수자 예산(50-80억)에 부합하는 매물입니다.","요청하신 성수/강남 권역에 해당합니다."],"cautionReasons":["요청한 용도와 달리 명도 협의가 다소 필요합니다."],"recommendedNextAction":"현장 답사 제안","kakaoMessage":"안녕하세요! 요청하신 조건에 부합하는 추천 매물이 있어 안내해 드립니다. 확인해보시고 피드백 부탁드립니다.","title":"강남 역삼역 초역세권 오피스 사옥용 빌딩 매각","shortSummary":"역삼역 도보 5분 거리의 준신축급 대형 오피스빌딩입니다.","dealPoints":["초역세권","사옥 최적"],"cautionPoints":["명도 조율 필요"],"hiddenInfoNotice":["보증금 및 지번은 인가 후 확인 가능"],"gateMessage":"G1 등급 등록이 필요합니다.","kakaoText":"강남 역삼역 오피스 빌딩 매각 안내입니다.","exactUnitCandidate":"101호","floor":"1층","areaSqmText":"150㎡","spaceType":"office","depositText":"5000만","monthlyRentText":"400만","maintenanceFeeText":"50만","availableFromText":"즉시입주","leaseTermMonthsText":"24","incentivesText":"렌트프리 2개월","restrictions":[],"landlordIdentity":"김성수","currentTenant":"스타트업","vacancyReason":"이전 확장","rentNegotiation":"협의 가능","region":"성수동","areaSqm":150,"deposit":5000,"monthlyRent":400,"maintenanceFee":50,"availableFrom":"즉시입주","leaseTermMonths":24,"incentives":{"rentFreeMonths":2,"interiorSupport":"일부 인테리어 지원","freeRentDetail":"렌트프리 2개월 지원"},"shortSummaryLease":"성수역 도보 5분 거리 1층 리테일 상가 매물입니다."}</a:t>
-            </a:r>
-            <a:endParaRPr lang="en-US" sz="1000" dirty="0"/>
-          </a:p>
-        </p:txBody>
       </p:sp>
     </p:spTree>
   </p:cSld>
@@ -7226,7 +7761,7 @@
         <p:spPr>
           <a:xfrm>
             <a:off x="566928" y="384048"/>
-            <a:ext cx="45720" cy="566928"/>
+            <a:ext cx="45720" cy="786384"/>
           </a:xfrm>
           <a:prstGeom prst="rect">
             <a:avLst/>
@@ -7317,13 +7852,688 @@
       </p:sp>
       <p:sp>
         <p:nvSpPr>
-          <p:cNvPr id="5" name="Shape 3"/>
-          <p:cNvSpPr/>
-          <p:nvPr/>
-        </p:nvSpPr>
-        <p:spPr>
-          <a:xfrm>
-            <a:off x="566928" y="4983480"/>
+          <p:cNvPr id="5" name="Text 3"/>
+          <p:cNvSpPr/>
+          <p:nvPr/>
+        </p:nvSpPr>
+        <p:spPr>
+          <a:xfrm>
+            <a:off x="749808" y="950976"/>
+            <a:ext cx="10874959" cy="219456"/>
+          </a:xfrm>
+          <a:prstGeom prst="rect">
+            <a:avLst/>
+          </a:prstGeom>
+          <a:noFill/>
+          <a:ln/>
+        </p:spPr>
+        <p:txBody>
+          <a:bodyPr wrap="square" lIns="0" tIns="0" rIns="0" bIns="0" rtlCol="0" anchor="ctr"/>
+          <a:lstStyle/>
+          <a:p>
+            <a:pPr indent="0" marL="0">
+              <a:buNone/>
+            </a:pPr>
+            <a:r>
+              <a:rPr lang="en-US" sz="1050" dirty="0">
+                <a:solidFill>
+                  <a:srgbClr val="64748B"/>
+                </a:solidFill>
+                <a:latin typeface="Pretendard" pitchFamily="34" charset="0"/>
+                <a:ea typeface="Pretendard" pitchFamily="34" charset="-122"/>
+                <a:cs typeface="Pretendard" pitchFamily="34" charset="-120"/>
+              </a:rPr>
+              <a:t>3대 핵심 투자 포인트 (Investment Highlights)</a:t>
+            </a:r>
+            <a:endParaRPr lang="en-US" sz="1050" dirty="0"/>
+          </a:p>
+        </p:txBody>
+      </p:sp>
+      <p:sp>
+        <p:nvSpPr>
+          <p:cNvPr id="6" name="Shape 4"/>
+          <p:cNvSpPr/>
+          <p:nvPr/>
+        </p:nvSpPr>
+        <p:spPr>
+          <a:xfrm>
+            <a:off x="566928" y="1481328"/>
+            <a:ext cx="3472586" cy="3474720"/>
+          </a:xfrm>
+          <a:prstGeom prst="roundRect">
+            <a:avLst>
+              <a:gd name="adj" fmla="val 2107"/>
+            </a:avLst>
+          </a:prstGeom>
+          <a:solidFill>
+            <a:srgbClr val="F8FAFC"/>
+          </a:solidFill>
+          <a:ln w="10160">
+            <a:solidFill>
+              <a:srgbClr val="CBD5E1"/>
+            </a:solidFill>
+            <a:prstDash val="solid"/>
+          </a:ln>
+        </p:spPr>
+      </p:sp>
+      <p:sp>
+        <p:nvSpPr>
+          <p:cNvPr id="7" name="Shape 5"/>
+          <p:cNvSpPr/>
+          <p:nvPr/>
+        </p:nvSpPr>
+        <p:spPr>
+          <a:xfrm>
+            <a:off x="566928" y="1481328"/>
+            <a:ext cx="3472586" cy="54864"/>
+          </a:xfrm>
+          <a:prstGeom prst="rect">
+            <a:avLst/>
+          </a:prstGeom>
+          <a:solidFill>
+            <a:srgbClr val="6B8E00"/>
+          </a:solidFill>
+          <a:ln/>
+        </p:spPr>
+      </p:sp>
+      <p:sp>
+        <p:nvSpPr>
+          <p:cNvPr id="8" name="Shape 6"/>
+          <p:cNvSpPr/>
+          <p:nvPr/>
+        </p:nvSpPr>
+        <p:spPr>
+          <a:xfrm>
+            <a:off x="795528" y="1755648"/>
+            <a:ext cx="475488" cy="292608"/>
+          </a:xfrm>
+          <a:prstGeom prst="roundRect">
+            <a:avLst>
+              <a:gd name="adj" fmla="val 12500"/>
+            </a:avLst>
+          </a:prstGeom>
+          <a:solidFill>
+            <a:srgbClr val="A3D900"/>
+          </a:solidFill>
+          <a:ln/>
+        </p:spPr>
+      </p:sp>
+      <p:sp>
+        <p:nvSpPr>
+          <p:cNvPr id="9" name="Text 7"/>
+          <p:cNvSpPr/>
+          <p:nvPr/>
+        </p:nvSpPr>
+        <p:spPr>
+          <a:xfrm>
+            <a:off x="795528" y="1755648"/>
+            <a:ext cx="475488" cy="292608"/>
+          </a:xfrm>
+          <a:prstGeom prst="rect">
+            <a:avLst/>
+          </a:prstGeom>
+          <a:noFill/>
+          <a:ln/>
+        </p:spPr>
+        <p:txBody>
+          <a:bodyPr wrap="square" lIns="0" tIns="0" rIns="0" bIns="0" rtlCol="0" anchor="ctr"/>
+          <a:lstStyle/>
+          <a:p>
+            <a:pPr algn="ctr" indent="0" marL="0">
+              <a:buNone/>
+            </a:pPr>
+            <a:r>
+              <a:rPr lang="en-US" sz="1100" b="1" dirty="0">
+                <a:solidFill>
+                  <a:srgbClr val="4F6A00"/>
+                </a:solidFill>
+                <a:latin typeface="Arial" pitchFamily="34" charset="0"/>
+                <a:ea typeface="Arial" pitchFamily="34" charset="-122"/>
+                <a:cs typeface="Arial" pitchFamily="34" charset="-120"/>
+              </a:rPr>
+              <a:t>01</a:t>
+            </a:r>
+            <a:endParaRPr lang="en-US" sz="1100" dirty="0"/>
+          </a:p>
+        </p:txBody>
+      </p:sp>
+      <p:sp>
+        <p:nvSpPr>
+          <p:cNvPr id="10" name="Text 8"/>
+          <p:cNvSpPr/>
+          <p:nvPr/>
+        </p:nvSpPr>
+        <p:spPr>
+          <a:xfrm>
+            <a:off x="795528" y="2194560"/>
+            <a:ext cx="3015386" cy="365760"/>
+          </a:xfrm>
+          <a:prstGeom prst="rect">
+            <a:avLst/>
+          </a:prstGeom>
+          <a:noFill/>
+          <a:ln/>
+        </p:spPr>
+        <p:txBody>
+          <a:bodyPr wrap="square" lIns="0" tIns="0" rIns="0" bIns="0" rtlCol="0" anchor="t"/>
+          <a:lstStyle/>
+          <a:p>
+            <a:pPr indent="0" marL="0">
+              <a:buNone/>
+            </a:pPr>
+            <a:r>
+              <a:rPr lang="en-US" sz="1500" b="1" dirty="0">
+                <a:solidFill>
+                  <a:srgbClr val="0F172A"/>
+                </a:solidFill>
+                <a:latin typeface="Pretendard" pitchFamily="34" charset="0"/>
+                <a:ea typeface="Pretendard" pitchFamily="34" charset="-122"/>
+                <a:cs typeface="Pretendard" pitchFamily="34" charset="-120"/>
+              </a:rPr>
+              <a:t>원금 안전판 확보</a:t>
+            </a:r>
+            <a:endParaRPr lang="en-US" sz="1500" dirty="0"/>
+          </a:p>
+        </p:txBody>
+      </p:sp>
+      <p:sp>
+        <p:nvSpPr>
+          <p:cNvPr id="11" name="Shape 9"/>
+          <p:cNvSpPr/>
+          <p:nvPr/>
+        </p:nvSpPr>
+        <p:spPr>
+          <a:xfrm>
+            <a:off x="795528" y="2624328"/>
+            <a:ext cx="3015386" cy="0"/>
+          </a:xfrm>
+          <a:prstGeom prst="line">
+            <a:avLst/>
+          </a:prstGeom>
+          <a:noFill/>
+          <a:ln w="6350">
+            <a:solidFill>
+              <a:srgbClr val="CBD5E1"/>
+            </a:solidFill>
+            <a:prstDash val="solid"/>
+          </a:ln>
+        </p:spPr>
+      </p:sp>
+      <p:sp>
+        <p:nvSpPr>
+          <p:cNvPr id="12" name="Text 10"/>
+          <p:cNvSpPr/>
+          <p:nvPr/>
+        </p:nvSpPr>
+        <p:spPr>
+          <a:xfrm>
+            <a:off x="795528" y="2779776"/>
+            <a:ext cx="3015386" cy="1965960"/>
+          </a:xfrm>
+          <a:prstGeom prst="rect">
+            <a:avLst/>
+          </a:prstGeom>
+          <a:noFill/>
+          <a:ln/>
+        </p:spPr>
+        <p:txBody>
+          <a:bodyPr wrap="square" lIns="0" tIns="0" rIns="0" bIns="0" rtlCol="0" anchor="t"/>
+          <a:lstStyle/>
+          <a:p>
+            <a:pPr indent="0" marL="0">
+              <a:lnSpc>
+                <a:spcPct val="130000"/>
+              </a:lnSpc>
+              <a:buNone/>
+            </a:pPr>
+            <a:r>
+              <a:rPr lang="en-US" sz="1200" dirty="0">
+                <a:solidFill>
+                  <a:srgbClr val="0F172A"/>
+                </a:solidFill>
+                <a:latin typeface="Pretendard" pitchFamily="34" charset="0"/>
+                <a:ea typeface="Pretendard" pitchFamily="34" charset="-122"/>
+                <a:cs typeface="Pretendard" pitchFamily="34" charset="-120"/>
+              </a:rPr>
+              <a:t>강남권역의 핵심 입지로, 우량한 대지 지분 가치가 하방 경직성을 강력히 지지합니다.</a:t>
+            </a:r>
+            <a:endParaRPr lang="en-US" sz="1200" dirty="0"/>
+          </a:p>
+        </p:txBody>
+      </p:sp>
+      <p:sp>
+        <p:nvSpPr>
+          <p:cNvPr id="13" name="Shape 11"/>
+          <p:cNvSpPr/>
+          <p:nvPr/>
+        </p:nvSpPr>
+        <p:spPr>
+          <a:xfrm>
+            <a:off x="4359554" y="1481328"/>
+            <a:ext cx="3472586" cy="3474720"/>
+          </a:xfrm>
+          <a:prstGeom prst="roundRect">
+            <a:avLst>
+              <a:gd name="adj" fmla="val 2107"/>
+            </a:avLst>
+          </a:prstGeom>
+          <a:solidFill>
+            <a:srgbClr val="F8FAFC"/>
+          </a:solidFill>
+          <a:ln w="10160">
+            <a:solidFill>
+              <a:srgbClr val="CBD5E1"/>
+            </a:solidFill>
+            <a:prstDash val="solid"/>
+          </a:ln>
+        </p:spPr>
+      </p:sp>
+      <p:sp>
+        <p:nvSpPr>
+          <p:cNvPr id="14" name="Shape 12"/>
+          <p:cNvSpPr/>
+          <p:nvPr/>
+        </p:nvSpPr>
+        <p:spPr>
+          <a:xfrm>
+            <a:off x="4359554" y="1481328"/>
+            <a:ext cx="3472586" cy="54864"/>
+          </a:xfrm>
+          <a:prstGeom prst="rect">
+            <a:avLst/>
+          </a:prstGeom>
+          <a:solidFill>
+            <a:srgbClr val="6B8E00"/>
+          </a:solidFill>
+          <a:ln/>
+        </p:spPr>
+      </p:sp>
+      <p:sp>
+        <p:nvSpPr>
+          <p:cNvPr id="15" name="Shape 13"/>
+          <p:cNvSpPr/>
+          <p:nvPr/>
+        </p:nvSpPr>
+        <p:spPr>
+          <a:xfrm>
+            <a:off x="4588154" y="1755648"/>
+            <a:ext cx="475488" cy="292608"/>
+          </a:xfrm>
+          <a:prstGeom prst="roundRect">
+            <a:avLst>
+              <a:gd name="adj" fmla="val 12500"/>
+            </a:avLst>
+          </a:prstGeom>
+          <a:solidFill>
+            <a:srgbClr val="A3D900"/>
+          </a:solidFill>
+          <a:ln/>
+        </p:spPr>
+      </p:sp>
+      <p:sp>
+        <p:nvSpPr>
+          <p:cNvPr id="16" name="Text 14"/>
+          <p:cNvSpPr/>
+          <p:nvPr/>
+        </p:nvSpPr>
+        <p:spPr>
+          <a:xfrm>
+            <a:off x="4588154" y="1755648"/>
+            <a:ext cx="475488" cy="292608"/>
+          </a:xfrm>
+          <a:prstGeom prst="rect">
+            <a:avLst/>
+          </a:prstGeom>
+          <a:noFill/>
+          <a:ln/>
+        </p:spPr>
+        <p:txBody>
+          <a:bodyPr wrap="square" lIns="0" tIns="0" rIns="0" bIns="0" rtlCol="0" anchor="ctr"/>
+          <a:lstStyle/>
+          <a:p>
+            <a:pPr algn="ctr" indent="0" marL="0">
+              <a:buNone/>
+            </a:pPr>
+            <a:r>
+              <a:rPr lang="en-US" sz="1100" b="1" dirty="0">
+                <a:solidFill>
+                  <a:srgbClr val="4F6A00"/>
+                </a:solidFill>
+                <a:latin typeface="Arial" pitchFamily="34" charset="0"/>
+                <a:ea typeface="Arial" pitchFamily="34" charset="-122"/>
+                <a:cs typeface="Arial" pitchFamily="34" charset="-120"/>
+              </a:rPr>
+              <a:t>02</a:t>
+            </a:r>
+            <a:endParaRPr lang="en-US" sz="1100" dirty="0"/>
+          </a:p>
+        </p:txBody>
+      </p:sp>
+      <p:sp>
+        <p:nvSpPr>
+          <p:cNvPr id="17" name="Text 15"/>
+          <p:cNvSpPr/>
+          <p:nvPr/>
+        </p:nvSpPr>
+        <p:spPr>
+          <a:xfrm>
+            <a:off x="4588154" y="2194560"/>
+            <a:ext cx="3015386" cy="365760"/>
+          </a:xfrm>
+          <a:prstGeom prst="rect">
+            <a:avLst/>
+          </a:prstGeom>
+          <a:noFill/>
+          <a:ln/>
+        </p:spPr>
+        <p:txBody>
+          <a:bodyPr wrap="square" lIns="0" tIns="0" rIns="0" bIns="0" rtlCol="0" anchor="t"/>
+          <a:lstStyle/>
+          <a:p>
+            <a:pPr indent="0" marL="0">
+              <a:buNone/>
+            </a:pPr>
+            <a:r>
+              <a:rPr lang="en-US" sz="1500" b="1" dirty="0">
+                <a:solidFill>
+                  <a:srgbClr val="0F172A"/>
+                </a:solidFill>
+                <a:latin typeface="Pretendard" pitchFamily="34" charset="0"/>
+                <a:ea typeface="Pretendard" pitchFamily="34" charset="-122"/>
+                <a:cs typeface="Pretendard" pitchFamily="34" charset="-120"/>
+              </a:rPr>
+              <a:t>확실한 월 현금흐름</a:t>
+            </a:r>
+            <a:endParaRPr lang="en-US" sz="1500" dirty="0"/>
+          </a:p>
+        </p:txBody>
+      </p:sp>
+      <p:sp>
+        <p:nvSpPr>
+          <p:cNvPr id="18" name="Shape 16"/>
+          <p:cNvSpPr/>
+          <p:nvPr/>
+        </p:nvSpPr>
+        <p:spPr>
+          <a:xfrm>
+            <a:off x="4588154" y="2624328"/>
+            <a:ext cx="3015386" cy="0"/>
+          </a:xfrm>
+          <a:prstGeom prst="line">
+            <a:avLst/>
+          </a:prstGeom>
+          <a:noFill/>
+          <a:ln w="6350">
+            <a:solidFill>
+              <a:srgbClr val="CBD5E1"/>
+            </a:solidFill>
+            <a:prstDash val="solid"/>
+          </a:ln>
+        </p:spPr>
+      </p:sp>
+      <p:sp>
+        <p:nvSpPr>
+          <p:cNvPr id="19" name="Text 17"/>
+          <p:cNvSpPr/>
+          <p:nvPr/>
+        </p:nvSpPr>
+        <p:spPr>
+          <a:xfrm>
+            <a:off x="4588154" y="2779776"/>
+            <a:ext cx="3015386" cy="1965960"/>
+          </a:xfrm>
+          <a:prstGeom prst="rect">
+            <a:avLst/>
+          </a:prstGeom>
+          <a:noFill/>
+          <a:ln/>
+        </p:spPr>
+        <p:txBody>
+          <a:bodyPr wrap="square" lIns="0" tIns="0" rIns="0" bIns="0" rtlCol="0" anchor="t"/>
+          <a:lstStyle/>
+          <a:p>
+            <a:pPr indent="0" marL="0">
+              <a:lnSpc>
+                <a:spcPct val="130000"/>
+              </a:lnSpc>
+              <a:buNone/>
+            </a:pPr>
+            <a:r>
+              <a:rPr lang="en-US" sz="1200" dirty="0">
+                <a:solidFill>
+                  <a:srgbClr val="0F172A"/>
+                </a:solidFill>
+                <a:latin typeface="Pretendard" pitchFamily="34" charset="0"/>
+                <a:ea typeface="Pretendard" pitchFamily="34" charset="-122"/>
+                <a:cs typeface="Pretendard" pitchFamily="34" charset="-120"/>
+              </a:rPr>
+              <a:t>우량 테넌트 만실 운영 및 장기 계약 구조를 통해 매월 안정적인 순수익 창출이 검토 여지가 있으나, 관련 법규·인허가·시설 요건의 현장 확인이 필요합니다..</a:t>
+            </a:r>
+            <a:endParaRPr lang="en-US" sz="1200" dirty="0"/>
+          </a:p>
+        </p:txBody>
+      </p:sp>
+      <p:sp>
+        <p:nvSpPr>
+          <p:cNvPr id="20" name="Shape 18"/>
+          <p:cNvSpPr/>
+          <p:nvPr/>
+        </p:nvSpPr>
+        <p:spPr>
+          <a:xfrm>
+            <a:off x="8152181" y="1481328"/>
+            <a:ext cx="3472586" cy="3474720"/>
+          </a:xfrm>
+          <a:prstGeom prst="roundRect">
+            <a:avLst>
+              <a:gd name="adj" fmla="val 2107"/>
+            </a:avLst>
+          </a:prstGeom>
+          <a:solidFill>
+            <a:srgbClr val="F8FAFC"/>
+          </a:solidFill>
+          <a:ln w="10160">
+            <a:solidFill>
+              <a:srgbClr val="CBD5E1"/>
+            </a:solidFill>
+            <a:prstDash val="solid"/>
+          </a:ln>
+        </p:spPr>
+      </p:sp>
+      <p:sp>
+        <p:nvSpPr>
+          <p:cNvPr id="21" name="Shape 19"/>
+          <p:cNvSpPr/>
+          <p:nvPr/>
+        </p:nvSpPr>
+        <p:spPr>
+          <a:xfrm>
+            <a:off x="8152181" y="1481328"/>
+            <a:ext cx="3472586" cy="54864"/>
+          </a:xfrm>
+          <a:prstGeom prst="rect">
+            <a:avLst/>
+          </a:prstGeom>
+          <a:solidFill>
+            <a:srgbClr val="6B8E00"/>
+          </a:solidFill>
+          <a:ln/>
+        </p:spPr>
+      </p:sp>
+      <p:sp>
+        <p:nvSpPr>
+          <p:cNvPr id="22" name="Shape 20"/>
+          <p:cNvSpPr/>
+          <p:nvPr/>
+        </p:nvSpPr>
+        <p:spPr>
+          <a:xfrm>
+            <a:off x="8380781" y="1755648"/>
+            <a:ext cx="475488" cy="292608"/>
+          </a:xfrm>
+          <a:prstGeom prst="roundRect">
+            <a:avLst>
+              <a:gd name="adj" fmla="val 12500"/>
+            </a:avLst>
+          </a:prstGeom>
+          <a:solidFill>
+            <a:srgbClr val="A3D900"/>
+          </a:solidFill>
+          <a:ln/>
+        </p:spPr>
+      </p:sp>
+      <p:sp>
+        <p:nvSpPr>
+          <p:cNvPr id="23" name="Text 21"/>
+          <p:cNvSpPr/>
+          <p:nvPr/>
+        </p:nvSpPr>
+        <p:spPr>
+          <a:xfrm>
+            <a:off x="8380781" y="1755648"/>
+            <a:ext cx="475488" cy="292608"/>
+          </a:xfrm>
+          <a:prstGeom prst="rect">
+            <a:avLst/>
+          </a:prstGeom>
+          <a:noFill/>
+          <a:ln/>
+        </p:spPr>
+        <p:txBody>
+          <a:bodyPr wrap="square" lIns="0" tIns="0" rIns="0" bIns="0" rtlCol="0" anchor="ctr"/>
+          <a:lstStyle/>
+          <a:p>
+            <a:pPr algn="ctr" indent="0" marL="0">
+              <a:buNone/>
+            </a:pPr>
+            <a:r>
+              <a:rPr lang="en-US" sz="1100" b="1" dirty="0">
+                <a:solidFill>
+                  <a:srgbClr val="4F6A00"/>
+                </a:solidFill>
+                <a:latin typeface="Arial" pitchFamily="34" charset="0"/>
+                <a:ea typeface="Arial" pitchFamily="34" charset="-122"/>
+                <a:cs typeface="Arial" pitchFamily="34" charset="-120"/>
+              </a:rPr>
+              <a:t>03</a:t>
+            </a:r>
+            <a:endParaRPr lang="en-US" sz="1100" dirty="0"/>
+          </a:p>
+        </p:txBody>
+      </p:sp>
+      <p:sp>
+        <p:nvSpPr>
+          <p:cNvPr id="24" name="Text 22"/>
+          <p:cNvSpPr/>
+          <p:nvPr/>
+        </p:nvSpPr>
+        <p:spPr>
+          <a:xfrm>
+            <a:off x="8380781" y="2194560"/>
+            <a:ext cx="3015386" cy="365760"/>
+          </a:xfrm>
+          <a:prstGeom prst="rect">
+            <a:avLst/>
+          </a:prstGeom>
+          <a:noFill/>
+          <a:ln/>
+        </p:spPr>
+        <p:txBody>
+          <a:bodyPr wrap="square" lIns="0" tIns="0" rIns="0" bIns="0" rtlCol="0" anchor="t"/>
+          <a:lstStyle/>
+          <a:p>
+            <a:pPr indent="0" marL="0">
+              <a:buNone/>
+            </a:pPr>
+            <a:r>
+              <a:rPr lang="en-US" sz="1500" b="1" dirty="0">
+                <a:solidFill>
+                  <a:srgbClr val="0F172A"/>
+                </a:solidFill>
+                <a:latin typeface="Pretendard" pitchFamily="34" charset="0"/>
+                <a:ea typeface="Pretendard" pitchFamily="34" charset="-122"/>
+                <a:cs typeface="Pretendard" pitchFamily="34" charset="-120"/>
+              </a:rPr>
+              <a:t>가치 상승 및 출구 전략</a:t>
+            </a:r>
+            <a:endParaRPr lang="en-US" sz="1500" dirty="0"/>
+          </a:p>
+        </p:txBody>
+      </p:sp>
+      <p:sp>
+        <p:nvSpPr>
+          <p:cNvPr id="25" name="Shape 23"/>
+          <p:cNvSpPr/>
+          <p:nvPr/>
+        </p:nvSpPr>
+        <p:spPr>
+          <a:xfrm>
+            <a:off x="8380781" y="2624328"/>
+            <a:ext cx="3015386" cy="0"/>
+          </a:xfrm>
+          <a:prstGeom prst="line">
+            <a:avLst/>
+          </a:prstGeom>
+          <a:noFill/>
+          <a:ln w="6350">
+            <a:solidFill>
+              <a:srgbClr val="CBD5E1"/>
+            </a:solidFill>
+            <a:prstDash val="solid"/>
+          </a:ln>
+        </p:spPr>
+      </p:sp>
+      <p:sp>
+        <p:nvSpPr>
+          <p:cNvPr id="26" name="Text 24"/>
+          <p:cNvSpPr/>
+          <p:nvPr/>
+        </p:nvSpPr>
+        <p:spPr>
+          <a:xfrm>
+            <a:off x="8380781" y="2779776"/>
+            <a:ext cx="3015386" cy="1965960"/>
+          </a:xfrm>
+          <a:prstGeom prst="rect">
+            <a:avLst/>
+          </a:prstGeom>
+          <a:noFill/>
+          <a:ln/>
+        </p:spPr>
+        <p:txBody>
+          <a:bodyPr wrap="square" lIns="0" tIns="0" rIns="0" bIns="0" rtlCol="0" anchor="t"/>
+          <a:lstStyle/>
+          <a:p>
+            <a:pPr indent="0" marL="0">
+              <a:lnSpc>
+                <a:spcPct val="130000"/>
+              </a:lnSpc>
+              <a:buNone/>
+            </a:pPr>
+            <a:r>
+              <a:rPr lang="en-US" sz="1200" dirty="0">
+                <a:solidFill>
+                  <a:srgbClr val="0F172A"/>
+                </a:solidFill>
+                <a:latin typeface="Pretendard" pitchFamily="34" charset="0"/>
+                <a:ea typeface="Pretendard" pitchFamily="34" charset="-122"/>
+                <a:cs typeface="Pretendard" pitchFamily="34" charset="-120"/>
+              </a:rPr>
+              <a:t>현행 공법 여력을 활용한 밸류업 기회와 더불어 향후 권역 지가 상승에 따른 시세차익 실현이 유력합니다.</a:t>
+            </a:r>
+            <a:endParaRPr lang="en-US" sz="1200" dirty="0"/>
+          </a:p>
+        </p:txBody>
+      </p:sp>
+      <p:sp>
+        <p:nvSpPr>
+          <p:cNvPr id="27" name="Shape 25"/>
+          <p:cNvSpPr/>
+          <p:nvPr/>
+        </p:nvSpPr>
+        <p:spPr>
+          <a:xfrm>
+            <a:off x="566928" y="5138928"/>
             <a:ext cx="11057839" cy="804672"/>
           </a:xfrm>
           <a:prstGeom prst="roundRect">
@@ -7344,13 +8554,13 @@
       </p:sp>
       <p:sp>
         <p:nvSpPr>
-          <p:cNvPr id="6" name="Text 4"/>
-          <p:cNvSpPr/>
-          <p:nvPr/>
-        </p:nvSpPr>
-        <p:spPr>
-          <a:xfrm>
-            <a:off x="749808" y="5093208"/>
+          <p:cNvPr id="28" name="Text 26"/>
+          <p:cNvSpPr/>
+          <p:nvPr/>
+        </p:nvSpPr>
+        <p:spPr>
+          <a:xfrm>
+            <a:off x="749808" y="5248656"/>
             <a:ext cx="1645920" cy="219456"/>
           </a:xfrm>
           <a:prstGeom prst="rect">
@@ -7383,13 +8593,13 @@
       </p:sp>
       <p:sp>
         <p:nvSpPr>
-          <p:cNvPr id="7" name="Text 5"/>
-          <p:cNvSpPr/>
-          <p:nvPr/>
-        </p:nvSpPr>
-        <p:spPr>
-          <a:xfrm>
-            <a:off x="2441448" y="5074920"/>
+          <p:cNvPr id="29" name="Text 27"/>
+          <p:cNvSpPr/>
+          <p:nvPr/>
+        </p:nvSpPr>
+        <p:spPr>
+          <a:xfrm>
+            <a:off x="2441448" y="5230368"/>
             <a:ext cx="9000439" cy="621792"/>
           </a:xfrm>
           <a:prstGeom prst="rect">
@@ -7417,7 +8627,7 @@
                 <a:ea typeface="Pretendard" pitchFamily="34" charset="-122"/>
                 <a:cs typeface="Pretendard" pitchFamily="34" charset="-120"/>
               </a:rPr>
-              <a:t>{"ok":true,"mocked":true,"extractedFields":{"area_signal":"역삼","asset_type":"오피스빌딩","price_band":"300억","size_signal":"3000평(약 9917.4㎡)"},"extractedFacts":{"region":"역삼","exactAddressCandidate":"역삼동 742-1","assetType":"오피스빌딩","priceText":"300억","sizeText":"3000평(약 9917.4㎡)","currentUse":"오피스","currentUseSignal":"근린생활시설","leaseSignal":"임대중","vacancySignal":"공실없음","tenantNames":["쿠팡","네이버"],"unitRentTexts":["301호: 1500만"],"sellerMotivationText":"자산 효율화","brokerNotes":["초역세권 매물"]},"detectedSensitiveFields":["exact_address","tenant_name"],"ambiguousFields":[],"warnings":[],"areaSignal":"역삼","assetType":"오피스빌딩","priceBand":"300억","sizeSignal":"3000평(약 9917.4㎡)","dealType":"매각","buildingName":"역삼 센트럴타워","exactAddress":"역삼동 742-1","totalFloorArea":9917.3,"buildYear":2015,"currentUseSignal":"근린생활시설","vacancySignal":"공실 없음","fitSummary":"초역세권 근생 빌딩으로 시행/사옥 매입에 최적화","cautionSummary":"주요 임차 업종 만기 조율 필요","hiddenFields":["exact_address","seller_motivation"],"confidence":{"areaSignal":"confirmed","assetType":"confirmed","priceBand":"ai_hypothesis","fitSummary":"ai_hypothesis"},"missingData":["sizeSignal"],"boundaryNote":"본 자료는 실거래 통계 기반 참고치입니다.","buyerType":"법인 사옥형","budgetRange":{"min":50,"max":80,"display":"50억~80억"},"preferredRegions":["강남","성수"],"assetTypes":["꼬마빌딩","사옥용"],"purchasePurpose":"사옥용 매입","mustHave":["초역세권","주차"],"niceToHave":["테라스","루프탑"],"riskTolerance":"medium","financingNote":"자본금 50% 준비","missingQuestions":["구체적인 입주 시기가 언제인가요?","선호하는 수익률이 있나요?"],"privacyNotes":["연락처 비공개"],"fitReasons":["매수자 예산(50-80억)에 부합하는 매물입니다.","요청하신 성수/강남 권역에 해당합니다."],"cautionReasons":["요청한 용도와 달리 명도 협의가 다소 필요합니다."],"recommendedNextAction":"현장 답사 제안","kakaoMessage":"안녕하세요! 요청하신 조건에 부합하는 추천 매물이 있어 안내해 드립니다. 확인해보시고 피드백 부탁드립니다.","title":"강남 역삼역 초역세권 오피스 사옥용 빌딩 매각","shortSummary":"역삼역 도보 5분 거리의 준신축급 대형 오피스빌딩입니다.","dealPoints":["초역세권","사옥 최적"],"cautionPoints":["명도 조율 필요"],"hiddenInfoNotice":["보증금 및 지번은 인가 후 확인 가능"],"gateMessage":"G1 등급 등록이 필요합니다.","kakaoText":"강남 역삼역 오피스 빌딩 매각 안내입니다.","exactUnitCandidate":"101호","floor":"1층","areaSqmText":"150㎡","spaceType":"office","depositText":"5000만","monthlyRentText":"400만","maintenanceFeeText":"50만","availableFromText":"즉시입주","leaseTermMonthsText":"24","incentivesText":"렌트프리 2개월","restrictions":[],"landlordIdentity":"김성수","currentTenant":"스타트업","vacancyReason":"이전 확장","rentNegotiation":"협의 가능","region":"성수동","areaSqm":150,"deposit":5000,"monthlyRent":400,"maintenanceFee":50,"availableFrom":"즉시입주","leaseTermMonths":24,"incentives":{"rentFreeMonths":2,"interiorSupport":"일부 인테리어 지원","freeRentDetail":"렌트프리 2개월 지원"},"shortSummaryLease":"성수역 도보 5분 거리 1층 리테일 상가 매물입니다."}</a:t>
+              <a:t>본 자산의 3대 핵심 투자 포인트와 예상 매수자 유형 분석입니다.</a:t>
             </a:r>
             <a:endParaRPr lang="en-US" sz="1000" dirty="0"/>
           </a:p>
@@ -7425,7 +8635,7 @@
       </p:sp>
       <p:sp>
         <p:nvSpPr>
-          <p:cNvPr id="8" name="Text 6"/>
+          <p:cNvPr id="30" name="Text 28"/>
           <p:cNvSpPr/>
           <p:nvPr/>
         </p:nvSpPr>
@@ -7464,7 +8674,7 @@
       </p:sp>
       <p:sp>
         <p:nvSpPr>
-          <p:cNvPr id="9" name="Shape 7"/>
+          <p:cNvPr id="31" name="Shape 29"/>
           <p:cNvSpPr/>
           <p:nvPr/>
         </p:nvSpPr>
@@ -7624,7 +8834,7 @@
         <p:spPr>
           <a:xfrm>
             <a:off x="566928" y="1572768"/>
-            <a:ext cx="11057839" cy="3200400"/>
+            <a:ext cx="3442106" cy="3200400"/>
           </a:xfrm>
           <a:prstGeom prst="rect">
             <a:avLst/>
@@ -7649,7 +8859,7 @@
         <p:spPr>
           <a:xfrm>
             <a:off x="566928" y="1572768"/>
-            <a:ext cx="11057839" cy="36576"/>
+            <a:ext cx="3442106" cy="36576"/>
           </a:xfrm>
           <a:prstGeom prst="rect">
             <a:avLst/>
@@ -7728,7 +8938,7 @@
         <p:spPr>
           <a:xfrm>
             <a:off x="786384" y="2304288"/>
-            <a:ext cx="10618927" cy="365760"/>
+            <a:ext cx="3003194" cy="365760"/>
           </a:xfrm>
           <a:prstGeom prst="rect">
             <a:avLst/>
@@ -7752,7 +8962,7 @@
                 <a:ea typeface="Pretendard" pitchFamily="34" charset="-122"/>
                 <a:cs typeface="Pretendard" pitchFamily="34" charset="-120"/>
               </a:rPr>
-              <a:t>{"ok"</a:t>
+              <a:t>초기 관심 표명 → 담당자 연락</a:t>
             </a:r>
             <a:endParaRPr lang="en-US" sz="1600" dirty="0"/>
           </a:p>
@@ -7767,7 +8977,7 @@
         <p:spPr>
           <a:xfrm>
             <a:off x="786384" y="2761488"/>
-            <a:ext cx="10618927" cy="1828800"/>
+            <a:ext cx="3003194" cy="1828800"/>
           </a:xfrm>
           <a:prstGeom prst="rect">
             <a:avLst/>
@@ -7782,8 +8992,165 @@
             <a:pPr indent="0" marL="0">
               <a:buNone/>
             </a:pPr>
-            <a:r>
-              <a:rPr lang="en-US" sz="1100" dirty="0">
+            <a:endParaRPr lang="en-US" sz="1100" dirty="0"/>
+          </a:p>
+        </p:txBody>
+      </p:sp>
+      <p:sp>
+        <p:nvSpPr>
+          <p:cNvPr id="11" name="Shape 9"/>
+          <p:cNvSpPr/>
+          <p:nvPr/>
+        </p:nvSpPr>
+        <p:spPr>
+          <a:xfrm>
+            <a:off x="4100474" y="3035808"/>
+            <a:ext cx="182880" cy="274320"/>
+          </a:xfrm>
+          <a:prstGeom prst="rightArrow">
+            <a:avLst/>
+          </a:prstGeom>
+          <a:solidFill>
+            <a:srgbClr val="CBD5E1"/>
+          </a:solidFill>
+          <a:ln w="6350">
+            <a:solidFill>
+              <a:srgbClr val="64748B"/>
+            </a:solidFill>
+            <a:prstDash val="solid"/>
+          </a:ln>
+        </p:spPr>
+      </p:sp>
+      <p:sp>
+        <p:nvSpPr>
+          <p:cNvPr id="12" name="Shape 10"/>
+          <p:cNvSpPr/>
+          <p:nvPr/>
+        </p:nvSpPr>
+        <p:spPr>
+          <a:xfrm>
+            <a:off x="4374794" y="1572768"/>
+            <a:ext cx="3442106" cy="3200400"/>
+          </a:xfrm>
+          <a:prstGeom prst="rect">
+            <a:avLst/>
+          </a:prstGeom>
+          <a:solidFill>
+            <a:srgbClr val="F8FAFC"/>
+          </a:solidFill>
+          <a:ln w="3810">
+            <a:solidFill>
+              <a:srgbClr val="CBD5E1"/>
+            </a:solidFill>
+            <a:prstDash val="solid"/>
+          </a:ln>
+        </p:spPr>
+      </p:sp>
+      <p:sp>
+        <p:nvSpPr>
+          <p:cNvPr id="13" name="Shape 11"/>
+          <p:cNvSpPr/>
+          <p:nvPr/>
+        </p:nvSpPr>
+        <p:spPr>
+          <a:xfrm>
+            <a:off x="4374794" y="1572768"/>
+            <a:ext cx="3442106" cy="36576"/>
+          </a:xfrm>
+          <a:prstGeom prst="rect">
+            <a:avLst/>
+          </a:prstGeom>
+          <a:solidFill>
+            <a:srgbClr val="6B8E00"/>
+          </a:solidFill>
+          <a:ln/>
+        </p:spPr>
+      </p:sp>
+      <p:sp>
+        <p:nvSpPr>
+          <p:cNvPr id="14" name="Shape 12"/>
+          <p:cNvSpPr/>
+          <p:nvPr/>
+        </p:nvSpPr>
+        <p:spPr>
+          <a:xfrm>
+            <a:off x="4594250" y="1792224"/>
+            <a:ext cx="384048" cy="384048"/>
+          </a:xfrm>
+          <a:prstGeom prst="ellipse">
+            <a:avLst/>
+          </a:prstGeom>
+          <a:solidFill>
+            <a:srgbClr val="6B8E00"/>
+          </a:solidFill>
+          <a:ln/>
+        </p:spPr>
+      </p:sp>
+      <p:sp>
+        <p:nvSpPr>
+          <p:cNvPr id="15" name="Text 13"/>
+          <p:cNvSpPr/>
+          <p:nvPr/>
+        </p:nvSpPr>
+        <p:spPr>
+          <a:xfrm>
+            <a:off x="4594250" y="1792224"/>
+            <a:ext cx="384048" cy="384048"/>
+          </a:xfrm>
+          <a:prstGeom prst="rect">
+            <a:avLst/>
+          </a:prstGeom>
+          <a:noFill/>
+          <a:ln/>
+        </p:spPr>
+        <p:txBody>
+          <a:bodyPr wrap="square" lIns="0" tIns="0" rIns="0" bIns="0" rtlCol="0" anchor="ctr"/>
+          <a:lstStyle/>
+          <a:p>
+            <a:pPr algn="ctr" indent="0" marL="0">
+              <a:buNone/>
+            </a:pPr>
+            <a:r>
+              <a:rPr lang="en-US" sz="1300" b="1" dirty="0">
+                <a:solidFill>
+                  <a:srgbClr val="FFFFFF"/>
+                </a:solidFill>
+                <a:latin typeface="Arial" pitchFamily="34" charset="0"/>
+                <a:ea typeface="Arial" pitchFamily="34" charset="-122"/>
+                <a:cs typeface="Arial" pitchFamily="34" charset="-120"/>
+              </a:rPr>
+              <a:t>STEP 2</a:t>
+            </a:r>
+            <a:endParaRPr lang="en-US" sz="1300" dirty="0"/>
+          </a:p>
+        </p:txBody>
+      </p:sp>
+      <p:sp>
+        <p:nvSpPr>
+          <p:cNvPr id="16" name="Text 14"/>
+          <p:cNvSpPr/>
+          <p:nvPr/>
+        </p:nvSpPr>
+        <p:spPr>
+          <a:xfrm>
+            <a:off x="4594250" y="2304288"/>
+            <a:ext cx="3003194" cy="365760"/>
+          </a:xfrm>
+          <a:prstGeom prst="rect">
+            <a:avLst/>
+          </a:prstGeom>
+          <a:noFill/>
+          <a:ln/>
+        </p:spPr>
+        <p:txBody>
+          <a:bodyPr wrap="square" rtlCol="0" anchor="ctr"/>
+          <a:lstStyle/>
+          <a:p>
+            <a:pPr indent="0" marL="0">
+              <a:buNone/>
+            </a:pPr>
+            <a:r>
+              <a:rPr lang="en-US" sz="1600" b="1" dirty="0">
                 <a:solidFill>
                   <a:srgbClr val="0F172A"/>
                 </a:solidFill>
@@ -7791,15 +9158,239 @@
                 <a:ea typeface="Pretendard" pitchFamily="34" charset="-122"/>
                 <a:cs typeface="Pretendard" pitchFamily="34" charset="-120"/>
               </a:rPr>
-              <a:t>true,"mocked":true,"extractedFields":{"area_signal":"역삼","asset_type":"오피스빌딩","price_band":"300억","size_signal":"3000평(약 9917.4㎡)"},"extractedFacts":{"region":"역삼","exactAddressCandidate":"역삼동 742-1","assetType":"오피스빌딩","priceText":"300억","sizeText":"3000평(약 9917.4㎡)","currentUse":"오피스","currentUseSignal":"근린생활시설","leaseSignal":"임대중","vacancySignal":"공실없음","tenantNames":["쿠팡","네이버"],"unitRentTexts":["301호: 1500만"],"sellerMotivationText":"자산 효율화","brokerNotes":["초역세권 매물"]},"detectedSensitiveFields":["exact_address","tenant_name"],"ambiguousFields":[],"warnings":[],"areaSignal":"역삼","assetType":"오피스빌딩","priceBand":"300억","sizeSignal":"3000평(약 9917.4㎡)","dealType":"매각","buildingName":"역삼 센트럴타워","exactAddress":"역삼동 742-1","totalFloorArea":9917.3,"buildYear":2015,"currentUseSignal":"근린생활시설","vacancySignal":"공실 없음","fitSummary":"초역세권 근생 빌딩으로 시행/사옥 매입에 최적화","cautionSummary":"주요 임차 업종 만기 조율 필요","hiddenFields":["exact_address","seller_motivation"],"confidence":{"areaSignal":"confirmed","assetType":"confirmed","priceBand":"ai_hypothesis","fitSummary":"ai_hypothesis"},"missingData":["sizeSignal"],"boundaryNote":"본 자료는 실거래 통계 기반 참고치입니다.","buyerType":"법인 사옥형","budgetRange":{"min":50,"max":80,"display":"50억~80억"},"preferredRegions":["강남","성수"],"assetTypes":["꼬마빌딩","사옥용"],"purchasePurpose":"사옥용 매입","mustHave":["초역세권","주차"],"niceToHave":["테라스","루프탑"],"riskTolerance":"medium","financingNote":"자본금 50% 준비","missingQuestions":["구체적인 입주 시기가 언제인가요?","선호하는 수익률이 있나요?"],"privacyNotes":["연락처 비공개"],"fitReasons":["매수자 예산(50-80억)에 부합하는 매물입니다.","요청하신 성수/강남 권역에 해당합니다."],"cautionReasons":["요청한 용도와 달리 명도 협의가 다소 필요합니다."],"recommendedNextAction":"현장 답사 제안","kakaoMessage":"안녕하세요! 요청하신 조건에 부합하는 추천 매물이 있어 안내해 드립니다. 확인해보시고 피드백 부탁드립니다.","title":"강남 역삼역 초역세권 오피스 사옥용 빌딩 매각","shortSummary":"역삼역 도보 5분 거리의 준신축급 대형 오피스빌딩입니다.","dealPoints":["초역세권","사옥 최적"],"cautionPoints":["명도 조율 필요"],"hiddenInfoNotice":["보증금 및 지번은 인가 후 확인 가능"],"gateMessage":"G1 등급 등록이 필요합니다.","kakaoText":"강남 역삼역 오피스 빌딩 매각 안내입니다.","exactUnitCandidate":"101호","floor":"1층","areaSqmText":"150㎡","spaceType":"office","depositText":"5000만","monthlyRentText":"400만","maintenanceFeeText":"50만","availableFromText":"즉시입주","leaseTermMonthsText":"24","incentivesText":"렌트프리 2개월","restrictions":[],"landlordIdentity":"김성수","currentTenant":"스타트업","vacancyReason":"이전 확장","rentNegotiation":"협의 가능","region":"성수동","areaSqm":150,"deposit":5000,"monthlyRent":400,"maintenanceFee":50,"availableFrom":"즉시입주","leaseTermMonths":24,"incentives":{"rentFreeMonths":2,"interiorSupport":"일부 인테리어 지원","freeRentDetail":"렌트프리 2개월 지원"},"shortSummaryLease":"성수역 도보 5분 거리 1층 리테일 상가 매물입니다."}</a:t>
-            </a:r>
+              <a:t>NDA 체결 → 임차인 정보 및 임대차계약서 제공</a:t>
+            </a:r>
+            <a:endParaRPr lang="en-US" sz="1600" dirty="0"/>
+          </a:p>
+        </p:txBody>
+      </p:sp>
+      <p:sp>
+        <p:nvSpPr>
+          <p:cNvPr id="17" name="Text 15"/>
+          <p:cNvSpPr/>
+          <p:nvPr/>
+        </p:nvSpPr>
+        <p:spPr>
+          <a:xfrm>
+            <a:off x="4594250" y="2761488"/>
+            <a:ext cx="3003194" cy="1828800"/>
+          </a:xfrm>
+          <a:prstGeom prst="rect">
+            <a:avLst/>
+          </a:prstGeom>
+          <a:noFill/>
+          <a:ln/>
+        </p:spPr>
+        <p:txBody>
+          <a:bodyPr wrap="square" rtlCol="0" anchor="t"/>
+          <a:lstStyle/>
+          <a:p>
+            <a:pPr indent="0" marL="0">
+              <a:buNone/>
+            </a:pPr>
             <a:endParaRPr lang="en-US" sz="1100" dirty="0"/>
           </a:p>
         </p:txBody>
       </p:sp>
       <p:sp>
         <p:nvSpPr>
-          <p:cNvPr id="11" name="Text 9"/>
+          <p:cNvPr id="18" name="Shape 16"/>
+          <p:cNvSpPr/>
+          <p:nvPr/>
+        </p:nvSpPr>
+        <p:spPr>
+          <a:xfrm>
+            <a:off x="7908341" y="3035808"/>
+            <a:ext cx="182880" cy="274320"/>
+          </a:xfrm>
+          <a:prstGeom prst="rightArrow">
+            <a:avLst/>
+          </a:prstGeom>
+          <a:solidFill>
+            <a:srgbClr val="CBD5E1"/>
+          </a:solidFill>
+          <a:ln w="6350">
+            <a:solidFill>
+              <a:srgbClr val="64748B"/>
+            </a:solidFill>
+            <a:prstDash val="solid"/>
+          </a:ln>
+        </p:spPr>
+      </p:sp>
+      <p:sp>
+        <p:nvSpPr>
+          <p:cNvPr id="19" name="Shape 17"/>
+          <p:cNvSpPr/>
+          <p:nvPr/>
+        </p:nvSpPr>
+        <p:spPr>
+          <a:xfrm>
+            <a:off x="8182661" y="1572768"/>
+            <a:ext cx="3442106" cy="3200400"/>
+          </a:xfrm>
+          <a:prstGeom prst="rect">
+            <a:avLst/>
+          </a:prstGeom>
+          <a:solidFill>
+            <a:srgbClr val="F8FAFC"/>
+          </a:solidFill>
+          <a:ln w="3810">
+            <a:solidFill>
+              <a:srgbClr val="CBD5E1"/>
+            </a:solidFill>
+            <a:prstDash val="solid"/>
+          </a:ln>
+        </p:spPr>
+      </p:sp>
+      <p:sp>
+        <p:nvSpPr>
+          <p:cNvPr id="20" name="Shape 18"/>
+          <p:cNvSpPr/>
+          <p:nvPr/>
+        </p:nvSpPr>
+        <p:spPr>
+          <a:xfrm>
+            <a:off x="8182661" y="1572768"/>
+            <a:ext cx="3442106" cy="36576"/>
+          </a:xfrm>
+          <a:prstGeom prst="rect">
+            <a:avLst/>
+          </a:prstGeom>
+          <a:solidFill>
+            <a:srgbClr val="6B8E00"/>
+          </a:solidFill>
+          <a:ln/>
+        </p:spPr>
+      </p:sp>
+      <p:sp>
+        <p:nvSpPr>
+          <p:cNvPr id="21" name="Shape 19"/>
+          <p:cNvSpPr/>
+          <p:nvPr/>
+        </p:nvSpPr>
+        <p:spPr>
+          <a:xfrm>
+            <a:off x="8402117" y="1792224"/>
+            <a:ext cx="384048" cy="384048"/>
+          </a:xfrm>
+          <a:prstGeom prst="ellipse">
+            <a:avLst/>
+          </a:prstGeom>
+          <a:solidFill>
+            <a:srgbClr val="6B8E00"/>
+          </a:solidFill>
+          <a:ln/>
+        </p:spPr>
+      </p:sp>
+      <p:sp>
+        <p:nvSpPr>
+          <p:cNvPr id="22" name="Text 20"/>
+          <p:cNvSpPr/>
+          <p:nvPr/>
+        </p:nvSpPr>
+        <p:spPr>
+          <a:xfrm>
+            <a:off x="8402117" y="1792224"/>
+            <a:ext cx="384048" cy="384048"/>
+          </a:xfrm>
+          <a:prstGeom prst="rect">
+            <a:avLst/>
+          </a:prstGeom>
+          <a:noFill/>
+          <a:ln/>
+        </p:spPr>
+        <p:txBody>
+          <a:bodyPr wrap="square" lIns="0" tIns="0" rIns="0" bIns="0" rtlCol="0" anchor="ctr"/>
+          <a:lstStyle/>
+          <a:p>
+            <a:pPr algn="ctr" indent="0" marL="0">
+              <a:buNone/>
+            </a:pPr>
+            <a:r>
+              <a:rPr lang="en-US" sz="1300" b="1" dirty="0">
+                <a:solidFill>
+                  <a:srgbClr val="FFFFFF"/>
+                </a:solidFill>
+                <a:latin typeface="Arial" pitchFamily="34" charset="0"/>
+                <a:ea typeface="Arial" pitchFamily="34" charset="-122"/>
+                <a:cs typeface="Arial" pitchFamily="34" charset="-120"/>
+              </a:rPr>
+              <a:t>STEP 3</a:t>
+            </a:r>
+            <a:endParaRPr lang="en-US" sz="1300" dirty="0"/>
+          </a:p>
+        </p:txBody>
+      </p:sp>
+      <p:sp>
+        <p:nvSpPr>
+          <p:cNvPr id="23" name="Text 21"/>
+          <p:cNvSpPr/>
+          <p:nvPr/>
+        </p:nvSpPr>
+        <p:spPr>
+          <a:xfrm>
+            <a:off x="8402117" y="2304288"/>
+            <a:ext cx="3003194" cy="365760"/>
+          </a:xfrm>
+          <a:prstGeom prst="rect">
+            <a:avLst/>
+          </a:prstGeom>
+          <a:noFill/>
+          <a:ln/>
+        </p:spPr>
+        <p:txBody>
+          <a:bodyPr wrap="square" rtlCol="0" anchor="ctr"/>
+          <a:lstStyle/>
+          <a:p>
+            <a:pPr indent="0" marL="0">
+              <a:buNone/>
+            </a:pPr>
+            <a:r>
+              <a:rPr lang="en-US" sz="1600" b="1" dirty="0">
+                <a:solidFill>
+                  <a:srgbClr val="0F172A"/>
+                </a:solidFill>
+                <a:latin typeface="Pretendard" pitchFamily="34" charset="0"/>
+                <a:ea typeface="Pretendard" pitchFamily="34" charset="-122"/>
+                <a:cs typeface="Pretendard" pitchFamily="34" charset="-120"/>
+              </a:rPr>
+              <a:t>현장 실사 일정 조율 → 건물 컨디션 및 설비 직접 확인</a:t>
+            </a:r>
+            <a:endParaRPr lang="en-US" sz="1600" dirty="0"/>
+          </a:p>
+        </p:txBody>
+      </p:sp>
+      <p:sp>
+        <p:nvSpPr>
+          <p:cNvPr id="24" name="Text 22"/>
+          <p:cNvSpPr/>
+          <p:nvPr/>
+        </p:nvSpPr>
+        <p:spPr>
+          <a:xfrm>
+            <a:off x="8402117" y="2761488"/>
+            <a:ext cx="3003194" cy="1828800"/>
+          </a:xfrm>
+          <a:prstGeom prst="rect">
+            <a:avLst/>
+          </a:prstGeom>
+          <a:noFill/>
+          <a:ln/>
+        </p:spPr>
+        <p:txBody>
+          <a:bodyPr wrap="square" rtlCol="0" anchor="t"/>
+          <a:lstStyle/>
+          <a:p>
+            <a:pPr indent="0" marL="0">
+              <a:buNone/>
+            </a:pPr>
+            <a:endParaRPr lang="en-US" sz="1100" dirty="0"/>
+          </a:p>
+        </p:txBody>
+      </p:sp>
+      <p:sp>
+        <p:nvSpPr>
+          <p:cNvPr id="25" name="Text 23"/>
           <p:cNvSpPr/>
           <p:nvPr/>
         </p:nvSpPr>
@@ -7838,7 +9429,7 @@
       </p:sp>
       <p:sp>
         <p:nvSpPr>
-          <p:cNvPr id="12" name="Shape 10"/>
+          <p:cNvPr id="26" name="Shape 24"/>
           <p:cNvSpPr/>
           <p:nvPr/>
         </p:nvSpPr>

</xml_diff>

<commit_message>
feat(D30): V3 고도화 구현 1차 — BL-1~BL-9, M-1~M-3, M-12~M-13, M-16~M-17, M-19
차단(BL):
- BL-1: 아키타입 16종 라벨·조건 정본 치환
- BL-2: R-OPR-04/R-TRD-04 경고 강제 섹션 삽입
- BL-3: L02 덱 편성 재배정 (R-INC-02→06 + 9종 타입)
- BL-6: Fail-Closed (LLM 실패→system_error→발행 차단)
- BL-7: 105초 확인사항 이관 + 필수 섹션 차단
- BL-8: NaN→[확인 필요] (무음 치환 금지)
- BL-9: 임차인 전량 마스킹 + 업종 보존

중대(M):
- M-1: 출처 계수 정본값 (broker_aug 0.80, expert 0.95, ledger 0.70)
- M-2: derived 최약 고리 승계 (getDerivedCoeff)
- M-3: ai_inferred 제거
- M-12: not_applicable 분모 제외 (운영형/사옥형/매매형)
- M-13: IncomeArchetype 4종→9종
- M-16: 금지어 확장 (CATALOG_RULES §7.3)
- M-17: SLIDE_ARCHETYPE_REGISTRY 개명
- M-19: Cap Rate 병기 + 캡레이트 직역 교정
</commit_message>
<xml_diff>
--- a/docs/test/stress/e2e-outputs/development_case12_yeoksam_dev_basic.pptx
+++ b/docs/test/stress/e2e-outputs/development_case12_yeoksam_dev_basic.pptx
@@ -15,9 +15,10 @@
     <p:sldId id="263" r:id="rId9"/>
     <p:sldId id="264" r:id="rId10"/>
     <p:sldId id="265" r:id="rId11"/>
+    <p:sldId id="266" r:id="rId12"/>
   </p:sldIdLst>
   <p:notesMasterIdLst>
-    <p:notesMasterId r:id="rId12"/>
+    <p:notesMasterId r:id="rId13"/>
   </p:notesMasterIdLst>
   <p:sldSz cx="12192000" cy="6858000"/>
   <p:notesSz cx="6858000" cy="12192000"/>
@@ -623,6 +624,94 @@
             <a:fld id="{F7021451-1387-4CA6-816F-3879F97B5CBC}" type="slidenum">
               <a:rPr lang="en-US"/>
               <a:t>10</a:t>
+            </a:fld>
+            <a:endParaRPr lang="en-US"/>
+          </a:p>
+        </p:txBody>
+      </p:sp>
+    </p:spTree>
+    <p:extLst>
+      <p:ext uri="{BB962C8B-B14F-4D97-AF65-F5344CB8AC3E}">
+        <p14:creationId xmlns:p14="http://schemas.microsoft.com/office/powerpoint/2010/main" val="1024086991"/>
+      </p:ext>
+    </p:extLst>
+  </p:cSld>
+  <p:clrMapOvr>
+    <a:masterClrMapping/>
+  </p:clrMapOvr>
+</p:notes>
+</file>
+
+<file path=ppt/notesSlides/notesSlide11.xml><?xml version="1.0" encoding="utf-8"?>
+<p:notes xmlns:a="http://schemas.openxmlformats.org/drawingml/2006/main" xmlns:r="http://schemas.openxmlformats.org/officeDocument/2006/relationships" xmlns:p="http://schemas.openxmlformats.org/presentationml/2006/main">
+  <p:cSld>
+    <p:spTree>
+      <p:nvGrpSpPr>
+        <p:cNvPr id="1" name=""/>
+        <p:cNvGrpSpPr/>
+        <p:nvPr/>
+      </p:nvGrpSpPr>
+      <p:grpSpPr>
+        <a:xfrm>
+          <a:off x="0" y="0"/>
+          <a:ext cx="0" cy="0"/>
+          <a:chOff x="0" y="0"/>
+          <a:chExt cx="0" cy="0"/>
+        </a:xfrm>
+      </p:grpSpPr>
+      <p:sp>
+        <p:nvSpPr>
+          <p:cNvPr id="2" name="Slide Image Placeholder 1"/>
+          <p:cNvSpPr>
+            <a:spLocks noGrp="1" noRot="1" noChangeAspect="1"/>
+          </p:cNvSpPr>
+          <p:nvPr>
+            <p:ph type="sldImg"/>
+          </p:nvPr>
+        </p:nvSpPr>
+        <p:spPr/>
+      </p:sp>
+      <p:sp>
+        <p:nvSpPr>
+          <p:cNvPr id="3" name="Notes Placeholder 2"/>
+          <p:cNvSpPr>
+            <a:spLocks noGrp="1"/>
+          </p:cNvSpPr>
+          <p:nvPr>
+            <p:ph type="body" idx="1"/>
+          </p:nvPr>
+        </p:nvSpPr>
+        <p:spPr/>
+        <p:txBody>
+          <a:bodyPr/>
+          <a:lstStyle/>
+          <a:p>
+            <a:r>
+              <a:rPr lang="en-US" dirty="0"/>
+              <a:t/>
+            </a:r>
+            <a:endParaRPr lang="en-US" dirty="0"/>
+          </a:p>
+        </p:txBody>
+      </p:sp>
+      <p:sp>
+        <p:nvSpPr>
+          <p:cNvPr id="4" name="Slide Number Placeholder 3"/>
+          <p:cNvSpPr>
+            <a:spLocks noGrp="1"/>
+          </p:cNvSpPr>
+          <p:nvPr>
+            <p:ph type="sldNum" sz="quarter" idx="10"/>
+          </p:nvPr>
+        </p:nvSpPr>
+        <p:spPr/>
+        <p:txBody>
+          <a:bodyPr/>
+          <a:lstStyle/>
+          <a:p>
+            <a:fld id="{F7021451-1387-4CA6-816F-3879F97B5CBC}" type="slidenum">
+              <a:rPr lang="en-US"/>
+              <a:t>11</a:t>
             </a:fld>
             <a:endParaRPr lang="en-US"/>
           </a:p>
@@ -2297,6 +2386,434 @@
     <p:bg>
       <p:bgPr>
         <a:solidFill>
+          <a:srgbClr val="FFFFFF"/>
+        </a:solidFill>
+      </p:bgPr>
+    </p:bg>
+    <p:spTree>
+      <p:nvGrpSpPr>
+        <p:cNvPr id="1" name=""/>
+        <p:cNvGrpSpPr/>
+        <p:nvPr/>
+      </p:nvGrpSpPr>
+      <p:grpSpPr>
+        <a:xfrm>
+          <a:off x="0" y="0"/>
+          <a:ext cx="0" cy="0"/>
+          <a:chOff x="0" y="0"/>
+          <a:chExt cx="0" cy="0"/>
+        </a:xfrm>
+      </p:grpSpPr>
+      <p:sp>
+        <p:nvSpPr>
+          <p:cNvPr id="2" name="Shape 0"/>
+          <p:cNvSpPr/>
+          <p:nvPr/>
+        </p:nvSpPr>
+        <p:spPr>
+          <a:xfrm>
+            <a:off x="566928" y="457200"/>
+            <a:ext cx="384048" cy="384048"/>
+          </a:xfrm>
+          <a:prstGeom prst="ellipse">
+            <a:avLst/>
+          </a:prstGeom>
+          <a:solidFill>
+            <a:srgbClr val="B98A2E"/>
+          </a:solidFill>
+          <a:ln/>
+        </p:spPr>
+      </p:sp>
+      <p:sp>
+        <p:nvSpPr>
+          <p:cNvPr id="3" name="Text 1"/>
+          <p:cNvSpPr/>
+          <p:nvPr/>
+        </p:nvSpPr>
+        <p:spPr>
+          <a:xfrm>
+            <a:off x="566928" y="457200"/>
+            <a:ext cx="384048" cy="384048"/>
+          </a:xfrm>
+          <a:prstGeom prst="rect">
+            <a:avLst/>
+          </a:prstGeom>
+          <a:noFill/>
+          <a:ln/>
+        </p:spPr>
+        <p:txBody>
+          <a:bodyPr wrap="square" lIns="0" tIns="0" rIns="0" bIns="0" rtlCol="0" anchor="ctr"/>
+          <a:lstStyle/>
+          <a:p>
+            <a:pPr algn="ctr" indent="0" marL="0">
+              <a:buNone/>
+            </a:pPr>
+            <a:r>
+              <a:rPr lang="en-US" sz="1300" b="1" dirty="0">
+                <a:solidFill>
+                  <a:srgbClr val="FFFFFF"/>
+                </a:solidFill>
+                <a:latin typeface="Arial" pitchFamily="34" charset="0"/>
+                <a:ea typeface="Arial" pitchFamily="34" charset="-122"/>
+                <a:cs typeface="Arial" pitchFamily="34" charset="-120"/>
+              </a:rPr>
+              <a:t>10</a:t>
+            </a:r>
+            <a:endParaRPr lang="en-US" sz="1300" dirty="0"/>
+          </a:p>
+        </p:txBody>
+      </p:sp>
+      <p:sp>
+        <p:nvSpPr>
+          <p:cNvPr id="4" name="Text 2"/>
+          <p:cNvSpPr/>
+          <p:nvPr/>
+        </p:nvSpPr>
+        <p:spPr>
+          <a:xfrm>
+            <a:off x="1133856" y="457200"/>
+            <a:ext cx="10490911" cy="182880"/>
+          </a:xfrm>
+          <a:prstGeom prst="rect">
+            <a:avLst/>
+          </a:prstGeom>
+          <a:noFill/>
+          <a:ln/>
+        </p:spPr>
+        <p:txBody>
+          <a:bodyPr wrap="square" lIns="0" tIns="0" rIns="0" bIns="0" rtlCol="0" anchor="ctr"/>
+          <a:lstStyle/>
+          <a:p>
+            <a:pPr indent="0" marL="0">
+              <a:buNone/>
+            </a:pPr>
+            <a:r>
+              <a:rPr lang="en-US" sz="950" b="1" spc="200" kern="0" dirty="0">
+                <a:solidFill>
+                  <a:srgbClr val="B98A2E"/>
+                </a:solidFill>
+                <a:latin typeface="Arial" pitchFamily="34" charset="0"/>
+                <a:ea typeface="Arial" pitchFamily="34" charset="-122"/>
+                <a:cs typeface="Arial" pitchFamily="34" charset="-120"/>
+              </a:rPr>
+              <a:t>Process</a:t>
+            </a:r>
+            <a:endParaRPr lang="en-US" sz="950" dirty="0"/>
+          </a:p>
+        </p:txBody>
+      </p:sp>
+      <p:sp>
+        <p:nvSpPr>
+          <p:cNvPr id="5" name="Text 3"/>
+          <p:cNvSpPr/>
+          <p:nvPr/>
+        </p:nvSpPr>
+        <p:spPr>
+          <a:xfrm>
+            <a:off x="1133856" y="640080"/>
+            <a:ext cx="10490911" cy="365760"/>
+          </a:xfrm>
+          <a:prstGeom prst="rect">
+            <a:avLst/>
+          </a:prstGeom>
+          <a:noFill/>
+          <a:ln/>
+        </p:spPr>
+        <p:txBody>
+          <a:bodyPr wrap="square" lIns="0" tIns="0" rIns="0" bIns="0" rtlCol="0" anchor="ctr"/>
+          <a:lstStyle/>
+          <a:p>
+            <a:pPr indent="0" marL="0">
+              <a:buNone/>
+            </a:pPr>
+            <a:r>
+              <a:rPr lang="en-US" sz="2300" b="1" dirty="0">
+                <a:solidFill>
+                  <a:srgbClr val="10161F"/>
+                </a:solidFill>
+                <a:latin typeface="Pretendard" pitchFamily="34" charset="0"/>
+                <a:ea typeface="Pretendard" pitchFamily="34" charset="-122"/>
+                <a:cs typeface="Pretendard" pitchFamily="34" charset="-120"/>
+              </a:rPr>
+              <a:t>검토 후 다음 단계는 무엇인가</a:t>
+            </a:r>
+            <a:endParaRPr lang="en-US" sz="2300" dirty="0"/>
+          </a:p>
+        </p:txBody>
+      </p:sp>
+      <p:sp>
+        <p:nvSpPr>
+          <p:cNvPr id="6" name="Shape 4"/>
+          <p:cNvSpPr/>
+          <p:nvPr/>
+        </p:nvSpPr>
+        <p:spPr>
+          <a:xfrm>
+            <a:off x="566928" y="1572768"/>
+            <a:ext cx="11057839" cy="3200400"/>
+          </a:xfrm>
+          <a:prstGeom prst="roundRect">
+            <a:avLst>
+              <a:gd name="adj" fmla="val 1714"/>
+            </a:avLst>
+          </a:prstGeom>
+          <a:solidFill>
+            <a:srgbClr val="F7FAFC"/>
+          </a:solidFill>
+          <a:ln w="6350">
+            <a:solidFill>
+              <a:srgbClr val="CBD5E0"/>
+            </a:solidFill>
+            <a:prstDash val="solid"/>
+          </a:ln>
+        </p:spPr>
+      </p:sp>
+      <p:sp>
+        <p:nvSpPr>
+          <p:cNvPr id="7" name="Shape 5"/>
+          <p:cNvSpPr/>
+          <p:nvPr/>
+        </p:nvSpPr>
+        <p:spPr>
+          <a:xfrm>
+            <a:off x="786384" y="1792224"/>
+            <a:ext cx="438912" cy="438912"/>
+          </a:xfrm>
+          <a:prstGeom prst="ellipse">
+            <a:avLst/>
+          </a:prstGeom>
+          <a:solidFill>
+            <a:srgbClr val="B98A2E"/>
+          </a:solidFill>
+          <a:ln/>
+        </p:spPr>
+      </p:sp>
+      <p:sp>
+        <p:nvSpPr>
+          <p:cNvPr id="8" name="Text 6"/>
+          <p:cNvSpPr/>
+          <p:nvPr/>
+        </p:nvSpPr>
+        <p:spPr>
+          <a:xfrm>
+            <a:off x="786384" y="1792224"/>
+            <a:ext cx="438912" cy="438912"/>
+          </a:xfrm>
+          <a:prstGeom prst="rect">
+            <a:avLst/>
+          </a:prstGeom>
+          <a:noFill/>
+          <a:ln/>
+        </p:spPr>
+        <p:txBody>
+          <a:bodyPr wrap="square" lIns="0" tIns="0" rIns="0" bIns="0" rtlCol="0" anchor="ctr"/>
+          <a:lstStyle/>
+          <a:p>
+            <a:pPr algn="ctr" indent="0" marL="0">
+              <a:buNone/>
+            </a:pPr>
+            <a:r>
+              <a:rPr lang="en-US" sz="1400" b="1" dirty="0">
+                <a:solidFill>
+                  <a:srgbClr val="FFFFFF"/>
+                </a:solidFill>
+                <a:latin typeface="Arial" pitchFamily="34" charset="0"/>
+                <a:ea typeface="Arial" pitchFamily="34" charset="-122"/>
+                <a:cs typeface="Arial" pitchFamily="34" charset="-120"/>
+              </a:rPr>
+              <a:t>01</a:t>
+            </a:r>
+            <a:endParaRPr lang="en-US" sz="1400" dirty="0"/>
+          </a:p>
+        </p:txBody>
+      </p:sp>
+      <p:sp>
+        <p:nvSpPr>
+          <p:cNvPr id="9" name="Text 7"/>
+          <p:cNvSpPr/>
+          <p:nvPr/>
+        </p:nvSpPr>
+        <p:spPr>
+          <a:xfrm>
+            <a:off x="786384" y="2304288"/>
+            <a:ext cx="10618927" cy="365760"/>
+          </a:xfrm>
+          <a:prstGeom prst="rect">
+            <a:avLst/>
+          </a:prstGeom>
+          <a:noFill/>
+          <a:ln/>
+        </p:spPr>
+        <p:txBody>
+          <a:bodyPr wrap="square" rtlCol="0" anchor="ctr"/>
+          <a:lstStyle/>
+          <a:p>
+            <a:pPr indent="0" marL="0">
+              <a:buNone/>
+            </a:pPr>
+            <a:r>
+              <a:rPr lang="en-US" sz="1600" b="1" dirty="0">
+                <a:solidFill>
+                  <a:srgbClr val="10161F"/>
+                </a:solidFill>
+                <a:latin typeface="Pretendard" pitchFamily="34" charset="0"/>
+                <a:ea typeface="Pretendard" pitchFamily="34" charset="-122"/>
+                <a:cs typeface="Pretendard" pitchFamily="34" charset="-120"/>
+              </a:rPr>
+              <a:t>1단계</a:t>
+            </a:r>
+            <a:endParaRPr lang="en-US" sz="1600" dirty="0"/>
+          </a:p>
+        </p:txBody>
+      </p:sp>
+      <p:sp>
+        <p:nvSpPr>
+          <p:cNvPr id="10" name="Text 8"/>
+          <p:cNvSpPr/>
+          <p:nvPr/>
+        </p:nvSpPr>
+        <p:spPr>
+          <a:xfrm>
+            <a:off x="786384" y="2761488"/>
+            <a:ext cx="10618927" cy="1828800"/>
+          </a:xfrm>
+          <a:prstGeom prst="rect">
+            <a:avLst/>
+          </a:prstGeom>
+          <a:noFill/>
+          <a:ln/>
+        </p:spPr>
+        <p:txBody>
+          <a:bodyPr wrap="square" rtlCol="0" anchor="t"/>
+          <a:lstStyle/>
+          <a:p>
+            <a:pPr indent="0" marL="0">
+              <a:buNone/>
+            </a:pPr>
+            <a:r>
+              <a:rPr lang="en-US" sz="1100" dirty="0">
+                <a:solidFill>
+                  <a:srgbClr val="10161F"/>
+                </a:solidFill>
+                <a:latin typeface="Pretendard" pitchFamily="34" charset="0"/>
+                <a:ea typeface="Pretendard" pitchFamily="34" charset="-122"/>
+                <a:cs typeface="Pretendard" pitchFamily="34" charset="-120"/>
+              </a:rPr>
+              <a:t>{"ok"</a:t>
+            </a:r>
+            <a:endParaRPr lang="en-US" sz="1100" dirty="0"/>
+          </a:p>
+          <a:p>
+            <a:pPr indent="0" marL="0">
+              <a:buNone/>
+            </a:pPr>
+            <a:r>
+              <a:rPr lang="en-US" sz="1100" dirty="0">
+                <a:solidFill>
+                  <a:srgbClr val="10161F"/>
+                </a:solidFill>
+                <a:latin typeface="Pretendard" pitchFamily="34" charset="0"/>
+                <a:ea typeface="Pretendard" pitchFamily="34" charset="-122"/>
+                <a:cs typeface="Pretendard" pitchFamily="34" charset="-120"/>
+              </a:rPr>
+              <a:t>true,"mocked":true,"extractedFields":{"area_signal":"역삼","asset_type":"오피스빌딩","price_band":"300억","size_signal":"3000평(약 9917.4㎡)"},"extractedFacts":{"region":"역삼","exactAddressCandidate":"역삼동 742-1","assetType":"오피스빌딩","priceText":"300억","sizeText":"3000평(약 9917.4㎡)","currentUse":"오피스","currentUseSignal":"근린생활시설","leaseSignal":"임대중","vacancySignal":"공실없음","tenantNames":["쿠팡","네이버"],"unitRentTexts":["301호: 1500만"],"sellerMotivationText":"자산 효율화","brokerNotes":["초역세권 매물"]},"detectedSensitiveFields":["exact_address","tenant_name"],"ambiguousFields":[],"warnings":[],"areaSignal":"역삼","assetType":"오피스빌딩","priceBand":"300억","sizeSignal":"3000평(약 9917.4㎡)","dealType":"매각","buildingName":"역삼 센트럴타워","exactAddress":"역삼동 742-1","totalFloorArea":9917.3,"buildYear":2015,"currentUseSignal":"근린생활시설","vacancySignal":"공실 없음","fitSummary":"초역세권 근생 빌딩으로 시행/사옥 매입에 최적화","cautionSummary":"주요 임차인 만기 조율 필요","hiddenFields":["exact_address","seller_motivation"],"confidence":{"areaSignal":"confirmed","assetType":"confirmed","priceBand":"ai_hypothesis","fitSummary":"ai_hypothesis"},"missingData":["sizeSignal"],"boundaryNote":"본 자료는 실거래 통계 기반 참고치입니다.","buyerType":"법인 사옥형","budgetRange":{"min":50,"max":80,"display":"50억~80억"},"preferredRegions":["강남","성수"],"assetTypes":["꼬마빌딩","사옥용"],"purchasePurpose":"사옥용 매입","mustHave":["초역세권","주차"],"niceToHave":["테라스","루프탑"],"riskTolerance":"medium","financingNote":"자본금 50% 준비","missingQuestions":["구체적인 입주 시기가 언제인가요?","선호하는 수익률이 있나요?"],"privacyNotes":["연락처 비공개"],"fitReasons":["매수자 예산(50-80억)에 부합하는 매물입니다.","요청하신 성수/강남 권역에 해당합니다."],"cautionReasons":["요청한 용도와 달리 명도 협의가 다소 필요합니다."],"recommendedNextAction":"현장 답사 제안","kakaoMessage":"안녕하세요! 요청하신 조건에 부합하는 추천 매물이 있어 안내해 드립니다. 확인해보시고 피드백 부탁드립니다.","title":"강남 역삼역 초역세권 오피스 사옥용 빌딩 매각","shortSummary":"역삼역 도보 5분 거리의 준신축급 대형 오피스빌딩입니다.","dealPoints":["초역세권","사옥 최적"],"cautionPoints":["명도 조율 필요"],"hiddenInfoNotice":["보증금 및 지번은 인가 후 확인 가능"],"gateMessage":"G1 등급 등록이 필요합니다.","kakaoText":"강남 역삼역 오피스 빌딩 매각 안내입니다.","exactUnitCandidate":"101호","floor":"1층","areaSqmText":"150㎡","spaceType":"office","depositText":"5000만","monthlyRentText":"400만","maintenanceFeeText":"50만","availableFromText":"즉시입주","leaseTermMonthsText":"24","incentivesText":"렌트프리 2개월","restrictions":[],"landlordIdentity":"김성수","currentTenant":"스타트업","vacancyReason":"이전 확장","rentNegotiation":"협의 가능","region":"성수동","areaSqm":150,"deposit":5000,"monthlyRent":400,"maintenanceFee":50,"availableFrom":"즉시입주","leaseTermMonths":24,"incentives":{"rentFreeMonths":2,"interiorSupport":"일부 인테리어 지원","freeRentDetail":"렌트프리 2개월 지원"},"shortSummaryLease":"성수역 도보 5분 거리 1층 리테일 상가 매물입니다."}</a:t>
+            </a:r>
+            <a:endParaRPr lang="en-US" sz="1100" dirty="0"/>
+          </a:p>
+        </p:txBody>
+      </p:sp>
+      <p:sp>
+        <p:nvSpPr>
+          <p:cNvPr id="11" name="Text 9"/>
+          <p:cNvSpPr/>
+          <p:nvPr/>
+        </p:nvSpPr>
+        <p:spPr>
+          <a:xfrm>
+            <a:off x="566928" y="6382512"/>
+            <a:ext cx="7315200" cy="219456"/>
+          </a:xfrm>
+          <a:prstGeom prst="rect">
+            <a:avLst/>
+          </a:prstGeom>
+          <a:noFill/>
+          <a:ln/>
+        </p:spPr>
+        <p:txBody>
+          <a:bodyPr wrap="square" lIns="0" tIns="0" rIns="0" bIns="0" rtlCol="0" anchor="ctr"/>
+          <a:lstStyle/>
+          <a:p>
+            <a:pPr indent="0" marL="0">
+              <a:buNone/>
+            </a:pPr>
+            <a:r>
+              <a:rPr lang="en-US" sz="800" dirty="0">
+                <a:solidFill>
+                  <a:srgbClr val="718096"/>
+                </a:solidFill>
+                <a:latin typeface="Pretendard" pitchFamily="34" charset="0"/>
+                <a:ea typeface="Pretendard" pitchFamily="34" charset="-122"/>
+                <a:cs typeface="Pretendard" pitchFamily="34" charset="-120"/>
+              </a:rPr>
+              <a:t>크리딜   |   </a:t>
+            </a:r>
+            <a:endParaRPr lang="en-US" sz="800" dirty="0"/>
+          </a:p>
+        </p:txBody>
+      </p:sp>
+      <p:sp>
+        <p:nvSpPr>
+          <p:cNvPr id="12" name="Text 10"/>
+          <p:cNvSpPr/>
+          <p:nvPr/>
+        </p:nvSpPr>
+        <p:spPr>
+          <a:xfrm>
+            <a:off x="10710367" y="6382512"/>
+            <a:ext cx="914400" cy="219456"/>
+          </a:xfrm>
+          <a:prstGeom prst="rect">
+            <a:avLst/>
+          </a:prstGeom>
+          <a:noFill/>
+          <a:ln/>
+        </p:spPr>
+        <p:txBody>
+          <a:bodyPr wrap="square" lIns="0" tIns="0" rIns="0" bIns="0" rtlCol="0" anchor="ctr"/>
+          <a:lstStyle/>
+          <a:p>
+            <a:pPr algn="r" indent="0" marL="0">
+              <a:buNone/>
+            </a:pPr>
+            <a:r>
+              <a:rPr lang="en-US" sz="900" b="1" dirty="0">
+                <a:solidFill>
+                  <a:srgbClr val="B98A2E"/>
+                </a:solidFill>
+                <a:latin typeface="Arial" pitchFamily="34" charset="0"/>
+                <a:ea typeface="Arial" pitchFamily="34" charset="-122"/>
+                <a:cs typeface="Arial" pitchFamily="34" charset="-120"/>
+              </a:rPr>
+              <a:t>10</a:t>
+            </a:r>
+            <a:endParaRPr lang="en-US" sz="900" dirty="0"/>
+          </a:p>
+        </p:txBody>
+      </p:sp>
+    </p:spTree>
+  </p:cSld>
+  <p:clrMapOvr>
+    <a:masterClrMapping/>
+  </p:clrMapOvr>
+</p:sld>
+</file>
+
+<file path=ppt/slides/slide11.xml><?xml version="1.0" encoding="utf-8"?>
+<p:sld xmlns:a="http://schemas.openxmlformats.org/drawingml/2006/main" xmlns:r="http://schemas.openxmlformats.org/officeDocument/2006/relationships" xmlns:p="http://schemas.openxmlformats.org/presentationml/2006/main">
+  <p:cSld name="Slide 11">
+    <p:bg>
+      <p:bgPr>
+        <a:solidFill>
           <a:srgbClr val="10161F"/>
         </a:solidFill>
       </p:bgPr>
@@ -2368,7 +2885,7 @@
                 <a:ea typeface="Arial" pitchFamily="34" charset="-122"/>
                 <a:cs typeface="Arial" pitchFamily="34" charset="-120"/>
               </a:rPr>
-              <a:t>10</a:t>
+              <a:t>11</a:t>
             </a:r>
             <a:endParaRPr lang="en-US" sz="1300" dirty="0"/>
           </a:p>
@@ -3780,7 +4297,7 @@
                 <a:ea typeface="Arial" pitchFamily="34" charset="-122"/>
                 <a:cs typeface="Arial" pitchFamily="34" charset="-120"/>
               </a:rPr>
-              <a:t>10</a:t>
+              <a:t>11</a:t>
             </a:r>
             <a:endParaRPr lang="en-US" sz="900" dirty="0"/>
           </a:p>
@@ -5187,7 +5704,7 @@
                 <a:ea typeface="Pretendard" pitchFamily="34" charset="-122"/>
                 <a:cs typeface="Pretendard" pitchFamily="34" charset="-120"/>
               </a:rPr>
-              <a:t>교통 접근성 상세 정보는 담당 브로커를 통해 확인하</a:t>
+              <a:t>교통 접근성</a:t>
             </a:r>
             <a:endParaRPr lang="en-US" sz="1300" dirty="0"/>
           </a:p>
@@ -5220,70 +5737,16 @@
               </a:lnSpc>
               <a:buNone/>
             </a:pPr>
-            <a:endParaRPr lang="en-US" sz="1300" dirty="0"/>
-          </a:p>
-        </p:txBody>
-      </p:sp>
-      <p:sp>
-        <p:nvSpPr>
-          <p:cNvPr id="9" name="Shape 6"/>
-          <p:cNvSpPr/>
-          <p:nvPr/>
-        </p:nvSpPr>
-        <p:spPr>
-          <a:xfrm>
-            <a:off x="6053328" y="1975104"/>
-            <a:ext cx="5571439" cy="0"/>
-          </a:xfrm>
-          <a:prstGeom prst="line">
-            <a:avLst/>
-          </a:prstGeom>
-          <a:noFill/>
-          <a:ln w="3810">
-            <a:solidFill>
-              <a:srgbClr val="CBD5E0"/>
-            </a:solidFill>
-            <a:prstDash val="solid"/>
-          </a:ln>
-        </p:spPr>
-      </p:sp>
-      <p:sp>
-        <p:nvSpPr>
-          <p:cNvPr id="10" name="Text 7"/>
-          <p:cNvSpPr/>
-          <p:nvPr/>
-        </p:nvSpPr>
-        <p:spPr>
-          <a:xfrm>
-            <a:off x="6053328" y="1975104"/>
-            <a:ext cx="2117147" cy="493776"/>
-          </a:xfrm>
-          <a:prstGeom prst="rect">
-            <a:avLst/>
-          </a:prstGeom>
-          <a:noFill/>
-          <a:ln/>
-        </p:spPr>
-        <p:txBody>
-          <a:bodyPr wrap="square" lIns="0" tIns="0" rIns="0" bIns="0" rtlCol="0" anchor="ctr"/>
-          <a:lstStyle/>
-          <a:p>
-            <a:pPr indent="0" marL="0">
-              <a:lnSpc>
-                <a:spcPct val="120000"/>
-              </a:lnSpc>
-              <a:buNone/>
-            </a:pPr>
-            <a:r>
-              <a:rPr lang="en-US" sz="1300" dirty="0">
-                <a:solidFill>
-                  <a:srgbClr val="718096"/>
+            <a:r>
+              <a:rPr lang="en-US" sz="1300" b="1" dirty="0">
+                <a:solidFill>
+                  <a:srgbClr val="10161F"/>
                 </a:solidFill>
                 <a:latin typeface="Pretendard" pitchFamily="34" charset="0"/>
                 <a:ea typeface="Pretendard" pitchFamily="34" charset="-122"/>
                 <a:cs typeface="Pretendard" pitchFamily="34" charset="-120"/>
               </a:rPr>
-              <a:t>[건물] 주변 상권</a:t>
+              <a:t>{"ok":true,"mocked":true,"extractedFields":{"area_signal":"역삼","asset_type":"오피스빌딩","price_band":"300억","size_signal":"3000평(약 9917.</a:t>
             </a:r>
             <a:endParaRPr lang="en-US" sz="1300" dirty="0"/>
           </a:p>
@@ -5291,14 +5754,14 @@
       </p:sp>
       <p:sp>
         <p:nvSpPr>
-          <p:cNvPr id="11" name="Text 8"/>
-          <p:cNvSpPr/>
-          <p:nvPr/>
-        </p:nvSpPr>
-        <p:spPr>
-          <a:xfrm>
-            <a:off x="8170475" y="1975104"/>
-            <a:ext cx="3454292" cy="493776"/>
+          <p:cNvPr id="9" name="Text 6"/>
+          <p:cNvSpPr/>
+          <p:nvPr/>
+        </p:nvSpPr>
+        <p:spPr>
+          <a:xfrm>
+            <a:off x="566928" y="6382512"/>
+            <a:ext cx="7315200" cy="219456"/>
           </a:xfrm>
           <a:prstGeom prst="rect">
             <a:avLst/>
@@ -5311,197 +5774,98 @@
           <a:lstStyle/>
           <a:p>
             <a:pPr indent="0" marL="0">
-              <a:lnSpc>
-                <a:spcPct val="120000"/>
-              </a:lnSpc>
-              <a:buNone/>
-            </a:pPr>
-            <a:r>
-              <a:rPr lang="en-US" sz="1300" b="1" dirty="0">
-                <a:solidFill>
-                  <a:srgbClr val="10161F"/>
+              <a:buNone/>
+            </a:pPr>
+            <a:r>
+              <a:rPr lang="en-US" sz="800" dirty="0">
+                <a:solidFill>
+                  <a:srgbClr val="718096"/>
                 </a:solidFill>
                 <a:latin typeface="Pretendard" pitchFamily="34" charset="0"/>
                 <a:ea typeface="Pretendard" pitchFamily="34" charset="-122"/>
                 <a:cs typeface="Pretendard" pitchFamily="34" charset="-120"/>
               </a:rPr>
-              <a:t>강남권역 내 주요 비즈니스 및 유동인구 풍부한 상권 입지 ### [성장] 입지 평가</a:t>
-            </a:r>
-            <a:endParaRPr lang="en-US" sz="1300" dirty="0"/>
-          </a:p>
-        </p:txBody>
-      </p:sp>
-      <p:sp>
-        <p:nvSpPr>
-          <p:cNvPr id="12" name="Shape 9"/>
-          <p:cNvSpPr/>
-          <p:nvPr/>
-        </p:nvSpPr>
-        <p:spPr>
-          <a:xfrm>
-            <a:off x="6053328" y="2468880"/>
-            <a:ext cx="5571439" cy="0"/>
-          </a:xfrm>
-          <a:prstGeom prst="line">
-            <a:avLst/>
-          </a:prstGeom>
-          <a:noFill/>
-          <a:ln w="3810">
-            <a:solidFill>
-              <a:srgbClr val="CBD5E0"/>
-            </a:solidFill>
-            <a:prstDash val="solid"/>
-          </a:ln>
-        </p:spPr>
-      </p:sp>
-      <p:sp>
-        <p:nvSpPr>
-          <p:cNvPr id="13" name="Text 10"/>
-          <p:cNvSpPr/>
-          <p:nvPr/>
-        </p:nvSpPr>
-        <p:spPr>
-          <a:xfrm>
-            <a:off x="6053328" y="2468880"/>
-            <a:ext cx="2117147" cy="493776"/>
-          </a:xfrm>
-          <a:prstGeom prst="rect">
-            <a:avLst/>
-          </a:prstGeom>
-          <a:noFill/>
-          <a:ln/>
-        </p:spPr>
-        <p:txBody>
-          <a:bodyPr wrap="square" lIns="0" tIns="0" rIns="0" bIns="0" rtlCol="0" anchor="ctr"/>
+              <a:t>크리딜   |   </a:t>
+            </a:r>
+            <a:endParaRPr lang="en-US" sz="800" dirty="0"/>
+          </a:p>
+        </p:txBody>
+      </p:sp>
+      <p:sp>
+        <p:nvSpPr>
+          <p:cNvPr id="10" name="Text 7"/>
+          <p:cNvSpPr/>
+          <p:nvPr/>
+        </p:nvSpPr>
+        <p:spPr>
+          <a:xfrm>
+            <a:off x="10710367" y="6382512"/>
+            <a:ext cx="914400" cy="219456"/>
+          </a:xfrm>
+          <a:prstGeom prst="rect">
+            <a:avLst/>
+          </a:prstGeom>
+          <a:noFill/>
+          <a:ln/>
+        </p:spPr>
+        <p:txBody>
+          <a:bodyPr wrap="square" lIns="0" tIns="0" rIns="0" bIns="0" rtlCol="0" anchor="ctr"/>
+          <a:lstStyle/>
+          <a:p>
+            <a:pPr algn="r" indent="0" marL="0">
+              <a:buNone/>
+            </a:pPr>
+            <a:r>
+              <a:rPr lang="en-US" sz="900" b="1" dirty="0">
+                <a:solidFill>
+                  <a:srgbClr val="B98A2E"/>
+                </a:solidFill>
+                <a:latin typeface="Arial" pitchFamily="34" charset="0"/>
+                <a:ea typeface="Arial" pitchFamily="34" charset="-122"/>
+                <a:cs typeface="Arial" pitchFamily="34" charset="-120"/>
+              </a:rPr>
+              <a:t>3</a:t>
+            </a:r>
+            <a:endParaRPr lang="en-US" sz="900" dirty="0"/>
+          </a:p>
+        </p:txBody>
+      </p:sp>
+      <p:sp>
+        <p:nvSpPr>
+          <p:cNvPr id="11" name="Text 8"/>
+          <p:cNvSpPr/>
+          <p:nvPr/>
+        </p:nvSpPr>
+        <p:spPr>
+          <a:xfrm>
+            <a:off x="566928" y="1481328"/>
+            <a:ext cx="11057839" cy="9692640"/>
+          </a:xfrm>
+          <a:prstGeom prst="rect">
+            <a:avLst/>
+          </a:prstGeom>
+          <a:noFill/>
+          <a:ln/>
+        </p:spPr>
+        <p:txBody>
+          <a:bodyPr wrap="square" lIns="0" tIns="0" rIns="0" bIns="0" rtlCol="0" anchor="t"/>
           <a:lstStyle/>
           <a:p>
             <a:pPr indent="0" marL="0">
-              <a:lnSpc>
-                <a:spcPct val="120000"/>
-              </a:lnSpc>
-              <a:buNone/>
-            </a:pPr>
-            <a:r>
-              <a:rPr lang="en-US" sz="1300" dirty="0">
-                <a:solidFill>
-                  <a:srgbClr val="718096"/>
+              <a:buNone/>
+            </a:pPr>
+            <a:r>
+              <a:rPr lang="en-US" sz="1000" dirty="0">
+                <a:solidFill>
+                  <a:srgbClr val="10161F"/>
                 </a:solidFill>
                 <a:latin typeface="Pretendard" pitchFamily="34" charset="0"/>
                 <a:ea typeface="Pretendard" pitchFamily="34" charset="-122"/>
                 <a:cs typeface="Pretendard" pitchFamily="34" charset="-120"/>
               </a:rPr>
-              <a:t>강남권역 내 위치하며 접근성과 가시성이 양호한 입지</a:t>
-            </a:r>
-            <a:endParaRPr lang="en-US" sz="1300" dirty="0"/>
-          </a:p>
-        </p:txBody>
-      </p:sp>
-      <p:sp>
-        <p:nvSpPr>
-          <p:cNvPr id="14" name="Text 11"/>
-          <p:cNvSpPr/>
-          <p:nvPr/>
-        </p:nvSpPr>
-        <p:spPr>
-          <a:xfrm>
-            <a:off x="8170475" y="2468880"/>
-            <a:ext cx="3454292" cy="493776"/>
-          </a:xfrm>
-          <a:prstGeom prst="rect">
-            <a:avLst/>
-          </a:prstGeom>
-          <a:noFill/>
-          <a:ln/>
-        </p:spPr>
-        <p:txBody>
-          <a:bodyPr wrap="square" lIns="0" tIns="0" rIns="0" bIns="0" rtlCol="0" anchor="ctr"/>
-          <a:lstStyle/>
-          <a:p>
-            <a:pPr indent="0" marL="0">
-              <a:lnSpc>
-                <a:spcPct val="120000"/>
-              </a:lnSpc>
-              <a:buNone/>
-            </a:pPr>
-            <a:endParaRPr lang="en-US" sz="1300" dirty="0"/>
-          </a:p>
-        </p:txBody>
-      </p:sp>
-      <p:sp>
-        <p:nvSpPr>
-          <p:cNvPr id="15" name="Text 12"/>
-          <p:cNvSpPr/>
-          <p:nvPr/>
-        </p:nvSpPr>
-        <p:spPr>
-          <a:xfrm>
-            <a:off x="566928" y="6382512"/>
-            <a:ext cx="7315200" cy="219456"/>
-          </a:xfrm>
-          <a:prstGeom prst="rect">
-            <a:avLst/>
-          </a:prstGeom>
-          <a:noFill/>
-          <a:ln/>
-        </p:spPr>
-        <p:txBody>
-          <a:bodyPr wrap="square" lIns="0" tIns="0" rIns="0" bIns="0" rtlCol="0" anchor="ctr"/>
-          <a:lstStyle/>
-          <a:p>
-            <a:pPr indent="0" marL="0">
-              <a:buNone/>
-            </a:pPr>
-            <a:r>
-              <a:rPr lang="en-US" sz="800" dirty="0">
-                <a:solidFill>
-                  <a:srgbClr val="718096"/>
-                </a:solidFill>
-                <a:latin typeface="Pretendard" pitchFamily="34" charset="0"/>
-                <a:ea typeface="Pretendard" pitchFamily="34" charset="-122"/>
-                <a:cs typeface="Pretendard" pitchFamily="34" charset="-120"/>
-              </a:rPr>
-              <a:t>크리딜   |   </a:t>
-            </a:r>
-            <a:endParaRPr lang="en-US" sz="800" dirty="0"/>
-          </a:p>
-        </p:txBody>
-      </p:sp>
-      <p:sp>
-        <p:nvSpPr>
-          <p:cNvPr id="16" name="Text 13"/>
-          <p:cNvSpPr/>
-          <p:nvPr/>
-        </p:nvSpPr>
-        <p:spPr>
-          <a:xfrm>
-            <a:off x="10710367" y="6382512"/>
-            <a:ext cx="914400" cy="219456"/>
-          </a:xfrm>
-          <a:prstGeom prst="rect">
-            <a:avLst/>
-          </a:prstGeom>
-          <a:noFill/>
-          <a:ln/>
-        </p:spPr>
-        <p:txBody>
-          <a:bodyPr wrap="square" lIns="0" tIns="0" rIns="0" bIns="0" rtlCol="0" anchor="ctr"/>
-          <a:lstStyle/>
-          <a:p>
-            <a:pPr algn="r" indent="0" marL="0">
-              <a:buNone/>
-            </a:pPr>
-            <a:r>
-              <a:rPr lang="en-US" sz="900" b="1" dirty="0">
-                <a:solidFill>
-                  <a:srgbClr val="B98A2E"/>
-                </a:solidFill>
-                <a:latin typeface="Arial" pitchFamily="34" charset="0"/>
-                <a:ea typeface="Arial" pitchFamily="34" charset="-122"/>
-                <a:cs typeface="Arial" pitchFamily="34" charset="-120"/>
-              </a:rPr>
-              <a:t>3</a:t>
-            </a:r>
-            <a:endParaRPr lang="en-US" sz="900" dirty="0"/>
+              <a:t>{"ok":true,"mocked":true,"extractedFields":{"area_signal":"역삼","asset_type":"오피스빌딩","price_band":"300억","size_signal":"3000평(약 9917.4㎡)"},"extractedFacts":{"region":"역삼","exactAddressCandidate":"역삼동 742-1","assetType":"오피스빌딩","priceText":"300억","sizeText":"3000평(약 9917.4㎡)","currentUse":"오피스","currentUseSignal":"근린생활시설","leaseSignal":"임대중","vacancySignal":"공실없음","tenantNames":["쿠팡","네이버"],"unitRentTexts":["301호: 1500만"],"sellerMotivationText":"자산 효율화","brokerNotes":["초역세권 매물"]},"detectedSensitiveFields":["exact_address","tenant_name"],"ambiguousFields":[],"warnings":[],"areaSignal":"역삼","assetType":"오피스빌딩","priceBand":"300억","sizeSignal":"3000평(약 9917.4㎡)","dealType":"매각","buildingName":"역삼 센트럴타워","exactAddress":"역삼동 742-1","totalFloorArea":9917.3,"buildYear":2015,"currentUseSignal":"근린생활시설","vacancySignal":"공실 없음","fitSummary":"초역세권 근생 빌딩으로 시행/사옥 매입에 최적화","cautionSummary":"주요 임차인 만기 조율 필요","hiddenFields":["exact_address","seller_motivation"],"confidence":{"areaSignal":"confirmed","assetType":"confirmed","priceBand":"ai_hypothesis","fitSummary":"ai_hypothesis"},"missingData":["sizeSignal"],"boundaryNote":"본 자료는 실거래 통계 기반 참고치입니다.","buyerType":"법인 사옥형","budgetRange":{"min":50,"max":80,"display":"50억~80억"},"preferredRegions":["강남","성수"],"assetTypes":["꼬마빌딩","사옥용"],"purchasePurpose":"사옥용 매입","mustHave":["초역세권","주차"],"niceToHave":["테라스","루프탑"],"riskTolerance":"medium","financingNote":"자본금 50% 준비","missingQuestions":["구체적인 입주 시기가 언제인가요?","선호하는 수익률이 있나요?"],"privacyNotes":["연락처 비공개"],"fitReasons":["매수자 예산(50-80억)에 부합하는 매물입니다.","요청하신 성수/강남 권역에 해당합니다."],"cautionReasons":["요청한 용도와 달리 명도 협의가 다소 필요합니다."],"recommendedNextAction":"현장 답사 제안","kakaoMessage":"안녕하세요! 요청하신 조건에 부합하는 추천 매물이 있어 안내해 드립니다. 확인해보시고 피드백 부탁드립니다.","title":"강남 역삼역 초역세권 오피스 사옥용 빌딩 매각","shortSummary":"역삼역 도보 5분 거리의 준신축급 대형 오피스빌딩입니다.","dealPoints":["초역세권","사옥 최적"],"cautionPoints":["명도 조율 필요"],"hiddenInfoNotice":["보증금 및 지번은 인가 후 확인 가능"],"gateMessage":"G1 등급 등록이 필요합니다.","kakaoText":"강남 역삼역 오피스 빌딩 매각 안내입니다.","exactUnitCandidate":"101호","floor":"1층","areaSqmText":"150㎡","spaceType":"office","depositText":"5000만","monthlyRentText":"400만","maintenanceFeeText":"50만","availableFromText":"즉시입주","leaseTermMonthsText":"24","incentivesText":"렌트프리 2개월","restrictions":[],"landlordIdentity":"김성수","currentTenant":"스타트업","vacancyReason":"이전 확장","rentNegotiation":"협의 가능","region":"성수동","areaSqm":150,"deposit":5000,"monthlyRent":400,"maintenanceFee":50,"availableFrom":"즉시입주","leaseTermMonths":24,"incentives":{"rentFreeMonths":2,"interiorSupport":"일부 인테리어 지원","freeRentDetail":"렌트프리 2개월 지원"},"shortSummaryLease":"성수역 도보 5분 거리 1층 리테일 상가 매물입니다."}</a:t>
+            </a:r>
+            <a:endParaRPr lang="en-US" sz="1000" dirty="0"/>
           </a:p>
         </p:txBody>
       </p:sp>
@@ -8011,11 +8375,11 @@
         <p:spPr>
           <a:xfrm>
             <a:off x="566928" y="1417320"/>
-            <a:ext cx="3515258" cy="3657600"/>
+            <a:ext cx="11057839" cy="3657600"/>
           </a:xfrm>
           <a:prstGeom prst="roundRect">
             <a:avLst>
-              <a:gd name="adj" fmla="val 1561"/>
+              <a:gd name="adj" fmla="val 1500"/>
             </a:avLst>
           </a:prstGeom>
           <a:solidFill>
@@ -8038,7 +8402,7 @@
         <p:spPr>
           <a:xfrm>
             <a:off x="566928" y="1417320"/>
-            <a:ext cx="3515258" cy="45720"/>
+            <a:ext cx="11057839" cy="45720"/>
           </a:xfrm>
           <a:prstGeom prst="rect">
             <a:avLst/>
@@ -8058,7 +8422,7 @@
         <p:spPr>
           <a:xfrm>
             <a:off x="795528" y="1618488"/>
-            <a:ext cx="3058058" cy="292608"/>
+            <a:ext cx="10600639" cy="292608"/>
           </a:xfrm>
           <a:prstGeom prst="rect">
             <a:avLst/>
@@ -8082,7 +8446,7 @@
                 <a:ea typeface="Pretendard" pitchFamily="34" charset="-122"/>
                 <a:cs typeface="Pretendard" pitchFamily="34" charset="-120"/>
               </a:rPr>
-              <a:t>건물 물리적 상태</a:t>
+              <a:t>용도 리스크</a:t>
             </a:r>
             <a:endParaRPr lang="en-US" sz="1350" dirty="0"/>
           </a:p>
@@ -8097,7 +8461,7 @@
         <p:spPr>
           <a:xfrm>
             <a:off x="795528" y="1947672"/>
-            <a:ext cx="3058058" cy="365760"/>
+            <a:ext cx="10600639" cy="365760"/>
           </a:xfrm>
           <a:prstGeom prst="rect">
             <a:avLst/>
@@ -8123,7 +8487,7 @@
                 <a:ea typeface="Pretendard" pitchFamily="34" charset="-122"/>
                 <a:cs typeface="Pretendard" pitchFamily="34" charset="-120"/>
               </a:rPr>
-              <a:t>준공연도 확인 필요, 구조 확인 필요</a:t>
+              <a:t>—</a:t>
             </a:r>
             <a:endParaRPr lang="en-US" sz="1250" dirty="0"/>
           </a:p>
@@ -8138,7 +8502,7 @@
         <p:spPr>
           <a:xfrm>
             <a:off x="795528" y="2377440"/>
-            <a:ext cx="3058058" cy="2606040"/>
+            <a:ext cx="10600639" cy="2606040"/>
           </a:xfrm>
           <a:prstGeom prst="rect">
             <a:avLst/>
@@ -8168,58 +8532,10 @@
                 <a:ea typeface="Pretendard" pitchFamily="34" charset="-122"/>
                 <a:cs typeface="Pretendard" pitchFamily="34" charset="-120"/>
               </a:rPr>
-              <a:t>누수</a:t>
+              <a:t>{"ok":true,"mocked":true,"extractedFields":{"area_signal":"역삼","asset_type":"오피스빌딩","price_band":"300억","size_signal":"3000평(약 9917.4㎡)"},"extractedFacts":{"region":"역삼","exactAddressCandidate":"역삼동 7</a:t>
             </a:r>
             <a:endParaRPr lang="en-US" sz="1100" dirty="0"/>
           </a:p>
-          <a:p>
-            <a:pPr marL="342900" indent="-342900">
-              <a:lnSpc>
-                <a:spcPct val="125000"/>
-              </a:lnSpc>
-              <a:spcBef>
-                <a:spcPts val="600"/>
-              </a:spcBef>
-              <a:buSzPct val="100000"/>
-              <a:buChar char="•"/>
-            </a:pPr>
-            <a:r>
-              <a:rPr lang="en-US" sz="1100" dirty="0">
-                <a:solidFill>
-                  <a:srgbClr val="10161F"/>
-                </a:solidFill>
-                <a:latin typeface="Pretendard" pitchFamily="34" charset="0"/>
-                <a:ea typeface="Pretendard" pitchFamily="34" charset="-122"/>
-                <a:cs typeface="Pretendard" pitchFamily="34" charset="-120"/>
-              </a:rPr>
-              <a:t>균열</a:t>
-            </a:r>
-            <a:endParaRPr lang="en-US" sz="1100" dirty="0"/>
-          </a:p>
-          <a:p>
-            <a:pPr marL="342900" indent="-342900">
-              <a:lnSpc>
-                <a:spcPct val="125000"/>
-              </a:lnSpc>
-              <a:spcBef>
-                <a:spcPts val="600"/>
-              </a:spcBef>
-              <a:buSzPct val="100000"/>
-              <a:buChar char="•"/>
-            </a:pPr>
-            <a:r>
-              <a:rPr lang="en-US" sz="1100" dirty="0">
-                <a:solidFill>
-                  <a:srgbClr val="10161F"/>
-                </a:solidFill>
-                <a:latin typeface="Pretendard" pitchFamily="34" charset="0"/>
-                <a:ea typeface="Pretendard" pitchFamily="34" charset="-122"/>
-                <a:cs typeface="Pretendard" pitchFamily="34" charset="-120"/>
-              </a:rPr>
-              <a:t>설비 노후 여부 현장 점검 필요</a:t>
-            </a:r>
-            <a:endParaRPr lang="en-US" sz="1100" dirty="0"/>
-          </a:p>
         </p:txBody>
       </p:sp>
       <p:sp>
@@ -8230,12 +8546,12 @@
         </p:nvSpPr>
         <p:spPr>
           <a:xfrm>
-            <a:off x="4338218" y="1417320"/>
-            <a:ext cx="3515258" cy="3657600"/>
+            <a:off x="566928" y="5193792"/>
+            <a:ext cx="11057839" cy="621792"/>
           </a:xfrm>
           <a:prstGeom prst="roundRect">
             <a:avLst>
-              <a:gd name="adj" fmla="val 1561"/>
+              <a:gd name="adj" fmla="val 8824"/>
             </a:avLst>
           </a:prstGeom>
           <a:solidFill>
@@ -8251,34 +8567,14 @@
       </p:sp>
       <p:sp>
         <p:nvSpPr>
-          <p:cNvPr id="12" name="Shape 10"/>
-          <p:cNvSpPr/>
-          <p:nvPr/>
-        </p:nvSpPr>
-        <p:spPr>
-          <a:xfrm>
-            <a:off x="4338218" y="1417320"/>
-            <a:ext cx="3515258" cy="45720"/>
-          </a:xfrm>
-          <a:prstGeom prst="rect">
-            <a:avLst/>
-          </a:prstGeom>
-          <a:solidFill>
-            <a:srgbClr val="B98A2E"/>
-          </a:solidFill>
-          <a:ln/>
-        </p:spPr>
-      </p:sp>
-      <p:sp>
-        <p:nvSpPr>
-          <p:cNvPr id="13" name="Text 11"/>
-          <p:cNvSpPr/>
-          <p:nvPr/>
-        </p:nvSpPr>
-        <p:spPr>
-          <a:xfrm>
-            <a:off x="4566818" y="1618488"/>
-            <a:ext cx="3058058" cy="292608"/>
+          <p:cNvPr id="12" name="Text 10"/>
+          <p:cNvSpPr/>
+          <p:nvPr/>
+        </p:nvSpPr>
+        <p:spPr>
+          <a:xfrm>
+            <a:off x="795528" y="5193792"/>
+            <a:ext cx="10600639" cy="621792"/>
           </a:xfrm>
           <a:prstGeom prst="rect">
             <a:avLst/>
@@ -8294,377 +8590,53 @@
               <a:buNone/>
             </a:pPr>
             <a:r>
-              <a:rPr lang="en-US" sz="1350" b="1" dirty="0">
-                <a:solidFill>
-                  <a:srgbClr val="977024"/>
+              <a:rPr lang="en-US" sz="1100" dirty="0">
+                <a:solidFill>
+                  <a:srgbClr val="10161F"/>
                 </a:solidFill>
                 <a:latin typeface="Pretendard" pitchFamily="34" charset="0"/>
                 <a:ea typeface="Pretendard" pitchFamily="34" charset="-122"/>
                 <a:cs typeface="Pretendard" pitchFamily="34" charset="-120"/>
               </a:rPr>
-              <a:t>승강기 및 설비</a:t>
-            </a:r>
-            <a:endParaRPr lang="en-US" sz="1350" dirty="0"/>
-          </a:p>
-        </p:txBody>
-      </p:sp>
-      <p:sp>
-        <p:nvSpPr>
-          <p:cNvPr id="14" name="Text 12"/>
-          <p:cNvSpPr/>
-          <p:nvPr/>
-        </p:nvSpPr>
-        <p:spPr>
-          <a:xfrm>
-            <a:off x="4566818" y="1947672"/>
-            <a:ext cx="3058058" cy="365760"/>
-          </a:xfrm>
-          <a:prstGeom prst="rect">
-            <a:avLst/>
-          </a:prstGeom>
-          <a:noFill/>
-          <a:ln/>
-        </p:spPr>
-        <p:txBody>
-          <a:bodyPr wrap="square" lIns="0" tIns="0" rIns="0" bIns="0" rtlCol="0" anchor="ctr">
-            <a:normAutofit/>
-          </a:bodyPr>
+              <a:t>※ 본 리스크 체크는 공부 및 브로커 확인 기반이며, 매수 전 전문 실사팀(변호사/건축사)을 통한 정밀 실사가 필요합니다.</a:t>
+            </a:r>
+            <a:endParaRPr lang="en-US" sz="1100" dirty="0"/>
+          </a:p>
+        </p:txBody>
+      </p:sp>
+      <p:sp>
+        <p:nvSpPr>
+          <p:cNvPr id="13" name="Text 11"/>
+          <p:cNvSpPr/>
+          <p:nvPr/>
+        </p:nvSpPr>
+        <p:spPr>
+          <a:xfrm>
+            <a:off x="566928" y="6382512"/>
+            <a:ext cx="7315200" cy="219456"/>
+          </a:xfrm>
+          <a:prstGeom prst="rect">
+            <a:avLst/>
+          </a:prstGeom>
+          <a:noFill/>
+          <a:ln/>
+        </p:spPr>
+        <p:txBody>
+          <a:bodyPr wrap="square" lIns="0" tIns="0" rIns="0" bIns="0" rtlCol="0" anchor="ctr"/>
           <a:lstStyle/>
           <a:p>
             <a:pPr indent="0" marL="0">
               <a:buNone/>
             </a:pPr>
             <a:r>
-              <a:rPr lang="en-US" sz="1250" b="1" dirty="0">
-                <a:solidFill>
-                  <a:srgbClr val="10161F"/>
+              <a:rPr lang="en-US" sz="800" dirty="0">
+                <a:solidFill>
+                  <a:srgbClr val="718096"/>
                 </a:solidFill>
                 <a:latin typeface="Pretendard" pitchFamily="34" charset="0"/>
                 <a:ea typeface="Pretendard" pitchFamily="34" charset="-122"/>
                 <a:cs typeface="Pretendard" pitchFamily="34" charset="-120"/>
               </a:rPr>
-              <a:t>승강기 정보 확인 필요</a:t>
-            </a:r>
-            <a:endParaRPr lang="en-US" sz="1250" dirty="0"/>
-          </a:p>
-        </p:txBody>
-      </p:sp>
-      <p:sp>
-        <p:nvSpPr>
-          <p:cNvPr id="15" name="Text 13"/>
-          <p:cNvSpPr/>
-          <p:nvPr/>
-        </p:nvSpPr>
-        <p:spPr>
-          <a:xfrm>
-            <a:off x="4566818" y="2377440"/>
-            <a:ext cx="3058058" cy="2606040"/>
-          </a:xfrm>
-          <a:prstGeom prst="rect">
-            <a:avLst/>
-          </a:prstGeom>
-          <a:noFill/>
-          <a:ln/>
-        </p:spPr>
-        <p:txBody>
-          <a:bodyPr wrap="square" lIns="0" tIns="0" rIns="0" bIns="0" rtlCol="0" anchor="t">
-            <a:normAutofit/>
-          </a:bodyPr>
-          <a:lstStyle/>
-          <a:p>
-            <a:pPr marL="342900" indent="-342900">
-              <a:lnSpc>
-                <a:spcPct val="125000"/>
-              </a:lnSpc>
-              <a:buSzPct val="100000"/>
-              <a:buChar char="•"/>
-            </a:pPr>
-            <a:r>
-              <a:rPr lang="en-US" sz="1100" dirty="0">
-                <a:solidFill>
-                  <a:srgbClr val="10161F"/>
-                </a:solidFill>
-                <a:latin typeface="Pretendard" pitchFamily="34" charset="0"/>
-                <a:ea typeface="Pretendard" pitchFamily="34" charset="-122"/>
-                <a:cs typeface="Pretendard" pitchFamily="34" charset="-120"/>
-              </a:rPr>
-              <a:t>정기검사 이력, 냉난방 설비 상태 확인 필요</a:t>
-            </a:r>
-            <a:endParaRPr lang="en-US" sz="1100" dirty="0"/>
-          </a:p>
-        </p:txBody>
-      </p:sp>
-      <p:sp>
-        <p:nvSpPr>
-          <p:cNvPr id="16" name="Shape 14"/>
-          <p:cNvSpPr/>
-          <p:nvPr/>
-        </p:nvSpPr>
-        <p:spPr>
-          <a:xfrm>
-            <a:off x="8109509" y="1417320"/>
-            <a:ext cx="3515258" cy="3657600"/>
-          </a:xfrm>
-          <a:prstGeom prst="roundRect">
-            <a:avLst>
-              <a:gd name="adj" fmla="val 1561"/>
-            </a:avLst>
-          </a:prstGeom>
-          <a:solidFill>
-            <a:srgbClr val="F7FAFC"/>
-          </a:solidFill>
-          <a:ln w="6350">
-            <a:solidFill>
-              <a:srgbClr val="CBD5E0"/>
-            </a:solidFill>
-            <a:prstDash val="solid"/>
-          </a:ln>
-        </p:spPr>
-      </p:sp>
-      <p:sp>
-        <p:nvSpPr>
-          <p:cNvPr id="17" name="Shape 15"/>
-          <p:cNvSpPr/>
-          <p:nvPr/>
-        </p:nvSpPr>
-        <p:spPr>
-          <a:xfrm>
-            <a:off x="8109509" y="1417320"/>
-            <a:ext cx="3515258" cy="45720"/>
-          </a:xfrm>
-          <a:prstGeom prst="rect">
-            <a:avLst/>
-          </a:prstGeom>
-          <a:solidFill>
-            <a:srgbClr val="B98A2E"/>
-          </a:solidFill>
-          <a:ln/>
-        </p:spPr>
-      </p:sp>
-      <p:sp>
-        <p:nvSpPr>
-          <p:cNvPr id="18" name="Text 16"/>
-          <p:cNvSpPr/>
-          <p:nvPr/>
-        </p:nvSpPr>
-        <p:spPr>
-          <a:xfrm>
-            <a:off x="8338109" y="1618488"/>
-            <a:ext cx="3058058" cy="292608"/>
-          </a:xfrm>
-          <a:prstGeom prst="rect">
-            <a:avLst/>
-          </a:prstGeom>
-          <a:noFill/>
-          <a:ln/>
-        </p:spPr>
-        <p:txBody>
-          <a:bodyPr wrap="square" lIns="0" tIns="0" rIns="0" bIns="0" rtlCol="0" anchor="ctr"/>
-          <a:lstStyle/>
-          <a:p>
-            <a:pPr indent="0" marL="0">
-              <a:buNone/>
-            </a:pPr>
-            <a:r>
-              <a:rPr lang="en-US" sz="1350" b="1" dirty="0">
-                <a:solidFill>
-                  <a:srgbClr val="977024"/>
-                </a:solidFill>
-                <a:latin typeface="Pretendard" pitchFamily="34" charset="0"/>
-                <a:ea typeface="Pretendard" pitchFamily="34" charset="-122"/>
-                <a:cs typeface="Pretendard" pitchFamily="34" charset="-120"/>
-              </a:rPr>
-              <a:t>임차인 이탈 위험</a:t>
-            </a:r>
-            <a:endParaRPr lang="en-US" sz="1350" dirty="0"/>
-          </a:p>
-        </p:txBody>
-      </p:sp>
-      <p:sp>
-        <p:nvSpPr>
-          <p:cNvPr id="19" name="Text 17"/>
-          <p:cNvSpPr/>
-          <p:nvPr/>
-        </p:nvSpPr>
-        <p:spPr>
-          <a:xfrm>
-            <a:off x="8338109" y="1947672"/>
-            <a:ext cx="3058058" cy="365760"/>
-          </a:xfrm>
-          <a:prstGeom prst="rect">
-            <a:avLst/>
-          </a:prstGeom>
-          <a:noFill/>
-          <a:ln/>
-        </p:spPr>
-        <p:txBody>
-          <a:bodyPr wrap="square" lIns="0" tIns="0" rIns="0" bIns="0" rtlCol="0" anchor="ctr">
-            <a:normAutofit/>
-          </a:bodyPr>
-          <a:lstStyle/>
-          <a:p>
-            <a:pPr indent="0" marL="0">
-              <a:buNone/>
-            </a:pPr>
-            <a:r>
-              <a:rPr lang="en-US" sz="1250" b="1" dirty="0">
-                <a:solidFill>
-                  <a:srgbClr val="10161F"/>
-                </a:solidFill>
-                <a:latin typeface="Pretendard" pitchFamily="34" charset="0"/>
-                <a:ea typeface="Pretendard" pitchFamily="34" charset="-122"/>
-                <a:cs typeface="Pretendard" pitchFamily="34" charset="-120"/>
-              </a:rPr>
-              <a:t>임대차 계약 현황 LOI 접수 후 열람</a:t>
-            </a:r>
-            <a:endParaRPr lang="en-US" sz="1250" dirty="0"/>
-          </a:p>
-        </p:txBody>
-      </p:sp>
-      <p:sp>
-        <p:nvSpPr>
-          <p:cNvPr id="20" name="Text 18"/>
-          <p:cNvSpPr/>
-          <p:nvPr/>
-        </p:nvSpPr>
-        <p:spPr>
-          <a:xfrm>
-            <a:off x="8338109" y="2377440"/>
-            <a:ext cx="3058058" cy="2606040"/>
-          </a:xfrm>
-          <a:prstGeom prst="rect">
-            <a:avLst/>
-          </a:prstGeom>
-          <a:noFill/>
-          <a:ln/>
-        </p:spPr>
-        <p:txBody>
-          <a:bodyPr wrap="square" lIns="0" tIns="0" rIns="0" bIns="0" rtlCol="0" anchor="t">
-            <a:normAutofit/>
-          </a:bodyPr>
-          <a:lstStyle/>
-          <a:p>
-            <a:pPr marL="342900" indent="-342900">
-              <a:lnSpc>
-                <a:spcPct val="125000"/>
-              </a:lnSpc>
-              <a:buSzPct val="100000"/>
-              <a:buChar char="•"/>
-            </a:pPr>
-            <a:r>
-              <a:rPr lang="en-US" sz="1100" dirty="0">
-                <a:solidFill>
-                  <a:srgbClr val="10161F"/>
-                </a:solidFill>
-                <a:latin typeface="Pretendard" pitchFamily="34" charset="0"/>
-                <a:ea typeface="Pretendard" pitchFamily="34" charset="-122"/>
-                <a:cs typeface="Pretendard" pitchFamily="34" charset="-120"/>
-              </a:rPr>
-              <a:t>잔여 계약기간(WALE), 임차인 신용도 확인 필요</a:t>
-            </a:r>
-            <a:endParaRPr lang="en-US" sz="1100" dirty="0"/>
-          </a:p>
-        </p:txBody>
-      </p:sp>
-      <p:sp>
-        <p:nvSpPr>
-          <p:cNvPr id="21" name="Shape 19"/>
-          <p:cNvSpPr/>
-          <p:nvPr/>
-        </p:nvSpPr>
-        <p:spPr>
-          <a:xfrm>
-            <a:off x="566928" y="5193792"/>
-            <a:ext cx="11057839" cy="621792"/>
-          </a:xfrm>
-          <a:prstGeom prst="roundRect">
-            <a:avLst>
-              <a:gd name="adj" fmla="val 8824"/>
-            </a:avLst>
-          </a:prstGeom>
-          <a:solidFill>
-            <a:srgbClr val="F7FAFC"/>
-          </a:solidFill>
-          <a:ln w="6350">
-            <a:solidFill>
-              <a:srgbClr val="CBD5E0"/>
-            </a:solidFill>
-            <a:prstDash val="solid"/>
-          </a:ln>
-        </p:spPr>
-      </p:sp>
-      <p:sp>
-        <p:nvSpPr>
-          <p:cNvPr id="22" name="Text 20"/>
-          <p:cNvSpPr/>
-          <p:nvPr/>
-        </p:nvSpPr>
-        <p:spPr>
-          <a:xfrm>
-            <a:off x="795528" y="5193792"/>
-            <a:ext cx="10600639" cy="621792"/>
-          </a:xfrm>
-          <a:prstGeom prst="rect">
-            <a:avLst/>
-          </a:prstGeom>
-          <a:noFill/>
-          <a:ln/>
-        </p:spPr>
-        <p:txBody>
-          <a:bodyPr wrap="square" lIns="0" tIns="0" rIns="0" bIns="0" rtlCol="0" anchor="ctr"/>
-          <a:lstStyle/>
-          <a:p>
-            <a:pPr indent="0" marL="0">
-              <a:buNone/>
-            </a:pPr>
-            <a:r>
-              <a:rPr lang="en-US" sz="1100" dirty="0">
-                <a:solidFill>
-                  <a:srgbClr val="10161F"/>
-                </a:solidFill>
-                <a:latin typeface="Pretendard" pitchFamily="34" charset="0"/>
-                <a:ea typeface="Pretendard" pitchFamily="34" charset="-122"/>
-                <a:cs typeface="Pretendard" pitchFamily="34" charset="-120"/>
-              </a:rPr>
-              <a:t>※ 본 리스크 체크는 공부 및 브로커 확인 기반이며, 매수 전 전문 실사팀(변호사/건축사)을 통한 정밀 실사가 필요합니다.</a:t>
-            </a:r>
-            <a:endParaRPr lang="en-US" sz="1100" dirty="0"/>
-          </a:p>
-        </p:txBody>
-      </p:sp>
-      <p:sp>
-        <p:nvSpPr>
-          <p:cNvPr id="23" name="Text 21"/>
-          <p:cNvSpPr/>
-          <p:nvPr/>
-        </p:nvSpPr>
-        <p:spPr>
-          <a:xfrm>
-            <a:off x="566928" y="6382512"/>
-            <a:ext cx="7315200" cy="219456"/>
-          </a:xfrm>
-          <a:prstGeom prst="rect">
-            <a:avLst/>
-          </a:prstGeom>
-          <a:noFill/>
-          <a:ln/>
-        </p:spPr>
-        <p:txBody>
-          <a:bodyPr wrap="square" lIns="0" tIns="0" rIns="0" bIns="0" rtlCol="0" anchor="ctr"/>
-          <a:lstStyle/>
-          <a:p>
-            <a:pPr indent="0" marL="0">
-              <a:buNone/>
-            </a:pPr>
-            <a:r>
-              <a:rPr lang="en-US" sz="800" dirty="0">
-                <a:solidFill>
-                  <a:srgbClr val="718096"/>
-                </a:solidFill>
-                <a:latin typeface="Pretendard" pitchFamily="34" charset="0"/>
-                <a:ea typeface="Pretendard" pitchFamily="34" charset="-122"/>
-                <a:cs typeface="Pretendard" pitchFamily="34" charset="-120"/>
-              </a:rPr>
               <a:t>크리딜   |   </a:t>
             </a:r>
             <a:endParaRPr lang="en-US" sz="800" dirty="0"/>
@@ -8673,7 +8645,7 @@
       </p:sp>
       <p:sp>
         <p:nvSpPr>
-          <p:cNvPr id="24" name="Text 22"/>
+          <p:cNvPr id="14" name="Text 12"/>
           <p:cNvSpPr/>
           <p:nvPr/>
         </p:nvSpPr>
@@ -8721,13 +8693,6 @@
 <file path=ppt/slides/slide8.xml><?xml version="1.0" encoding="utf-8"?>
 <p:sld xmlns:a="http://schemas.openxmlformats.org/drawingml/2006/main" xmlns:r="http://schemas.openxmlformats.org/officeDocument/2006/relationships" xmlns:p="http://schemas.openxmlformats.org/presentationml/2006/main">
   <p:cSld name="Slide 8">
-    <p:bg>
-      <p:bgPr>
-        <a:solidFill>
-          <a:srgbClr val="FFFFFF"/>
-        </a:solidFill>
-      </p:bgPr>
-    </p:bg>
     <p:spTree>
       <p:nvGrpSpPr>
         <p:cNvPr id="1" name=""/>
@@ -8834,7 +8799,7 @@
                 <a:ea typeface="Arial" pitchFamily="34" charset="-122"/>
                 <a:cs typeface="Arial" pitchFamily="34" charset="-120"/>
               </a:rPr>
-              <a:t>Thesis</a:t>
+              <a:t>Checklist</a:t>
             </a:r>
             <a:endParaRPr lang="en-US" sz="950" dirty="0"/>
           </a:p>
@@ -8873,7 +8838,7 @@
                 <a:ea typeface="Pretendard" pitchFamily="34" charset="-122"/>
                 <a:cs typeface="Pretendard" pitchFamily="34" charset="-120"/>
               </a:rPr>
-              <a:t>왜 지금 이 매물을 사야 하는가</a:t>
+              <a:t>섹션 상세</a:t>
             </a:r>
             <a:endParaRPr lang="en-US" sz="2300" dirty="0"/>
           </a:p>
@@ -8881,30 +8846,31 @@
       </p:sp>
       <p:sp>
         <p:nvSpPr>
-          <p:cNvPr id="6" name="Shape 4"/>
-          <p:cNvSpPr/>
-          <p:nvPr/>
-        </p:nvSpPr>
-        <p:spPr>
-          <a:xfrm>
-            <a:off x="566928" y="4983480"/>
-            <a:ext cx="11057839" cy="804672"/>
-          </a:xfrm>
-          <a:prstGeom prst="roundRect">
-            <a:avLst>
-              <a:gd name="adj" fmla="val 6818"/>
-            </a:avLst>
-          </a:prstGeom>
-          <a:solidFill>
-            <a:srgbClr val="F3EBDA"/>
-          </a:solidFill>
-          <a:ln w="10160">
-            <a:solidFill>
-              <a:srgbClr val="D9B668"/>
-            </a:solidFill>
-            <a:prstDash val="solid"/>
-          </a:ln>
-        </p:spPr>
+          <p:cNvPr id="6" name="Text 4"/>
+          <p:cNvSpPr/>
+          <p:nvPr/>
+        </p:nvSpPr>
+        <p:spPr>
+          <a:xfrm>
+            <a:off x="566928" y="1517904"/>
+            <a:ext cx="6492240" cy="274320"/>
+          </a:xfrm>
+          <a:prstGeom prst="rect">
+            <a:avLst/>
+          </a:prstGeom>
+          <a:noFill/>
+          <a:ln/>
+        </p:spPr>
+        <p:txBody>
+          <a:bodyPr wrap="square" rtlCol="0" anchor="ctr"/>
+          <a:lstStyle/>
+          <a:p>
+            <a:pPr indent="0" marL="0">
+              <a:buNone/>
+            </a:pPr>
+            <a:endParaRPr lang="en-US" sz="1400" dirty="0"/>
+          </a:p>
+        </p:txBody>
       </p:sp>
       <p:sp>
         <p:nvSpPr>
@@ -8914,121 +8880,68 @@
         </p:nvSpPr>
         <p:spPr>
           <a:xfrm>
-            <a:off x="749808" y="5093208"/>
-            <a:ext cx="1691640" cy="256032"/>
-          </a:xfrm>
-          <a:prstGeom prst="rect">
-            <a:avLst/>
-          </a:prstGeom>
-          <a:noFill/>
-          <a:ln/>
-        </p:spPr>
-        <p:txBody>
-          <a:bodyPr wrap="square" lIns="0" tIns="0" rIns="0" bIns="0" rtlCol="0" anchor="ctr"/>
+            <a:off x="566928" y="1874520"/>
+            <a:ext cx="6492240" cy="182880"/>
+          </a:xfrm>
+          <a:prstGeom prst="rect">
+            <a:avLst/>
+          </a:prstGeom>
+          <a:noFill/>
+          <a:ln/>
+        </p:spPr>
+        <p:txBody>
+          <a:bodyPr wrap="square" rtlCol="0" anchor="ctr"/>
           <a:lstStyle/>
           <a:p>
             <a:pPr indent="0" marL="0">
               <a:buNone/>
             </a:pPr>
-            <a:r>
-              <a:rPr lang="en-US" sz="1050" b="1" dirty="0">
-                <a:solidFill>
-                  <a:srgbClr val="977024"/>
+            <a:endParaRPr lang="en-US" sz="900" dirty="0"/>
+          </a:p>
+        </p:txBody>
+      </p:sp>
+      <p:sp>
+        <p:nvSpPr>
+          <p:cNvPr id="8" name="Text 6"/>
+          <p:cNvSpPr/>
+          <p:nvPr/>
+        </p:nvSpPr>
+        <p:spPr>
+          <a:xfrm>
+            <a:off x="566928" y="6382512"/>
+            <a:ext cx="7315200" cy="219456"/>
+          </a:xfrm>
+          <a:prstGeom prst="rect">
+            <a:avLst/>
+          </a:prstGeom>
+          <a:noFill/>
+          <a:ln/>
+        </p:spPr>
+        <p:txBody>
+          <a:bodyPr wrap="square" lIns="0" tIns="0" rIns="0" bIns="0" rtlCol="0" anchor="ctr"/>
+          <a:lstStyle/>
+          <a:p>
+            <a:pPr indent="0" marL="0">
+              <a:buNone/>
+            </a:pPr>
+            <a:r>
+              <a:rPr lang="en-US" sz="800" dirty="0">
+                <a:solidFill>
+                  <a:srgbClr val="718096"/>
                 </a:solidFill>
                 <a:latin typeface="Pretendard" pitchFamily="34" charset="0"/>
                 <a:ea typeface="Pretendard" pitchFamily="34" charset="-122"/>
                 <a:cs typeface="Pretendard" pitchFamily="34" charset="-120"/>
               </a:rPr>
-              <a:t>종합 가치 제안</a:t>
-            </a:r>
-            <a:endParaRPr lang="en-US" sz="1050" dirty="0"/>
-          </a:p>
-        </p:txBody>
-      </p:sp>
-      <p:sp>
-        <p:nvSpPr>
-          <p:cNvPr id="8" name="Text 6"/>
-          <p:cNvSpPr/>
-          <p:nvPr/>
-        </p:nvSpPr>
-        <p:spPr>
-          <a:xfrm>
-            <a:off x="2487168" y="5056632"/>
-            <a:ext cx="8954719" cy="658368"/>
-          </a:xfrm>
-          <a:prstGeom prst="rect">
-            <a:avLst/>
-          </a:prstGeom>
-          <a:noFill/>
-          <a:ln/>
-        </p:spPr>
-        <p:txBody>
-          <a:bodyPr wrap="square" lIns="0" tIns="0" rIns="0" bIns="0" rtlCol="0" anchor="ctr"/>
-          <a:lstStyle/>
-          <a:p>
-            <a:pPr indent="0" marL="0">
-              <a:lnSpc>
-                <a:spcPct val="125000"/>
-              </a:lnSpc>
-              <a:buNone/>
-            </a:pPr>
-            <a:r>
-              <a:rPr lang="en-US" sz="1100" dirty="0">
-                <a:solidFill>
-                  <a:srgbClr val="10161F"/>
-                </a:solidFill>
-                <a:latin typeface="Pretendard" pitchFamily="34" charset="0"/>
-                <a:ea typeface="Pretendard" pitchFamily="34" charset="-122"/>
-                <a:cs typeface="Pretendard" pitchFamily="34" charset="-120"/>
-              </a:rPr>
-              <a:t>{"ok":true,"mocked":true,"extractedFields":{"area_signal":"역삼","asset_type":"오피스빌딩","price_band":"300억","size_signal":"3000평(약 9917.4㎡)"},"extractedFacts":{"region":"역삼","exactAddressCandidate":"역삼동 742-1","assetType":"오피스빌딩","priceText":"300억","sizeText":"3000평(약 9917.4㎡)","currentUse":"오피스","currentUseSignal":"근린생활시설","leaseSignal":"임대중","vacancySignal":"공실없음","tenantNames":["쿠팡","네이버"],"unitRentTexts":["301호: 1500만"],"sellerMotivationText":"자산 효율화","brokerNotes":["초역세권 매물"]},"detectedSensitiveFields":["exact_address","tenant_name"],"ambiguousFields":[],"warnings":[],"areaSignal":"역삼","assetType":"오피스빌딩","priceBand":"300억","sizeSignal":"3000평(약 9917.4㎡)","dealType":"매각","buildingName":"역삼 센트럴타워","exactAddress":"역삼동 742-1","totalFloorArea":9917.3,"buildYear":2015,"currentUseSignal":"근린생활시설","vacancySignal":"공실 없음","fitSummary":"초역세권 근생 빌딩으로 시행/사옥 매입에 최적화","cautionSummary":"주요 임차인 만기 조율 필요","hiddenFields":["exact_address","seller_motivation"],"confidence":{"areaSignal":"confirmed","assetType":"confirmed","priceBand":"ai_hypothesis","fitSummary":"ai_hypothesis"},"missingData":["sizeSignal"],"boundaryNote":"본 자료는 실거래 통계 기반 참고치입니다.","buyerType":"법인 사옥형","budgetRange":{"min":50,"max":80,"display":"50억~80억"},"preferredRegions":["강남","성수"],"assetTypes":["꼬마빌딩","사옥용"],"purchasePurpose":"사옥용 매입","mustHave":["초역세권","주차"],"niceToHave":["테라스","루프탑"],"riskTolerance":"medium","financingNote":"자본금 50% 준비","missingQuestions":["구체적인 입주 시기가 언제인가요?","선호하는 수익률이 있나요?"],"privacyNotes":["연락처 비공개"],"fitReasons":["매수자 예산(50-80억)에 부합하는 매물입니다.","요청하신 성수/강남 권역에 해당합니다."],"cautionReasons":["요청한 용도와 달리 명도 협의가 다소 필요합니다."],"recommendedNextAction":"현장 답사 제안","kakaoMessage":"안녕하세요! 요청하신 조건에 부합하는 추천 매물이 있어 안내해 드립니다. 확인해보시고 피드백 부탁드립니다.","title":"강남 역삼역 초역세권 오피스 사옥용 빌딩 매각","shortSummary":"역삼역 도보 5분 거리의 준신축급 대형 오피스빌딩입니다.","dealPoints":["초역세권","사옥 최적"],"cautionPoints":["명도 조율 필요"],"hiddenInfoNotice":["보증금 및 지번은 인가 후 확인 가능"],"gateMessage":"G1 등급 등록이 필요합니다.","kakaoText":"강남 역삼역 오피스 빌딩 매각 안내입니다.","exactUnitCandidate":"101호","floor":"1층","areaSqmText":"150㎡","spaceType":"office","depositText":"5000만","monthlyRentText":"400만","maintenanceFeeText":"50만","availableFromText":"즉시입주","leaseTermMonthsText":"24","incentivesText":"렌트프리 2개월","restrictions":[],"landlordIdentity":"김성수","currentTenant":"스타트업","vacancyReason":"이전 확장","rentNegotiation":"협의 가능","region":"성수동","areaSqm":150,"deposit":5000,"monthlyRent":400,"maintenanceFee":50,"availableFrom":"즉시입주","leaseTermMonths":24,"incentives":{"rentFreeMonths":2,"interiorSupport":"일부 인테리어 지원","freeRentDetail":"렌트프리 2개월 지원"},"shortSummaryLease":"성수역 도보 5분 거리 1층 리테일 상가 매물입니다."}</a:t>
-            </a:r>
-            <a:endParaRPr lang="en-US" sz="1100" dirty="0"/>
+              <a:t>크리딜   |   </a:t>
+            </a:r>
+            <a:endParaRPr lang="en-US" sz="800" dirty="0"/>
           </a:p>
         </p:txBody>
       </p:sp>
       <p:sp>
         <p:nvSpPr>
           <p:cNvPr id="9" name="Text 7"/>
-          <p:cNvSpPr/>
-          <p:nvPr/>
-        </p:nvSpPr>
-        <p:spPr>
-          <a:xfrm>
-            <a:off x="566928" y="6382512"/>
-            <a:ext cx="7315200" cy="219456"/>
-          </a:xfrm>
-          <a:prstGeom prst="rect">
-            <a:avLst/>
-          </a:prstGeom>
-          <a:noFill/>
-          <a:ln/>
-        </p:spPr>
-        <p:txBody>
-          <a:bodyPr wrap="square" lIns="0" tIns="0" rIns="0" bIns="0" rtlCol="0" anchor="ctr"/>
-          <a:lstStyle/>
-          <a:p>
-            <a:pPr indent="0" marL="0">
-              <a:buNone/>
-            </a:pPr>
-            <a:r>
-              <a:rPr lang="en-US" sz="800" dirty="0">
-                <a:solidFill>
-                  <a:srgbClr val="718096"/>
-                </a:solidFill>
-                <a:latin typeface="Pretendard" pitchFamily="34" charset="0"/>
-                <a:ea typeface="Pretendard" pitchFamily="34" charset="-122"/>
-                <a:cs typeface="Pretendard" pitchFamily="34" charset="-120"/>
-              </a:rPr>
-              <a:t>크리딜   |   </a:t>
-            </a:r>
-            <a:endParaRPr lang="en-US" sz="800" dirty="0"/>
-          </a:p>
-        </p:txBody>
-      </p:sp>
-      <p:sp>
-        <p:nvSpPr>
-          <p:cNvPr id="10" name="Text 8"/>
           <p:cNvSpPr/>
           <p:nvPr/>
         </p:nvSpPr>
@@ -9189,7 +9102,7 @@
                 <a:ea typeface="Arial" pitchFamily="34" charset="-122"/>
                 <a:cs typeface="Arial" pitchFamily="34" charset="-120"/>
               </a:rPr>
-              <a:t>Process</a:t>
+              <a:t>Thesis</a:t>
             </a:r>
             <a:endParaRPr lang="en-US" sz="950" dirty="0"/>
           </a:p>
@@ -9228,7 +9141,7 @@
                 <a:ea typeface="Pretendard" pitchFamily="34" charset="-122"/>
                 <a:cs typeface="Pretendard" pitchFamily="34" charset="-120"/>
               </a:rPr>
-              <a:t>검토 후 다음 단계는 무엇인가</a:t>
+              <a:t>왜 지금 이 매물을 사야 하는가</a:t>
             </a:r>
             <a:endParaRPr lang="en-US" sz="2300" dirty="0"/>
           </a:p>
@@ -9242,17 +9155,160 @@
         </p:nvSpPr>
         <p:spPr>
           <a:xfrm>
-            <a:off x="566928" y="1572768"/>
-            <a:ext cx="2490140" cy="3200400"/>
+            <a:off x="566928" y="1325880"/>
+            <a:ext cx="5368900" cy="2560320"/>
           </a:xfrm>
           <a:prstGeom prst="roundRect">
             <a:avLst>
-              <a:gd name="adj" fmla="val 2203"/>
+              <a:gd name="adj" fmla="val 2857"/>
             </a:avLst>
           </a:prstGeom>
           <a:solidFill>
             <a:srgbClr val="F7FAFC"/>
           </a:solidFill>
+          <a:ln w="10160">
+            <a:solidFill>
+              <a:srgbClr val="CBD5E0"/>
+            </a:solidFill>
+            <a:prstDash val="solid"/>
+          </a:ln>
+        </p:spPr>
+      </p:sp>
+      <p:sp>
+        <p:nvSpPr>
+          <p:cNvPr id="7" name="Shape 5"/>
+          <p:cNvSpPr/>
+          <p:nvPr/>
+        </p:nvSpPr>
+        <p:spPr>
+          <a:xfrm>
+            <a:off x="566928" y="1325880"/>
+            <a:ext cx="5368900" cy="54864"/>
+          </a:xfrm>
+          <a:prstGeom prst="rect">
+            <a:avLst/>
+          </a:prstGeom>
+          <a:solidFill>
+            <a:srgbClr val="B98A2E"/>
+          </a:solidFill>
+          <a:ln/>
+        </p:spPr>
+      </p:sp>
+      <p:sp>
+        <p:nvSpPr>
+          <p:cNvPr id="8" name="Shape 6"/>
+          <p:cNvSpPr/>
+          <p:nvPr/>
+        </p:nvSpPr>
+        <p:spPr>
+          <a:xfrm>
+            <a:off x="795528" y="1600200"/>
+            <a:ext cx="475488" cy="292608"/>
+          </a:xfrm>
+          <a:prstGeom prst="roundRect">
+            <a:avLst>
+              <a:gd name="adj" fmla="val 12500"/>
+            </a:avLst>
+          </a:prstGeom>
+          <a:solidFill>
+            <a:srgbClr val="D9B668"/>
+          </a:solidFill>
+          <a:ln/>
+        </p:spPr>
+      </p:sp>
+      <p:sp>
+        <p:nvSpPr>
+          <p:cNvPr id="9" name="Text 7"/>
+          <p:cNvSpPr/>
+          <p:nvPr/>
+        </p:nvSpPr>
+        <p:spPr>
+          <a:xfrm>
+            <a:off x="795528" y="1600200"/>
+            <a:ext cx="475488" cy="292608"/>
+          </a:xfrm>
+          <a:prstGeom prst="rect">
+            <a:avLst/>
+          </a:prstGeom>
+          <a:noFill/>
+          <a:ln/>
+        </p:spPr>
+        <p:txBody>
+          <a:bodyPr wrap="square" lIns="0" tIns="0" rIns="0" bIns="0" rtlCol="0" anchor="ctr"/>
+          <a:lstStyle/>
+          <a:p>
+            <a:pPr algn="ctr" indent="0" marL="0">
+              <a:buNone/>
+            </a:pPr>
+            <a:r>
+              <a:rPr lang="en-US" sz="1100" b="1" dirty="0">
+                <a:solidFill>
+                  <a:srgbClr val="977024"/>
+                </a:solidFill>
+                <a:latin typeface="Arial" pitchFamily="34" charset="0"/>
+                <a:ea typeface="Arial" pitchFamily="34" charset="-122"/>
+                <a:cs typeface="Arial" pitchFamily="34" charset="-120"/>
+              </a:rPr>
+              <a:t>01</a:t>
+            </a:r>
+            <a:endParaRPr lang="en-US" sz="1100" dirty="0"/>
+          </a:p>
+        </p:txBody>
+      </p:sp>
+      <p:sp>
+        <p:nvSpPr>
+          <p:cNvPr id="10" name="Text 8"/>
+          <p:cNvSpPr/>
+          <p:nvPr/>
+        </p:nvSpPr>
+        <p:spPr>
+          <a:xfrm>
+            <a:off x="795528" y="2039112"/>
+            <a:ext cx="4911700" cy="365760"/>
+          </a:xfrm>
+          <a:prstGeom prst="rect">
+            <a:avLst/>
+          </a:prstGeom>
+          <a:noFill/>
+          <a:ln/>
+        </p:spPr>
+        <p:txBody>
+          <a:bodyPr wrap="square" lIns="0" tIns="0" rIns="0" bIns="0" rtlCol="0" anchor="t"/>
+          <a:lstStyle/>
+          <a:p>
+            <a:pPr indent="0" marL="0">
+              <a:buNone/>
+            </a:pPr>
+            <a:r>
+              <a:rPr lang="en-US" sz="1500" b="1" dirty="0">
+                <a:solidFill>
+                  <a:srgbClr val="10161F"/>
+                </a:solidFill>
+                <a:latin typeface="Pretendard" pitchFamily="34" charset="0"/>
+                <a:ea typeface="Pretendard" pitchFamily="34" charset="-122"/>
+                <a:cs typeface="Pretendard" pitchFamily="34" charset="-120"/>
+              </a:rPr>
+              <a:t>확실한 월 현금흐름</a:t>
+            </a:r>
+            <a:endParaRPr lang="en-US" sz="1500" dirty="0"/>
+          </a:p>
+        </p:txBody>
+      </p:sp>
+      <p:sp>
+        <p:nvSpPr>
+          <p:cNvPr id="11" name="Shape 9"/>
+          <p:cNvSpPr/>
+          <p:nvPr/>
+        </p:nvSpPr>
+        <p:spPr>
+          <a:xfrm>
+            <a:off x="795528" y="2468880"/>
+            <a:ext cx="4911700" cy="0"/>
+          </a:xfrm>
+          <a:prstGeom prst="line">
+            <a:avLst/>
+          </a:prstGeom>
+          <a:noFill/>
           <a:ln w="6350">
             <a:solidFill>
               <a:srgbClr val="CBD5E0"/>
@@ -9263,16 +9319,85 @@
       </p:sp>
       <p:sp>
         <p:nvSpPr>
-          <p:cNvPr id="7" name="Shape 5"/>
-          <p:cNvSpPr/>
-          <p:nvPr/>
-        </p:nvSpPr>
-        <p:spPr>
-          <a:xfrm>
-            <a:off x="786384" y="1792224"/>
-            <a:ext cx="438912" cy="438912"/>
-          </a:xfrm>
-          <a:prstGeom prst="ellipse">
+          <p:cNvPr id="12" name="Text 10"/>
+          <p:cNvSpPr/>
+          <p:nvPr/>
+        </p:nvSpPr>
+        <p:spPr>
+          <a:xfrm>
+            <a:off x="795528" y="2624328"/>
+            <a:ext cx="4911700" cy="1051560"/>
+          </a:xfrm>
+          <a:prstGeom prst="rect">
+            <a:avLst/>
+          </a:prstGeom>
+          <a:noFill/>
+          <a:ln/>
+        </p:spPr>
+        <p:txBody>
+          <a:bodyPr wrap="square" lIns="0" tIns="0" rIns="0" bIns="0" rtlCol="0" anchor="t"/>
+          <a:lstStyle/>
+          <a:p>
+            <a:pPr indent="0" marL="0">
+              <a:lnSpc>
+                <a:spcPct val="130000"/>
+              </a:lnSpc>
+              <a:buNone/>
+            </a:pPr>
+            <a:r>
+              <a:rPr lang="en-US" sz="1200" dirty="0">
+                <a:solidFill>
+                  <a:srgbClr val="10161F"/>
+                </a:solidFill>
+                <a:latin typeface="Pretendard" pitchFamily="34" charset="0"/>
+                <a:ea typeface="Pretendard" pitchFamily="34" charset="-122"/>
+                <a:cs typeface="Pretendard" pitchFamily="34" charset="-120"/>
+              </a:rPr>
+              <a:t>임대차 현황 및 공실률을 반영한 순영업소득(NOI) 분석은 수익분석 섹션을 참조하시기 바랍니다.</a:t>
+            </a:r>
+            <a:endParaRPr lang="en-US" sz="1200" dirty="0"/>
+          </a:p>
+        </p:txBody>
+      </p:sp>
+      <p:sp>
+        <p:nvSpPr>
+          <p:cNvPr id="13" name="Shape 11"/>
+          <p:cNvSpPr/>
+          <p:nvPr/>
+        </p:nvSpPr>
+        <p:spPr>
+          <a:xfrm>
+            <a:off x="6255868" y="1325880"/>
+            <a:ext cx="5368900" cy="2560320"/>
+          </a:xfrm>
+          <a:prstGeom prst="roundRect">
+            <a:avLst>
+              <a:gd name="adj" fmla="val 2857"/>
+            </a:avLst>
+          </a:prstGeom>
+          <a:solidFill>
+            <a:srgbClr val="F7FAFC"/>
+          </a:solidFill>
+          <a:ln w="10160">
+            <a:solidFill>
+              <a:srgbClr val="CBD5E0"/>
+            </a:solidFill>
+            <a:prstDash val="solid"/>
+          </a:ln>
+        </p:spPr>
+      </p:sp>
+      <p:sp>
+        <p:nvSpPr>
+          <p:cNvPr id="14" name="Shape 12"/>
+          <p:cNvSpPr/>
+          <p:nvPr/>
+        </p:nvSpPr>
+        <p:spPr>
+          <a:xfrm>
+            <a:off x="6255868" y="1325880"/>
+            <a:ext cx="5368900" cy="54864"/>
+          </a:xfrm>
+          <a:prstGeom prst="rect">
             <a:avLst/>
           </a:prstGeom>
           <a:solidFill>
@@ -9283,14 +9408,36 @@
       </p:sp>
       <p:sp>
         <p:nvSpPr>
-          <p:cNvPr id="8" name="Text 6"/>
-          <p:cNvSpPr/>
-          <p:nvPr/>
-        </p:nvSpPr>
-        <p:spPr>
-          <a:xfrm>
-            <a:off x="786384" y="1792224"/>
-            <a:ext cx="438912" cy="438912"/>
+          <p:cNvPr id="15" name="Shape 13"/>
+          <p:cNvSpPr/>
+          <p:nvPr/>
+        </p:nvSpPr>
+        <p:spPr>
+          <a:xfrm>
+            <a:off x="6484468" y="1600200"/>
+            <a:ext cx="475488" cy="292608"/>
+          </a:xfrm>
+          <a:prstGeom prst="roundRect">
+            <a:avLst>
+              <a:gd name="adj" fmla="val 12500"/>
+            </a:avLst>
+          </a:prstGeom>
+          <a:solidFill>
+            <a:srgbClr val="D9B668"/>
+          </a:solidFill>
+          <a:ln/>
+        </p:spPr>
+      </p:sp>
+      <p:sp>
+        <p:nvSpPr>
+          <p:cNvPr id="16" name="Text 14"/>
+          <p:cNvSpPr/>
+          <p:nvPr/>
+        </p:nvSpPr>
+        <p:spPr>
+          <a:xfrm>
+            <a:off x="6484468" y="1600200"/>
+            <a:ext cx="475488" cy="292608"/>
           </a:xfrm>
           <a:prstGeom prst="rect">
             <a:avLst/>
@@ -9306,46 +9453,46 @@
               <a:buNone/>
             </a:pPr>
             <a:r>
-              <a:rPr lang="en-US" sz="1400" b="1" dirty="0">
-                <a:solidFill>
-                  <a:srgbClr val="FFFFFF"/>
+              <a:rPr lang="en-US" sz="1100" b="1" dirty="0">
+                <a:solidFill>
+                  <a:srgbClr val="977024"/>
                 </a:solidFill>
                 <a:latin typeface="Arial" pitchFamily="34" charset="0"/>
                 <a:ea typeface="Arial" pitchFamily="34" charset="-122"/>
                 <a:cs typeface="Arial" pitchFamily="34" charset="-120"/>
               </a:rPr>
-              <a:t>01</a:t>
-            </a:r>
-            <a:endParaRPr lang="en-US" sz="1400" dirty="0"/>
-          </a:p>
-        </p:txBody>
-      </p:sp>
-      <p:sp>
-        <p:nvSpPr>
-          <p:cNvPr id="9" name="Text 7"/>
-          <p:cNvSpPr/>
-          <p:nvPr/>
-        </p:nvSpPr>
-        <p:spPr>
-          <a:xfrm>
-            <a:off x="786384" y="2304288"/>
-            <a:ext cx="2051228" cy="365760"/>
-          </a:xfrm>
-          <a:prstGeom prst="rect">
-            <a:avLst/>
-          </a:prstGeom>
-          <a:noFill/>
-          <a:ln/>
-        </p:spPr>
-        <p:txBody>
-          <a:bodyPr wrap="square" rtlCol="0" anchor="ctr"/>
+              <a:t>02</a:t>
+            </a:r>
+            <a:endParaRPr lang="en-US" sz="1100" dirty="0"/>
+          </a:p>
+        </p:txBody>
+      </p:sp>
+      <p:sp>
+        <p:nvSpPr>
+          <p:cNvPr id="17" name="Text 15"/>
+          <p:cNvSpPr/>
+          <p:nvPr/>
+        </p:nvSpPr>
+        <p:spPr>
+          <a:xfrm>
+            <a:off x="6484468" y="2039112"/>
+            <a:ext cx="4911700" cy="365760"/>
+          </a:xfrm>
+          <a:prstGeom prst="rect">
+            <a:avLst/>
+          </a:prstGeom>
+          <a:noFill/>
+          <a:ln/>
+        </p:spPr>
+        <p:txBody>
+          <a:bodyPr wrap="square" lIns="0" tIns="0" rIns="0" bIns="0" rtlCol="0" anchor="t"/>
           <a:lstStyle/>
           <a:p>
             <a:pPr indent="0" marL="0">
               <a:buNone/>
             </a:pPr>
             <a:r>
-              <a:rPr lang="en-US" sz="1600" b="1" dirty="0">
+              <a:rPr lang="en-US" sz="1500" b="1" dirty="0">
                 <a:solidFill>
                   <a:srgbClr val="10161F"/>
                 </a:solidFill>
@@ -9353,95 +9500,27 @@
                 <a:ea typeface="Pretendard" pitchFamily="34" charset="-122"/>
                 <a:cs typeface="Pretendard" pitchFamily="34" charset="-120"/>
               </a:rPr>
-              <a:t>1단계</a:t>
-            </a:r>
-            <a:endParaRPr lang="en-US" sz="1600" dirty="0"/>
-          </a:p>
-        </p:txBody>
-      </p:sp>
-      <p:sp>
-        <p:nvSpPr>
-          <p:cNvPr id="10" name="Text 8"/>
-          <p:cNvSpPr/>
-          <p:nvPr/>
-        </p:nvSpPr>
-        <p:spPr>
-          <a:xfrm>
-            <a:off x="786384" y="2761488"/>
-            <a:ext cx="2051228" cy="1828800"/>
-          </a:xfrm>
-          <a:prstGeom prst="rect">
-            <a:avLst/>
-          </a:prstGeom>
-          <a:noFill/>
-          <a:ln/>
-        </p:spPr>
-        <p:txBody>
-          <a:bodyPr wrap="square" rtlCol="0" anchor="t"/>
-          <a:lstStyle/>
-          <a:p>
-            <a:pPr indent="0" marL="0">
-              <a:buNone/>
-            </a:pPr>
-            <a:r>
-              <a:rPr lang="en-US" sz="1100" dirty="0">
-                <a:solidFill>
-                  <a:srgbClr val="10161F"/>
-                </a:solidFill>
-                <a:latin typeface="Pretendard" pitchFamily="34" charset="0"/>
-                <a:ea typeface="Pretendard" pitchFamily="34" charset="-122"/>
-                <a:cs typeface="Pretendard" pitchFamily="34" charset="-120"/>
-              </a:rPr>
-              <a:t>초기 관심 표명 → 담당자 연락</a:t>
-            </a:r>
-            <a:endParaRPr lang="en-US" sz="1100" dirty="0"/>
-          </a:p>
-        </p:txBody>
-      </p:sp>
-      <p:sp>
-        <p:nvSpPr>
-          <p:cNvPr id="11" name="Shape 9"/>
-          <p:cNvSpPr/>
-          <p:nvPr/>
-        </p:nvSpPr>
-        <p:spPr>
-          <a:xfrm>
-            <a:off x="3148508" y="3035808"/>
-            <a:ext cx="182880" cy="274320"/>
-          </a:xfrm>
-          <a:prstGeom prst="rightArrow">
-            <a:avLst/>
-          </a:prstGeom>
-          <a:solidFill>
-            <a:srgbClr val="CBD5E0"/>
-          </a:solidFill>
-          <a:ln w="6350">
-            <a:solidFill>
-              <a:srgbClr val="718096"/>
-            </a:solidFill>
-            <a:prstDash val="solid"/>
-          </a:ln>
-        </p:spPr>
-      </p:sp>
-      <p:sp>
-        <p:nvSpPr>
-          <p:cNvPr id="12" name="Shape 10"/>
-          <p:cNvSpPr/>
-          <p:nvPr/>
-        </p:nvSpPr>
-        <p:spPr>
-          <a:xfrm>
-            <a:off x="3422828" y="1572768"/>
-            <a:ext cx="2490140" cy="3200400"/>
-          </a:xfrm>
-          <a:prstGeom prst="roundRect">
-            <a:avLst>
-              <a:gd name="adj" fmla="val 2203"/>
-            </a:avLst>
-          </a:prstGeom>
-          <a:solidFill>
-            <a:srgbClr val="F7FAFC"/>
-          </a:solidFill>
+              <a:t>가치 상승 및 출구 전략</a:t>
+            </a:r>
+            <a:endParaRPr lang="en-US" sz="1500" dirty="0"/>
+          </a:p>
+        </p:txBody>
+      </p:sp>
+      <p:sp>
+        <p:nvSpPr>
+          <p:cNvPr id="18" name="Shape 16"/>
+          <p:cNvSpPr/>
+          <p:nvPr/>
+        </p:nvSpPr>
+        <p:spPr>
+          <a:xfrm>
+            <a:off x="6484468" y="2468880"/>
+            <a:ext cx="4911700" cy="0"/>
+          </a:xfrm>
+          <a:prstGeom prst="line">
+            <a:avLst/>
+          </a:prstGeom>
+          <a:noFill/>
           <a:ln w="6350">
             <a:solidFill>
               <a:srgbClr val="CBD5E0"/>
@@ -9452,89 +9531,33 @@
       </p:sp>
       <p:sp>
         <p:nvSpPr>
-          <p:cNvPr id="13" name="Shape 11"/>
-          <p:cNvSpPr/>
-          <p:nvPr/>
-        </p:nvSpPr>
-        <p:spPr>
-          <a:xfrm>
-            <a:off x="3642284" y="1792224"/>
-            <a:ext cx="438912" cy="438912"/>
-          </a:xfrm>
-          <a:prstGeom prst="ellipse">
-            <a:avLst/>
-          </a:prstGeom>
-          <a:solidFill>
-            <a:srgbClr val="B98A2E"/>
-          </a:solidFill>
-          <a:ln/>
-        </p:spPr>
-      </p:sp>
-      <p:sp>
-        <p:nvSpPr>
-          <p:cNvPr id="14" name="Text 12"/>
-          <p:cNvSpPr/>
-          <p:nvPr/>
-        </p:nvSpPr>
-        <p:spPr>
-          <a:xfrm>
-            <a:off x="3642284" y="1792224"/>
-            <a:ext cx="438912" cy="438912"/>
-          </a:xfrm>
-          <a:prstGeom prst="rect">
-            <a:avLst/>
-          </a:prstGeom>
-          <a:noFill/>
-          <a:ln/>
-        </p:spPr>
-        <p:txBody>
-          <a:bodyPr wrap="square" lIns="0" tIns="0" rIns="0" bIns="0" rtlCol="0" anchor="ctr"/>
-          <a:lstStyle/>
-          <a:p>
-            <a:pPr algn="ctr" indent="0" marL="0">
-              <a:buNone/>
-            </a:pPr>
-            <a:r>
-              <a:rPr lang="en-US" sz="1400" b="1" dirty="0">
-                <a:solidFill>
-                  <a:srgbClr val="FFFFFF"/>
-                </a:solidFill>
-                <a:latin typeface="Arial" pitchFamily="34" charset="0"/>
-                <a:ea typeface="Arial" pitchFamily="34" charset="-122"/>
-                <a:cs typeface="Arial" pitchFamily="34" charset="-120"/>
-              </a:rPr>
-              <a:t>02</a:t>
-            </a:r>
-            <a:endParaRPr lang="en-US" sz="1400" dirty="0"/>
-          </a:p>
-        </p:txBody>
-      </p:sp>
-      <p:sp>
-        <p:nvSpPr>
-          <p:cNvPr id="15" name="Text 13"/>
-          <p:cNvSpPr/>
-          <p:nvPr/>
-        </p:nvSpPr>
-        <p:spPr>
-          <a:xfrm>
-            <a:off x="3642284" y="2304288"/>
-            <a:ext cx="2051228" cy="365760"/>
-          </a:xfrm>
-          <a:prstGeom prst="rect">
-            <a:avLst/>
-          </a:prstGeom>
-          <a:noFill/>
-          <a:ln/>
-        </p:spPr>
-        <p:txBody>
-          <a:bodyPr wrap="square" rtlCol="0" anchor="ctr"/>
+          <p:cNvPr id="19" name="Text 17"/>
+          <p:cNvSpPr/>
+          <p:nvPr/>
+        </p:nvSpPr>
+        <p:spPr>
+          <a:xfrm>
+            <a:off x="6484468" y="2624328"/>
+            <a:ext cx="4911700" cy="1051560"/>
+          </a:xfrm>
+          <a:prstGeom prst="rect">
+            <a:avLst/>
+          </a:prstGeom>
+          <a:noFill/>
+          <a:ln/>
+        </p:spPr>
+        <p:txBody>
+          <a:bodyPr wrap="square" lIns="0" tIns="0" rIns="0" bIns="0" rtlCol="0" anchor="t"/>
           <a:lstStyle/>
           <a:p>
             <a:pPr indent="0" marL="0">
-              <a:buNone/>
-            </a:pPr>
-            <a:r>
-              <a:rPr lang="en-US" sz="1600" b="1" dirty="0">
+              <a:lnSpc>
+                <a:spcPct val="130000"/>
+              </a:lnSpc>
+              <a:buNone/>
+            </a:pPr>
+            <a:r>
+              <a:rPr lang="en-US" sz="1200" dirty="0">
                 <a:solidFill>
                   <a:srgbClr val="10161F"/>
                 </a:solidFill>
@@ -9542,188 +9565,1116 @@
                 <a:ea typeface="Pretendard" pitchFamily="34" charset="-122"/>
                 <a:cs typeface="Pretendard" pitchFamily="34" charset="-120"/>
               </a:rPr>
-              <a:t>2단계</a:t>
-            </a:r>
-            <a:endParaRPr lang="en-US" sz="1600" dirty="0"/>
-          </a:p>
-        </p:txBody>
-      </p:sp>
-      <p:sp>
-        <p:nvSpPr>
-          <p:cNvPr id="16" name="Text 14"/>
-          <p:cNvSpPr/>
-          <p:nvPr/>
-        </p:nvSpPr>
-        <p:spPr>
-          <a:xfrm>
-            <a:off x="3642284" y="2761488"/>
-            <a:ext cx="2051228" cy="1828800"/>
-          </a:xfrm>
-          <a:prstGeom prst="rect">
-            <a:avLst/>
-          </a:prstGeom>
-          <a:noFill/>
-          <a:ln/>
-        </p:spPr>
-        <p:txBody>
-          <a:bodyPr wrap="square" rtlCol="0" anchor="t"/>
+              <a:t>현행 공법 여력을 활용한 밸류업 기회와 더불어 향후 권역 지가 상승에 따른 시세차익 실현이 유력합니다. ### 예상 매수자 유형 (AI 분석)</a:t>
+            </a:r>
+            <a:endParaRPr lang="en-US" sz="1200" dirty="0"/>
+          </a:p>
+        </p:txBody>
+      </p:sp>
+      <p:graphicFrame>
+        <p:nvGraphicFramePr>
+          <p:cNvPr id="10" name="Table 0"/>
+          <p:cNvGraphicFramePr>
+            <a:graphicFrameLocks noGrp="1"/>
+          </p:cNvGraphicFramePr>
+          <p:nvPr>
+            <p:extLst>
+              <p:ext uri="{D42A27DB-BD31-4B8C-83A1-F6EECF244321}">
+                <p14:modId xmlns:p14="http://schemas.microsoft.com/office/powerpoint/2010/main" val="1579011935"/>
+              </p:ext>
+            </p:extLst>
+          </p:nvPr>
+        </p:nvGraphicFramePr>
+        <p:xfrm>
+          <a:off x="566928" y="4023360"/>
+          <a:ext cx="11057839" cy="914400"/>
+        </p:xfrm>
+        <a:graphic>
+          <a:graphicData uri="http://schemas.openxmlformats.org/drawingml/2006/table">
+            <a:tbl>
+              <a:tblPr/>
+              <a:tblGrid>
+                <a:gridCol w="3685946"/>
+                <a:gridCol w="3685946"/>
+                <a:gridCol w="3685946"/>
+              </a:tblGrid>
+              <a:tr h="329184">
+                <a:tc>
+                  <a:txBody>
+                    <a:bodyPr/>
+                    <a:lstStyle/>
+                    <a:p>
+                      <a:pPr indent="0" marL="0">
+                        <a:buNone/>
+                      </a:pPr>
+                      <a:r>
+                        <a:rPr lang="en-US" sz="1050" b="1" dirty="0">
+                          <a:solidFill>
+                            <a:srgbClr val="718096"/>
+                          </a:solidFill>
+                          <a:latin typeface="Pretendard" pitchFamily="34" charset="0"/>
+                          <a:ea typeface="Pretendard" pitchFamily="34" charset="-122"/>
+                          <a:cs typeface="Pretendard" pitchFamily="34" charset="-120"/>
+                        </a:rPr>
+                        <a:t>유형</a:t>
+                      </a:r>
+                      <a:endParaRPr lang="en-US" sz="1050" dirty="0">
+                        <a:latin typeface="Pretendard" charset="0"/>
+                        <a:ea typeface="Pretendard" charset="0"/>
+                        <a:cs typeface="Pretendard" charset="0"/>
+                      </a:endParaRPr>
+                    </a:p>
+                  </a:txBody>
+                  <a:tcPr marL="50800" marR="50800" marT="25400" marB="25400" anchor="ctr">
+                    <a:lnL w="3810" cap="flat" cmpd="sng" algn="ctr">
+                      <a:solidFill>
+                        <a:srgbClr val="CBD5E0"/>
+                      </a:solidFill>
+                      <a:prstDash val="solid"/>
+                      <a:round/>
+                      <a:headEnd type="none" w="med" len="med"/>
+                      <a:tailEnd type="none" w="med" len="med"/>
+                    </a:lnL>
+                    <a:lnR w="3810" cap="flat" cmpd="sng" algn="ctr">
+                      <a:solidFill>
+                        <a:srgbClr val="CBD5E0"/>
+                      </a:solidFill>
+                      <a:prstDash val="solid"/>
+                      <a:round/>
+                      <a:headEnd type="none" w="med" len="med"/>
+                      <a:tailEnd type="none" w="med" len="med"/>
+                    </a:lnR>
+                    <a:lnT w="3810" cap="flat" cmpd="sng" algn="ctr">
+                      <a:solidFill>
+                        <a:srgbClr val="CBD5E0"/>
+                      </a:solidFill>
+                      <a:prstDash val="solid"/>
+                      <a:round/>
+                      <a:headEnd type="none" w="med" len="med"/>
+                      <a:tailEnd type="none" w="med" len="med"/>
+                    </a:lnT>
+                    <a:lnB w="3810" cap="flat" cmpd="sng" algn="ctr">
+                      <a:solidFill>
+                        <a:srgbClr val="CBD5E0"/>
+                      </a:solidFill>
+                      <a:prstDash val="solid"/>
+                      <a:round/>
+                      <a:headEnd type="none" w="med" len="med"/>
+                      <a:tailEnd type="none" w="med" len="med"/>
+                    </a:lnB>
+                    <a:solidFill>
+                      <a:srgbClr val="F7FAFC"/>
+                    </a:solidFill>
+                  </a:tcPr>
+                </a:tc>
+                <a:tc>
+                  <a:txBody>
+                    <a:bodyPr/>
+                    <a:lstStyle/>
+                    <a:p>
+                      <a:pPr indent="0" marL="0">
+                        <a:buNone/>
+                      </a:pPr>
+                      <a:r>
+                        <a:rPr lang="en-US" sz="1050" b="1" dirty="0">
+                          <a:solidFill>
+                            <a:srgbClr val="718096"/>
+                          </a:solidFill>
+                          <a:latin typeface="Pretendard" pitchFamily="34" charset="0"/>
+                          <a:ea typeface="Pretendard" pitchFamily="34" charset="-122"/>
+                          <a:cs typeface="Pretendard" pitchFamily="34" charset="-120"/>
+                        </a:rPr>
+                        <a:t>적합도</a:t>
+                      </a:r>
+                      <a:endParaRPr lang="en-US" sz="1050" dirty="0">
+                        <a:latin typeface="Pretendard" charset="0"/>
+                        <a:ea typeface="Pretendard" charset="0"/>
+                        <a:cs typeface="Pretendard" charset="0"/>
+                      </a:endParaRPr>
+                    </a:p>
+                  </a:txBody>
+                  <a:tcPr marL="50800" marR="50800" marT="25400" marB="25400" anchor="ctr">
+                    <a:lnL w="3810" cap="flat" cmpd="sng" algn="ctr">
+                      <a:solidFill>
+                        <a:srgbClr val="CBD5E0"/>
+                      </a:solidFill>
+                      <a:prstDash val="solid"/>
+                      <a:round/>
+                      <a:headEnd type="none" w="med" len="med"/>
+                      <a:tailEnd type="none" w="med" len="med"/>
+                    </a:lnL>
+                    <a:lnR w="3810" cap="flat" cmpd="sng" algn="ctr">
+                      <a:solidFill>
+                        <a:srgbClr val="CBD5E0"/>
+                      </a:solidFill>
+                      <a:prstDash val="solid"/>
+                      <a:round/>
+                      <a:headEnd type="none" w="med" len="med"/>
+                      <a:tailEnd type="none" w="med" len="med"/>
+                    </a:lnR>
+                    <a:lnT w="3810" cap="flat" cmpd="sng" algn="ctr">
+                      <a:solidFill>
+                        <a:srgbClr val="CBD5E0"/>
+                      </a:solidFill>
+                      <a:prstDash val="solid"/>
+                      <a:round/>
+                      <a:headEnd type="none" w="med" len="med"/>
+                      <a:tailEnd type="none" w="med" len="med"/>
+                    </a:lnT>
+                    <a:lnB w="3810" cap="flat" cmpd="sng" algn="ctr">
+                      <a:solidFill>
+                        <a:srgbClr val="CBD5E0"/>
+                      </a:solidFill>
+                      <a:prstDash val="solid"/>
+                      <a:round/>
+                      <a:headEnd type="none" w="med" len="med"/>
+                      <a:tailEnd type="none" w="med" len="med"/>
+                    </a:lnB>
+                    <a:solidFill>
+                      <a:srgbClr val="F7FAFC"/>
+                    </a:solidFill>
+                  </a:tcPr>
+                </a:tc>
+                <a:tc>
+                  <a:txBody>
+                    <a:bodyPr/>
+                    <a:lstStyle/>
+                    <a:p>
+                      <a:pPr indent="0" marL="0">
+                        <a:buNone/>
+                      </a:pPr>
+                      <a:r>
+                        <a:rPr lang="en-US" sz="1050" b="1" dirty="0">
+                          <a:solidFill>
+                            <a:srgbClr val="718096"/>
+                          </a:solidFill>
+                          <a:latin typeface="Pretendard" pitchFamily="34" charset="0"/>
+                          <a:ea typeface="Pretendard" pitchFamily="34" charset="-122"/>
+                          <a:cs typeface="Pretendard" pitchFamily="34" charset="-120"/>
+                        </a:rPr>
+                        <a:t>이유</a:t>
+                      </a:r>
+                      <a:endParaRPr lang="en-US" sz="1050" dirty="0">
+                        <a:latin typeface="Pretendard" charset="0"/>
+                        <a:ea typeface="Pretendard" charset="0"/>
+                        <a:cs typeface="Pretendard" charset="0"/>
+                      </a:endParaRPr>
+                    </a:p>
+                  </a:txBody>
+                  <a:tcPr marL="50800" marR="50800" marT="25400" marB="25400" anchor="ctr">
+                    <a:lnL w="3810" cap="flat" cmpd="sng" algn="ctr">
+                      <a:solidFill>
+                        <a:srgbClr val="CBD5E0"/>
+                      </a:solidFill>
+                      <a:prstDash val="solid"/>
+                      <a:round/>
+                      <a:headEnd type="none" w="med" len="med"/>
+                      <a:tailEnd type="none" w="med" len="med"/>
+                    </a:lnL>
+                    <a:lnR w="3810" cap="flat" cmpd="sng" algn="ctr">
+                      <a:solidFill>
+                        <a:srgbClr val="CBD5E0"/>
+                      </a:solidFill>
+                      <a:prstDash val="solid"/>
+                      <a:round/>
+                      <a:headEnd type="none" w="med" len="med"/>
+                      <a:tailEnd type="none" w="med" len="med"/>
+                    </a:lnR>
+                    <a:lnT w="3810" cap="flat" cmpd="sng" algn="ctr">
+                      <a:solidFill>
+                        <a:srgbClr val="CBD5E0"/>
+                      </a:solidFill>
+                      <a:prstDash val="solid"/>
+                      <a:round/>
+                      <a:headEnd type="none" w="med" len="med"/>
+                      <a:tailEnd type="none" w="med" len="med"/>
+                    </a:lnT>
+                    <a:lnB w="3810" cap="flat" cmpd="sng" algn="ctr">
+                      <a:solidFill>
+                        <a:srgbClr val="CBD5E0"/>
+                      </a:solidFill>
+                      <a:prstDash val="solid"/>
+                      <a:round/>
+                      <a:headEnd type="none" w="med" len="med"/>
+                      <a:tailEnd type="none" w="med" len="med"/>
+                    </a:lnB>
+                    <a:solidFill>
+                      <a:srgbClr val="F7FAFC"/>
+                    </a:solidFill>
+                  </a:tcPr>
+                </a:tc>
+              </a:tr>
+              <a:tr h="329184">
+                <a:tc>
+                  <a:txBody>
+                    <a:bodyPr/>
+                    <a:lstStyle/>
+                    <a:p>
+                      <a:pPr indent="0" marL="0">
+                        <a:buNone/>
+                      </a:pPr>
+                      <a:r>
+                        <a:rPr lang="en-US" sz="1050" b="1" dirty="0">
+                          <a:solidFill>
+                            <a:srgbClr val="10161F"/>
+                          </a:solidFill>
+                          <a:latin typeface="Pretendard" pitchFamily="34" charset="0"/>
+                          <a:ea typeface="Pretendard" pitchFamily="34" charset="-122"/>
+                          <a:cs typeface="Pretendard" pitchFamily="34" charset="-120"/>
+                        </a:rPr>
+                        <a:t>(임대수익)</a:t>
+                      </a:r>
+                      <a:endParaRPr lang="en-US" sz="1050" dirty="0">
+                        <a:latin typeface="Pretendard" charset="0"/>
+                        <a:ea typeface="Pretendard" charset="0"/>
+                        <a:cs typeface="Pretendard" charset="0"/>
+                      </a:endParaRPr>
+                    </a:p>
+                  </a:txBody>
+                  <a:tcPr marL="50800" marR="50800" marT="25400" marB="25400" anchor="ctr">
+                    <a:lnL w="3810" cap="flat" cmpd="sng" algn="ctr">
+                      <a:solidFill>
+                        <a:srgbClr val="CBD5E0"/>
+                      </a:solidFill>
+                      <a:prstDash val="solid"/>
+                      <a:round/>
+                      <a:headEnd type="none" w="med" len="med"/>
+                      <a:tailEnd type="none" w="med" len="med"/>
+                    </a:lnL>
+                    <a:lnR w="3810" cap="flat" cmpd="sng" algn="ctr">
+                      <a:solidFill>
+                        <a:srgbClr val="CBD5E0"/>
+                      </a:solidFill>
+                      <a:prstDash val="solid"/>
+                      <a:round/>
+                      <a:headEnd type="none" w="med" len="med"/>
+                      <a:tailEnd type="none" w="med" len="med"/>
+                    </a:lnR>
+                    <a:lnT w="3810" cap="flat" cmpd="sng" algn="ctr">
+                      <a:solidFill>
+                        <a:srgbClr val="CBD5E0"/>
+                      </a:solidFill>
+                      <a:prstDash val="solid"/>
+                      <a:round/>
+                      <a:headEnd type="none" w="med" len="med"/>
+                      <a:tailEnd type="none" w="med" len="med"/>
+                    </a:lnT>
+                    <a:lnB w="3810" cap="flat" cmpd="sng" algn="ctr">
+                      <a:solidFill>
+                        <a:srgbClr val="CBD5E0"/>
+                      </a:solidFill>
+                      <a:prstDash val="solid"/>
+                      <a:round/>
+                      <a:headEnd type="none" w="med" len="med"/>
+                      <a:tailEnd type="none" w="med" len="med"/>
+                    </a:lnB>
+                    <a:solidFill>
+                      <a:srgbClr val="FFFFFF"/>
+                    </a:solidFill>
+                  </a:tcPr>
+                </a:tc>
+                <a:tc>
+                  <a:txBody>
+                    <a:bodyPr/>
+                    <a:lstStyle/>
+                    <a:p>
+                      <a:pPr indent="0" marL="0">
+                        <a:buNone/>
+                      </a:pPr>
+                      <a:r>
+                        <a:rPr lang="en-US" sz="1050" dirty="0">
+                          <a:solidFill>
+                            <a:srgbClr val="10161F"/>
+                          </a:solidFill>
+                          <a:latin typeface="Pretendard" pitchFamily="34" charset="0"/>
+                          <a:ea typeface="Pretendard" pitchFamily="34" charset="-122"/>
+                          <a:cs typeface="Pretendard" pitchFamily="34" charset="-120"/>
+                        </a:rPr>
+                        <a:t>최적합</a:t>
+                      </a:r>
+                      <a:endParaRPr lang="en-US" sz="1050" dirty="0">
+                        <a:latin typeface="Pretendard" charset="0"/>
+                        <a:ea typeface="Pretendard" charset="0"/>
+                        <a:cs typeface="Pretendard" charset="0"/>
+                      </a:endParaRPr>
+                    </a:p>
+                  </a:txBody>
+                  <a:tcPr marL="50800" marR="50800" marT="25400" marB="25400" anchor="ctr">
+                    <a:lnL w="3810" cap="flat" cmpd="sng" algn="ctr">
+                      <a:solidFill>
+                        <a:srgbClr val="CBD5E0"/>
+                      </a:solidFill>
+                      <a:prstDash val="solid"/>
+                      <a:round/>
+                      <a:headEnd type="none" w="med" len="med"/>
+                      <a:tailEnd type="none" w="med" len="med"/>
+                    </a:lnL>
+                    <a:lnR w="3810" cap="flat" cmpd="sng" algn="ctr">
+                      <a:solidFill>
+                        <a:srgbClr val="CBD5E0"/>
+                      </a:solidFill>
+                      <a:prstDash val="solid"/>
+                      <a:round/>
+                      <a:headEnd type="none" w="med" len="med"/>
+                      <a:tailEnd type="none" w="med" len="med"/>
+                    </a:lnR>
+                    <a:lnT w="3810" cap="flat" cmpd="sng" algn="ctr">
+                      <a:solidFill>
+                        <a:srgbClr val="CBD5E0"/>
+                      </a:solidFill>
+                      <a:prstDash val="solid"/>
+                      <a:round/>
+                      <a:headEnd type="none" w="med" len="med"/>
+                      <a:tailEnd type="none" w="med" len="med"/>
+                    </a:lnT>
+                    <a:lnB w="3810" cap="flat" cmpd="sng" algn="ctr">
+                      <a:solidFill>
+                        <a:srgbClr val="CBD5E0"/>
+                      </a:solidFill>
+                      <a:prstDash val="solid"/>
+                      <a:round/>
+                      <a:headEnd type="none" w="med" len="med"/>
+                      <a:tailEnd type="none" w="med" len="med"/>
+                    </a:lnB>
+                    <a:solidFill>
+                      <a:srgbClr val="FFFFFF"/>
+                    </a:solidFill>
+                  </a:tcPr>
+                </a:tc>
+                <a:tc>
+                  <a:txBody>
+                    <a:bodyPr/>
+                    <a:lstStyle/>
+                    <a:p>
+                      <a:pPr indent="0" marL="0">
+                        <a:buNone/>
+                      </a:pPr>
+                      <a:r>
+                        <a:rPr lang="en-US" sz="1050" dirty="0">
+                          <a:solidFill>
+                            <a:srgbClr val="10161F"/>
+                          </a:solidFill>
+                          <a:latin typeface="Pretendard" pitchFamily="34" charset="0"/>
+                          <a:ea typeface="Pretendard" pitchFamily="34" charset="-122"/>
+                          <a:cs typeface="Pretendard" pitchFamily="34" charset="-120"/>
+                        </a:rPr>
+                        <a:t>소형 </a:t>
+                      </a:r>
+                      <a:pPr indent="0" marL="0">
+                        <a:buNone/>
+                      </a:pPr>
+                      <a:r>
+                        <a:rPr lang="en-US" sz="1050" dirty="0">
+                          <a:solidFill>
+                            <a:srgbClr val="10161F"/>
+                          </a:solidFill>
+                          <a:latin typeface="Pretendard" pitchFamily="34" charset="0"/>
+                          <a:ea typeface="Pretendard" pitchFamily="34" charset="-122"/>
+                          <a:cs typeface="Pretendard" pitchFamily="34" charset="-120"/>
+                        </a:rPr>
+                        <a:t>빌딩 </a:t>
+                      </a:r>
+                      <a:pPr indent="0" marL="0">
+                        <a:buNone/>
+                      </a:pPr>
+                      <a:r>
+                        <a:rPr lang="en-US" sz="1050" dirty="0">
+                          <a:solidFill>
+                            <a:srgbClr val="10161F"/>
+                          </a:solidFill>
+                          <a:latin typeface="Pretendard" pitchFamily="34" charset="0"/>
+                          <a:ea typeface="Pretendard" pitchFamily="34" charset="-122"/>
+                          <a:cs typeface="Pretendard" pitchFamily="34" charset="-120"/>
+                        </a:rPr>
+                        <a:t>안정 </a:t>
+                      </a:r>
+                      <a:pPr indent="0" marL="0">
+                        <a:buNone/>
+                      </a:pPr>
+                      <a:r>
+                        <a:rPr lang="en-US" sz="1050" dirty="0">
+                          <a:solidFill>
+                            <a:srgbClr val="10161F"/>
+                          </a:solidFill>
+                          <a:latin typeface="Pretendard" pitchFamily="34" charset="0"/>
+                          <a:ea typeface="Pretendard" pitchFamily="34" charset="-122"/>
+                          <a:cs typeface="Pretendard" pitchFamily="34" charset="-120"/>
+                        </a:rPr>
+                        <a:t>수익 </a:t>
+                      </a:r>
+                      <a:pPr indent="0" marL="0">
+                        <a:buNone/>
+                      </a:pPr>
+                      <a:r>
+                        <a:rPr lang="en-US" sz="1050" dirty="0">
+                          <a:solidFill>
+                            <a:srgbClr val="10161F"/>
+                          </a:solidFill>
+                          <a:latin typeface="Pretendard" pitchFamily="34" charset="0"/>
+                          <a:ea typeface="Pretendard" pitchFamily="34" charset="-122"/>
+                          <a:cs typeface="Pretendard" pitchFamily="34" charset="-120"/>
+                        </a:rPr>
+                        <a:t>최적</a:t>
+                      </a:r>
+                      <a:endParaRPr lang="en-US" sz="1050" dirty="0">
+                        <a:latin typeface="Pretendard" charset="0"/>
+                        <a:ea typeface="Pretendard" charset="0"/>
+                        <a:cs typeface="Pretendard" charset="0"/>
+                      </a:endParaRPr>
+                    </a:p>
+                  </a:txBody>
+                  <a:tcPr marL="50800" marR="50800" marT="25400" marB="25400" anchor="ctr">
+                    <a:lnL w="3810" cap="flat" cmpd="sng" algn="ctr">
+                      <a:solidFill>
+                        <a:srgbClr val="CBD5E0"/>
+                      </a:solidFill>
+                      <a:prstDash val="solid"/>
+                      <a:round/>
+                      <a:headEnd type="none" w="med" len="med"/>
+                      <a:tailEnd type="none" w="med" len="med"/>
+                    </a:lnL>
+                    <a:lnR w="3810" cap="flat" cmpd="sng" algn="ctr">
+                      <a:solidFill>
+                        <a:srgbClr val="CBD5E0"/>
+                      </a:solidFill>
+                      <a:prstDash val="solid"/>
+                      <a:round/>
+                      <a:headEnd type="none" w="med" len="med"/>
+                      <a:tailEnd type="none" w="med" len="med"/>
+                    </a:lnR>
+                    <a:lnT w="3810" cap="flat" cmpd="sng" algn="ctr">
+                      <a:solidFill>
+                        <a:srgbClr val="CBD5E0"/>
+                      </a:solidFill>
+                      <a:prstDash val="solid"/>
+                      <a:round/>
+                      <a:headEnd type="none" w="med" len="med"/>
+                      <a:tailEnd type="none" w="med" len="med"/>
+                    </a:lnT>
+                    <a:lnB w="3810" cap="flat" cmpd="sng" algn="ctr">
+                      <a:solidFill>
+                        <a:srgbClr val="CBD5E0"/>
+                      </a:solidFill>
+                      <a:prstDash val="solid"/>
+                      <a:round/>
+                      <a:headEnd type="none" w="med" len="med"/>
+                      <a:tailEnd type="none" w="med" len="med"/>
+                    </a:lnB>
+                    <a:solidFill>
+                      <a:srgbClr val="FFFFFF"/>
+                    </a:solidFill>
+                  </a:tcPr>
+                </a:tc>
+              </a:tr>
+              <a:tr h="329184">
+                <a:tc>
+                  <a:txBody>
+                    <a:bodyPr/>
+                    <a:lstStyle/>
+                    <a:p>
+                      <a:pPr indent="0" marL="0">
+                        <a:buNone/>
+                      </a:pPr>
+                      <a:r>
+                        <a:rPr lang="en-US" sz="1050" b="1" dirty="0">
+                          <a:solidFill>
+                            <a:srgbClr val="10161F"/>
+                          </a:solidFill>
+                          <a:latin typeface="Pretendard" pitchFamily="34" charset="0"/>
+                          <a:ea typeface="Pretendard" pitchFamily="34" charset="-122"/>
+                          <a:cs typeface="Pretendard" pitchFamily="34" charset="-120"/>
+                        </a:rPr>
+                        <a:t>법인 </a:t>
+                      </a:r>
+                      <a:pPr indent="0" marL="0">
+                        <a:buNone/>
+                      </a:pPr>
+                      <a:r>
+                        <a:rPr lang="en-US" sz="1050" b="1" dirty="0">
+                          <a:solidFill>
+                            <a:srgbClr val="10161F"/>
+                          </a:solidFill>
+                          <a:latin typeface="Pretendard" pitchFamily="34" charset="0"/>
+                          <a:ea typeface="Pretendard" pitchFamily="34" charset="-122"/>
+                          <a:cs typeface="Pretendard" pitchFamily="34" charset="-120"/>
+                        </a:rPr>
+                        <a:t>사옥 </a:t>
+                      </a:r>
+                      <a:pPr indent="0" marL="0">
+                        <a:buNone/>
+                      </a:pPr>
+                      <a:r>
+                        <a:rPr lang="en-US" sz="1050" b="1" dirty="0">
+                          <a:solidFill>
+                            <a:srgbClr val="10161F"/>
+                          </a:solidFill>
+                          <a:latin typeface="Pretendard" pitchFamily="34" charset="0"/>
+                          <a:ea typeface="Pretendard" pitchFamily="34" charset="-122"/>
+                          <a:cs typeface="Pretendard" pitchFamily="34" charset="-120"/>
+                        </a:rPr>
+                        <a:t>이전</a:t>
+                      </a:r>
+                      <a:endParaRPr lang="en-US" sz="1050" dirty="0">
+                        <a:latin typeface="Pretendard" charset="0"/>
+                        <a:ea typeface="Pretendard" charset="0"/>
+                        <a:cs typeface="Pretendard" charset="0"/>
+                      </a:endParaRPr>
+                    </a:p>
+                  </a:txBody>
+                  <a:tcPr marL="50800" marR="50800" marT="25400" marB="25400" anchor="ctr">
+                    <a:lnL w="3810" cap="flat" cmpd="sng" algn="ctr">
+                      <a:solidFill>
+                        <a:srgbClr val="CBD5E0"/>
+                      </a:solidFill>
+                      <a:prstDash val="solid"/>
+                      <a:round/>
+                      <a:headEnd type="none" w="med" len="med"/>
+                      <a:tailEnd type="none" w="med" len="med"/>
+                    </a:lnL>
+                    <a:lnR w="3810" cap="flat" cmpd="sng" algn="ctr">
+                      <a:solidFill>
+                        <a:srgbClr val="CBD5E0"/>
+                      </a:solidFill>
+                      <a:prstDash val="solid"/>
+                      <a:round/>
+                      <a:headEnd type="none" w="med" len="med"/>
+                      <a:tailEnd type="none" w="med" len="med"/>
+                    </a:lnR>
+                    <a:lnT w="3810" cap="flat" cmpd="sng" algn="ctr">
+                      <a:solidFill>
+                        <a:srgbClr val="CBD5E0"/>
+                      </a:solidFill>
+                      <a:prstDash val="solid"/>
+                      <a:round/>
+                      <a:headEnd type="none" w="med" len="med"/>
+                      <a:tailEnd type="none" w="med" len="med"/>
+                    </a:lnT>
+                    <a:lnB w="3810" cap="flat" cmpd="sng" algn="ctr">
+                      <a:solidFill>
+                        <a:srgbClr val="CBD5E0"/>
+                      </a:solidFill>
+                      <a:prstDash val="solid"/>
+                      <a:round/>
+                      <a:headEnd type="none" w="med" len="med"/>
+                      <a:tailEnd type="none" w="med" len="med"/>
+                    </a:lnB>
+                    <a:solidFill>
+                      <a:srgbClr val="F7FAFC"/>
+                    </a:solidFill>
+                  </a:tcPr>
+                </a:tc>
+                <a:tc>
+                  <a:txBody>
+                    <a:bodyPr/>
+                    <a:lstStyle/>
+                    <a:p>
+                      <a:pPr indent="0" marL="0">
+                        <a:buNone/>
+                      </a:pPr>
+                      <a:r>
+                        <a:rPr lang="en-US" sz="1050" dirty="0">
+                          <a:solidFill>
+                            <a:srgbClr val="10161F"/>
+                          </a:solidFill>
+                          <a:latin typeface="Pretendard" pitchFamily="34" charset="0"/>
+                          <a:ea typeface="Pretendard" pitchFamily="34" charset="-122"/>
+                          <a:cs typeface="Pretendard" pitchFamily="34" charset="-120"/>
+                        </a:rPr>
+                        <a:t>적합</a:t>
+                      </a:r>
+                      <a:endParaRPr lang="en-US" sz="1050" dirty="0">
+                        <a:latin typeface="Pretendard" charset="0"/>
+                        <a:ea typeface="Pretendard" charset="0"/>
+                        <a:cs typeface="Pretendard" charset="0"/>
+                      </a:endParaRPr>
+                    </a:p>
+                  </a:txBody>
+                  <a:tcPr marL="50800" marR="50800" marT="25400" marB="25400" anchor="ctr">
+                    <a:lnL w="3810" cap="flat" cmpd="sng" algn="ctr">
+                      <a:solidFill>
+                        <a:srgbClr val="CBD5E0"/>
+                      </a:solidFill>
+                      <a:prstDash val="solid"/>
+                      <a:round/>
+                      <a:headEnd type="none" w="med" len="med"/>
+                      <a:tailEnd type="none" w="med" len="med"/>
+                    </a:lnL>
+                    <a:lnR w="3810" cap="flat" cmpd="sng" algn="ctr">
+                      <a:solidFill>
+                        <a:srgbClr val="CBD5E0"/>
+                      </a:solidFill>
+                      <a:prstDash val="solid"/>
+                      <a:round/>
+                      <a:headEnd type="none" w="med" len="med"/>
+                      <a:tailEnd type="none" w="med" len="med"/>
+                    </a:lnR>
+                    <a:lnT w="3810" cap="flat" cmpd="sng" algn="ctr">
+                      <a:solidFill>
+                        <a:srgbClr val="CBD5E0"/>
+                      </a:solidFill>
+                      <a:prstDash val="solid"/>
+                      <a:round/>
+                      <a:headEnd type="none" w="med" len="med"/>
+                      <a:tailEnd type="none" w="med" len="med"/>
+                    </a:lnT>
+                    <a:lnB w="3810" cap="flat" cmpd="sng" algn="ctr">
+                      <a:solidFill>
+                        <a:srgbClr val="CBD5E0"/>
+                      </a:solidFill>
+                      <a:prstDash val="solid"/>
+                      <a:round/>
+                      <a:headEnd type="none" w="med" len="med"/>
+                      <a:tailEnd type="none" w="med" len="med"/>
+                    </a:lnB>
+                    <a:solidFill>
+                      <a:srgbClr val="F7FAFC"/>
+                    </a:solidFill>
+                  </a:tcPr>
+                </a:tc>
+                <a:tc>
+                  <a:txBody>
+                    <a:bodyPr/>
+                    <a:lstStyle/>
+                    <a:p>
+                      <a:pPr indent="0" marL="0">
+                        <a:buNone/>
+                      </a:pPr>
+                      <a:r>
+                        <a:rPr lang="en-US" sz="1050" dirty="0">
+                          <a:solidFill>
+                            <a:srgbClr val="10161F"/>
+                          </a:solidFill>
+                          <a:latin typeface="Pretendard" pitchFamily="34" charset="0"/>
+                          <a:ea typeface="Pretendard" pitchFamily="34" charset="-122"/>
+                          <a:cs typeface="Pretendard" pitchFamily="34" charset="-120"/>
+                        </a:rPr>
+                        <a:t>강남권역 </a:t>
+                      </a:r>
+                      <a:pPr indent="0" marL="0">
+                        <a:buNone/>
+                      </a:pPr>
+                      <a:r>
+                        <a:rPr lang="en-US" sz="1050" dirty="0">
+                          <a:solidFill>
+                            <a:srgbClr val="10161F"/>
+                          </a:solidFill>
+                          <a:latin typeface="Pretendard" pitchFamily="34" charset="0"/>
+                          <a:ea typeface="Pretendard" pitchFamily="34" charset="-122"/>
+                          <a:cs typeface="Pretendard" pitchFamily="34" charset="-120"/>
+                        </a:rPr>
+                        <a:t>직주근접</a:t>
+                      </a:r>
+                      <a:endParaRPr lang="en-US" sz="1050" dirty="0">
+                        <a:latin typeface="Pretendard" charset="0"/>
+                        <a:ea typeface="Pretendard" charset="0"/>
+                        <a:cs typeface="Pretendard" charset="0"/>
+                      </a:endParaRPr>
+                    </a:p>
+                  </a:txBody>
+                  <a:tcPr marL="50800" marR="50800" marT="25400" marB="25400" anchor="ctr">
+                    <a:lnL w="3810" cap="flat" cmpd="sng" algn="ctr">
+                      <a:solidFill>
+                        <a:srgbClr val="CBD5E0"/>
+                      </a:solidFill>
+                      <a:prstDash val="solid"/>
+                      <a:round/>
+                      <a:headEnd type="none" w="med" len="med"/>
+                      <a:tailEnd type="none" w="med" len="med"/>
+                    </a:lnL>
+                    <a:lnR w="3810" cap="flat" cmpd="sng" algn="ctr">
+                      <a:solidFill>
+                        <a:srgbClr val="CBD5E0"/>
+                      </a:solidFill>
+                      <a:prstDash val="solid"/>
+                      <a:round/>
+                      <a:headEnd type="none" w="med" len="med"/>
+                      <a:tailEnd type="none" w="med" len="med"/>
+                    </a:lnR>
+                    <a:lnT w="3810" cap="flat" cmpd="sng" algn="ctr">
+                      <a:solidFill>
+                        <a:srgbClr val="CBD5E0"/>
+                      </a:solidFill>
+                      <a:prstDash val="solid"/>
+                      <a:round/>
+                      <a:headEnd type="none" w="med" len="med"/>
+                      <a:tailEnd type="none" w="med" len="med"/>
+                    </a:lnT>
+                    <a:lnB w="3810" cap="flat" cmpd="sng" algn="ctr">
+                      <a:solidFill>
+                        <a:srgbClr val="CBD5E0"/>
+                      </a:solidFill>
+                      <a:prstDash val="solid"/>
+                      <a:round/>
+                      <a:headEnd type="none" w="med" len="med"/>
+                      <a:tailEnd type="none" w="med" len="med"/>
+                    </a:lnB>
+                    <a:solidFill>
+                      <a:srgbClr val="F7FAFC"/>
+                    </a:solidFill>
+                  </a:tcPr>
+                </a:tc>
+              </a:tr>
+              <a:tr h="329184">
+                <a:tc>
+                  <a:txBody>
+                    <a:bodyPr/>
+                    <a:lstStyle/>
+                    <a:p>
+                      <a:pPr indent="0" marL="0">
+                        <a:buNone/>
+                      </a:pPr>
+                      <a:r>
+                        <a:rPr lang="en-US" sz="1050" b="1" dirty="0">
+                          <a:solidFill>
+                            <a:srgbClr val="10161F"/>
+                          </a:solidFill>
+                          <a:latin typeface="Pretendard" pitchFamily="34" charset="0"/>
+                          <a:ea typeface="Pretendard" pitchFamily="34" charset="-122"/>
+                          <a:cs typeface="Pretendard" pitchFamily="34" charset="-120"/>
+                        </a:rPr>
+                        <a:t>소규모 </a:t>
+                      </a:r>
+                      <a:pPr indent="0" marL="0">
+                        <a:buNone/>
+                      </a:pPr>
+                      <a:r>
+                        <a:rPr lang="en-US" sz="1050" b="1" dirty="0">
+                          <a:solidFill>
+                            <a:srgbClr val="10161F"/>
+                          </a:solidFill>
+                          <a:latin typeface="Pretendard" pitchFamily="34" charset="0"/>
+                          <a:ea typeface="Pretendard" pitchFamily="34" charset="-122"/>
+                          <a:cs typeface="Pretendard" pitchFamily="34" charset="-120"/>
+                        </a:rPr>
+                        <a:t>개발업체</a:t>
+                      </a:r>
+                      <a:endParaRPr lang="en-US" sz="1050" dirty="0">
+                        <a:latin typeface="Pretendard" charset="0"/>
+                        <a:ea typeface="Pretendard" charset="0"/>
+                        <a:cs typeface="Pretendard" charset="0"/>
+                      </a:endParaRPr>
+                    </a:p>
+                  </a:txBody>
+                  <a:tcPr marL="50800" marR="50800" marT="25400" marB="25400" anchor="ctr">
+                    <a:lnL w="3810" cap="flat" cmpd="sng" algn="ctr">
+                      <a:solidFill>
+                        <a:srgbClr val="CBD5E0"/>
+                      </a:solidFill>
+                      <a:prstDash val="solid"/>
+                      <a:round/>
+                      <a:headEnd type="none" w="med" len="med"/>
+                      <a:tailEnd type="none" w="med" len="med"/>
+                    </a:lnL>
+                    <a:lnR w="3810" cap="flat" cmpd="sng" algn="ctr">
+                      <a:solidFill>
+                        <a:srgbClr val="CBD5E0"/>
+                      </a:solidFill>
+                      <a:prstDash val="solid"/>
+                      <a:round/>
+                      <a:headEnd type="none" w="med" len="med"/>
+                      <a:tailEnd type="none" w="med" len="med"/>
+                    </a:lnR>
+                    <a:lnT w="3810" cap="flat" cmpd="sng" algn="ctr">
+                      <a:solidFill>
+                        <a:srgbClr val="CBD5E0"/>
+                      </a:solidFill>
+                      <a:prstDash val="solid"/>
+                      <a:round/>
+                      <a:headEnd type="none" w="med" len="med"/>
+                      <a:tailEnd type="none" w="med" len="med"/>
+                    </a:lnT>
+                    <a:lnB w="3810" cap="flat" cmpd="sng" algn="ctr">
+                      <a:solidFill>
+                        <a:srgbClr val="CBD5E0"/>
+                      </a:solidFill>
+                      <a:prstDash val="solid"/>
+                      <a:round/>
+                      <a:headEnd type="none" w="med" len="med"/>
+                      <a:tailEnd type="none" w="med" len="med"/>
+                    </a:lnB>
+                    <a:solidFill>
+                      <a:srgbClr val="FFFFFF"/>
+                    </a:solidFill>
+                  </a:tcPr>
+                </a:tc>
+                <a:tc>
+                  <a:txBody>
+                    <a:bodyPr/>
+                    <a:lstStyle/>
+                    <a:p>
+                      <a:pPr indent="0" marL="0">
+                        <a:buNone/>
+                      </a:pPr>
+                      <a:r>
+                        <a:rPr lang="en-US" sz="1050" dirty="0">
+                          <a:solidFill>
+                            <a:srgbClr val="10161F"/>
+                          </a:solidFill>
+                          <a:latin typeface="Pretendard" pitchFamily="34" charset="0"/>
+                          <a:ea typeface="Pretendard" pitchFamily="34" charset="-122"/>
+                          <a:cs typeface="Pretendard" pitchFamily="34" charset="-120"/>
+                        </a:rPr>
+                        <a:t>검토</a:t>
+                      </a:r>
+                      <a:endParaRPr lang="en-US" sz="1050" dirty="0">
+                        <a:latin typeface="Pretendard" charset="0"/>
+                        <a:ea typeface="Pretendard" charset="0"/>
+                        <a:cs typeface="Pretendard" charset="0"/>
+                      </a:endParaRPr>
+                    </a:p>
+                  </a:txBody>
+                  <a:tcPr marL="50800" marR="50800" marT="25400" marB="25400" anchor="ctr">
+                    <a:lnL w="3810" cap="flat" cmpd="sng" algn="ctr">
+                      <a:solidFill>
+                        <a:srgbClr val="CBD5E0"/>
+                      </a:solidFill>
+                      <a:prstDash val="solid"/>
+                      <a:round/>
+                      <a:headEnd type="none" w="med" len="med"/>
+                      <a:tailEnd type="none" w="med" len="med"/>
+                    </a:lnL>
+                    <a:lnR w="3810" cap="flat" cmpd="sng" algn="ctr">
+                      <a:solidFill>
+                        <a:srgbClr val="CBD5E0"/>
+                      </a:solidFill>
+                      <a:prstDash val="solid"/>
+                      <a:round/>
+                      <a:headEnd type="none" w="med" len="med"/>
+                      <a:tailEnd type="none" w="med" len="med"/>
+                    </a:lnR>
+                    <a:lnT w="3810" cap="flat" cmpd="sng" algn="ctr">
+                      <a:solidFill>
+                        <a:srgbClr val="CBD5E0"/>
+                      </a:solidFill>
+                      <a:prstDash val="solid"/>
+                      <a:round/>
+                      <a:headEnd type="none" w="med" len="med"/>
+                      <a:tailEnd type="none" w="med" len="med"/>
+                    </a:lnT>
+                    <a:lnB w="3810" cap="flat" cmpd="sng" algn="ctr">
+                      <a:solidFill>
+                        <a:srgbClr val="CBD5E0"/>
+                      </a:solidFill>
+                      <a:prstDash val="solid"/>
+                      <a:round/>
+                      <a:headEnd type="none" w="med" len="med"/>
+                      <a:tailEnd type="none" w="med" len="med"/>
+                    </a:lnB>
+                    <a:solidFill>
+                      <a:srgbClr val="FFFFFF"/>
+                    </a:solidFill>
+                  </a:tcPr>
+                </a:tc>
+                <a:tc>
+                  <a:txBody>
+                    <a:bodyPr/>
+                    <a:lstStyle/>
+                    <a:p>
+                      <a:pPr indent="0" marL="0">
+                        <a:buNone/>
+                      </a:pPr>
+                      <a:r>
+                        <a:rPr lang="en-US" sz="1050" dirty="0">
+                          <a:solidFill>
+                            <a:srgbClr val="10161F"/>
+                          </a:solidFill>
+                          <a:latin typeface="Pretendard" pitchFamily="34" charset="0"/>
+                          <a:ea typeface="Pretendard" pitchFamily="34" charset="-122"/>
+                          <a:cs typeface="Pretendard" pitchFamily="34" charset="-120"/>
+                        </a:rPr>
+                        <a:t>밸류업 </a:t>
+                      </a:r>
+                      <a:pPr indent="0" marL="0">
+                        <a:buNone/>
+                      </a:pPr>
+                      <a:r>
+                        <a:rPr lang="en-US" sz="1050" dirty="0">
+                          <a:solidFill>
+                            <a:srgbClr val="10161F"/>
+                          </a:solidFill>
+                          <a:latin typeface="Pretendard" pitchFamily="34" charset="0"/>
+                          <a:ea typeface="Pretendard" pitchFamily="34" charset="-122"/>
+                          <a:cs typeface="Pretendard" pitchFamily="34" charset="-120"/>
+                        </a:rPr>
+                        <a:t>후 </a:t>
+                      </a:r>
+                      <a:pPr indent="0" marL="0">
+                        <a:buNone/>
+                      </a:pPr>
+                      <a:r>
+                        <a:rPr lang="en-US" sz="1050" dirty="0">
+                          <a:solidFill>
+                            <a:srgbClr val="10161F"/>
+                          </a:solidFill>
+                          <a:latin typeface="Pretendard" pitchFamily="34" charset="0"/>
+                          <a:ea typeface="Pretendard" pitchFamily="34" charset="-122"/>
+                          <a:cs typeface="Pretendard" pitchFamily="34" charset="-120"/>
+                        </a:rPr>
+                        <a:t>매각 </a:t>
+                      </a:r>
+                      <a:pPr indent="0" marL="0">
+                        <a:buNone/>
+                      </a:pPr>
+                      <a:r>
+                        <a:rPr lang="en-US" sz="1050" dirty="0">
+                          <a:solidFill>
+                            <a:srgbClr val="10161F"/>
+                          </a:solidFill>
+                          <a:latin typeface="Pretendard" pitchFamily="34" charset="0"/>
+                          <a:ea typeface="Pretendard" pitchFamily="34" charset="-122"/>
+                          <a:cs typeface="Pretendard" pitchFamily="34" charset="-120"/>
+                        </a:rPr>
+                        <a:t>시나리오</a:t>
+                      </a:r>
+                      <a:endParaRPr lang="en-US" sz="1050" dirty="0">
+                        <a:latin typeface="Pretendard" charset="0"/>
+                        <a:ea typeface="Pretendard" charset="0"/>
+                        <a:cs typeface="Pretendard" charset="0"/>
+                      </a:endParaRPr>
+                    </a:p>
+                  </a:txBody>
+                  <a:tcPr marL="50800" marR="50800" marT="25400" marB="25400" anchor="ctr">
+                    <a:lnL w="3810" cap="flat" cmpd="sng" algn="ctr">
+                      <a:solidFill>
+                        <a:srgbClr val="CBD5E0"/>
+                      </a:solidFill>
+                      <a:prstDash val="solid"/>
+                      <a:round/>
+                      <a:headEnd type="none" w="med" len="med"/>
+                      <a:tailEnd type="none" w="med" len="med"/>
+                    </a:lnL>
+                    <a:lnR w="3810" cap="flat" cmpd="sng" algn="ctr">
+                      <a:solidFill>
+                        <a:srgbClr val="CBD5E0"/>
+                      </a:solidFill>
+                      <a:prstDash val="solid"/>
+                      <a:round/>
+                      <a:headEnd type="none" w="med" len="med"/>
+                      <a:tailEnd type="none" w="med" len="med"/>
+                    </a:lnR>
+                    <a:lnT w="3810" cap="flat" cmpd="sng" algn="ctr">
+                      <a:solidFill>
+                        <a:srgbClr val="CBD5E0"/>
+                      </a:solidFill>
+                      <a:prstDash val="solid"/>
+                      <a:round/>
+                      <a:headEnd type="none" w="med" len="med"/>
+                      <a:tailEnd type="none" w="med" len="med"/>
+                    </a:lnT>
+                    <a:lnB w="3810" cap="flat" cmpd="sng" algn="ctr">
+                      <a:solidFill>
+                        <a:srgbClr val="CBD5E0"/>
+                      </a:solidFill>
+                      <a:prstDash val="solid"/>
+                      <a:round/>
+                      <a:headEnd type="none" w="med" len="med"/>
+                      <a:tailEnd type="none" w="med" len="med"/>
+                    </a:lnB>
+                    <a:solidFill>
+                      <a:srgbClr val="FFFFFF"/>
+                    </a:solidFill>
+                  </a:tcPr>
+                </a:tc>
+              </a:tr>
+            </a:tbl>
+          </a:graphicData>
+        </a:graphic>
+      </p:graphicFrame>
+      <p:sp>
+        <p:nvSpPr>
+          <p:cNvPr id="21" name="Shape 18"/>
+          <p:cNvSpPr/>
+          <p:nvPr/>
+        </p:nvSpPr>
+        <p:spPr>
+          <a:xfrm>
+            <a:off x="566928" y="5522976"/>
+            <a:ext cx="11057839" cy="804672"/>
+          </a:xfrm>
+          <a:prstGeom prst="roundRect">
+            <a:avLst>
+              <a:gd name="adj" fmla="val 6818"/>
+            </a:avLst>
+          </a:prstGeom>
+          <a:solidFill>
+            <a:srgbClr val="F3EBDA"/>
+          </a:solidFill>
+          <a:ln w="10160">
+            <a:solidFill>
+              <a:srgbClr val="D9B668"/>
+            </a:solidFill>
+            <a:prstDash val="solid"/>
+          </a:ln>
+        </p:spPr>
+      </p:sp>
+      <p:sp>
+        <p:nvSpPr>
+          <p:cNvPr id="22" name="Text 19"/>
+          <p:cNvSpPr/>
+          <p:nvPr/>
+        </p:nvSpPr>
+        <p:spPr>
+          <a:xfrm>
+            <a:off x="749808" y="5632704"/>
+            <a:ext cx="1691640" cy="256032"/>
+          </a:xfrm>
+          <a:prstGeom prst="rect">
+            <a:avLst/>
+          </a:prstGeom>
+          <a:noFill/>
+          <a:ln/>
+        </p:spPr>
+        <p:txBody>
+          <a:bodyPr wrap="square" lIns="0" tIns="0" rIns="0" bIns="0" rtlCol="0" anchor="ctr"/>
           <a:lstStyle/>
           <a:p>
             <a:pPr indent="0" marL="0">
               <a:buNone/>
             </a:pPr>
             <a:r>
-              <a:rPr lang="en-US" sz="1100" dirty="0">
-                <a:solidFill>
-                  <a:srgbClr val="10161F"/>
+              <a:rPr lang="en-US" sz="1050" b="1" dirty="0">
+                <a:solidFill>
+                  <a:srgbClr val="977024"/>
                 </a:solidFill>
                 <a:latin typeface="Pretendard" pitchFamily="34" charset="0"/>
                 <a:ea typeface="Pretendard" pitchFamily="34" charset="-122"/>
                 <a:cs typeface="Pretendard" pitchFamily="34" charset="-120"/>
               </a:rPr>
-              <a:t>NDA 체결 → 임차인 정보 및 임대차계약서 제공</a:t>
-            </a:r>
-            <a:endParaRPr lang="en-US" sz="1100" dirty="0"/>
-          </a:p>
-        </p:txBody>
-      </p:sp>
-      <p:sp>
-        <p:nvSpPr>
-          <p:cNvPr id="17" name="Shape 15"/>
-          <p:cNvSpPr/>
-          <p:nvPr/>
-        </p:nvSpPr>
-        <p:spPr>
-          <a:xfrm>
-            <a:off x="6004408" y="3035808"/>
-            <a:ext cx="182880" cy="274320"/>
-          </a:xfrm>
-          <a:prstGeom prst="rightArrow">
-            <a:avLst/>
-          </a:prstGeom>
-          <a:solidFill>
-            <a:srgbClr val="CBD5E0"/>
-          </a:solidFill>
-          <a:ln w="6350">
-            <a:solidFill>
-              <a:srgbClr val="718096"/>
-            </a:solidFill>
-            <a:prstDash val="solid"/>
-          </a:ln>
-        </p:spPr>
-      </p:sp>
-      <p:sp>
-        <p:nvSpPr>
-          <p:cNvPr id="18" name="Shape 16"/>
-          <p:cNvSpPr/>
-          <p:nvPr/>
-        </p:nvSpPr>
-        <p:spPr>
-          <a:xfrm>
-            <a:off x="6278728" y="1572768"/>
-            <a:ext cx="2490140" cy="3200400"/>
-          </a:xfrm>
-          <a:prstGeom prst="roundRect">
-            <a:avLst>
-              <a:gd name="adj" fmla="val 2203"/>
-            </a:avLst>
-          </a:prstGeom>
-          <a:solidFill>
-            <a:srgbClr val="F7FAFC"/>
-          </a:solidFill>
-          <a:ln w="6350">
-            <a:solidFill>
-              <a:srgbClr val="CBD5E0"/>
-            </a:solidFill>
-            <a:prstDash val="solid"/>
-          </a:ln>
-        </p:spPr>
-      </p:sp>
-      <p:sp>
-        <p:nvSpPr>
-          <p:cNvPr id="19" name="Shape 17"/>
-          <p:cNvSpPr/>
-          <p:nvPr/>
-        </p:nvSpPr>
-        <p:spPr>
-          <a:xfrm>
-            <a:off x="6498184" y="1792224"/>
-            <a:ext cx="438912" cy="438912"/>
-          </a:xfrm>
-          <a:prstGeom prst="ellipse">
-            <a:avLst/>
-          </a:prstGeom>
-          <a:solidFill>
-            <a:srgbClr val="B98A2E"/>
-          </a:solidFill>
-          <a:ln/>
-        </p:spPr>
-      </p:sp>
-      <p:sp>
-        <p:nvSpPr>
-          <p:cNvPr id="20" name="Text 18"/>
-          <p:cNvSpPr/>
-          <p:nvPr/>
-        </p:nvSpPr>
-        <p:spPr>
-          <a:xfrm>
-            <a:off x="6498184" y="1792224"/>
-            <a:ext cx="438912" cy="438912"/>
-          </a:xfrm>
-          <a:prstGeom prst="rect">
-            <a:avLst/>
-          </a:prstGeom>
-          <a:noFill/>
-          <a:ln/>
-        </p:spPr>
-        <p:txBody>
-          <a:bodyPr wrap="square" lIns="0" tIns="0" rIns="0" bIns="0" rtlCol="0" anchor="ctr"/>
-          <a:lstStyle/>
-          <a:p>
-            <a:pPr algn="ctr" indent="0" marL="0">
-              <a:buNone/>
-            </a:pPr>
-            <a:r>
-              <a:rPr lang="en-US" sz="1400" b="1" dirty="0">
-                <a:solidFill>
-                  <a:srgbClr val="FFFFFF"/>
-                </a:solidFill>
-                <a:latin typeface="Arial" pitchFamily="34" charset="0"/>
-                <a:ea typeface="Arial" pitchFamily="34" charset="-122"/>
-                <a:cs typeface="Arial" pitchFamily="34" charset="-120"/>
-              </a:rPr>
-              <a:t>03</a:t>
-            </a:r>
-            <a:endParaRPr lang="en-US" sz="1400" dirty="0"/>
-          </a:p>
-        </p:txBody>
-      </p:sp>
-      <p:sp>
-        <p:nvSpPr>
-          <p:cNvPr id="21" name="Text 19"/>
-          <p:cNvSpPr/>
-          <p:nvPr/>
-        </p:nvSpPr>
-        <p:spPr>
-          <a:xfrm>
-            <a:off x="6498184" y="2304288"/>
-            <a:ext cx="2051228" cy="365760"/>
-          </a:xfrm>
-          <a:prstGeom prst="rect">
-            <a:avLst/>
-          </a:prstGeom>
-          <a:noFill/>
-          <a:ln/>
-        </p:spPr>
-        <p:txBody>
-          <a:bodyPr wrap="square" rtlCol="0" anchor="ctr"/>
+              <a:t>종합 가치 제안</a:t>
+            </a:r>
+            <a:endParaRPr lang="en-US" sz="1050" dirty="0"/>
+          </a:p>
+        </p:txBody>
+      </p:sp>
+      <p:sp>
+        <p:nvSpPr>
+          <p:cNvPr id="23" name="Text 20"/>
+          <p:cNvSpPr/>
+          <p:nvPr/>
+        </p:nvSpPr>
+        <p:spPr>
+          <a:xfrm>
+            <a:off x="2487168" y="5596128"/>
+            <a:ext cx="8954719" cy="658368"/>
+          </a:xfrm>
+          <a:prstGeom prst="rect">
+            <a:avLst/>
+          </a:prstGeom>
+          <a:noFill/>
+          <a:ln/>
+        </p:spPr>
+        <p:txBody>
+          <a:bodyPr wrap="square" lIns="0" tIns="0" rIns="0" bIns="0" rtlCol="0" anchor="ctr"/>
           <a:lstStyle/>
           <a:p>
             <a:pPr indent="0" marL="0">
-              <a:buNone/>
-            </a:pPr>
-            <a:r>
-              <a:rPr lang="en-US" sz="1600" b="1" dirty="0">
+              <a:lnSpc>
+                <a:spcPct val="125000"/>
+              </a:lnSpc>
+              <a:buNone/>
+            </a:pPr>
+            <a:r>
+              <a:rPr lang="en-US" sz="1100" dirty="0">
                 <a:solidFill>
                   <a:srgbClr val="10161F"/>
                 </a:solidFill>
@@ -9731,273 +10682,45 @@
                 <a:ea typeface="Pretendard" pitchFamily="34" charset="-122"/>
                 <a:cs typeface="Pretendard" pitchFamily="34" charset="-120"/>
               </a:rPr>
-              <a:t>3단계</a:t>
-            </a:r>
-            <a:endParaRPr lang="en-US" sz="1600" dirty="0"/>
-          </a:p>
-        </p:txBody>
-      </p:sp>
-      <p:sp>
-        <p:nvSpPr>
-          <p:cNvPr id="22" name="Text 20"/>
-          <p:cNvSpPr/>
-          <p:nvPr/>
-        </p:nvSpPr>
-        <p:spPr>
-          <a:xfrm>
-            <a:off x="6498184" y="2761488"/>
-            <a:ext cx="2051228" cy="1828800"/>
-          </a:xfrm>
-          <a:prstGeom prst="rect">
-            <a:avLst/>
-          </a:prstGeom>
-          <a:noFill/>
-          <a:ln/>
-        </p:spPr>
-        <p:txBody>
-          <a:bodyPr wrap="square" rtlCol="0" anchor="t"/>
+              <a:t>[참고] 종합 가치 제안: 강남권역 소재 신축부지으로, 입지 및 자산 특성에 대한 상세 분석은 본문을 참조하시기 바랍니다. ### 3대 핵심 투자 포인트 (Investment Highlights) • 원금 안전판 확보: 강남권역 소재 자산으로, 대지 지분 가치 및 입지 경쟁력에 대한 분석은 자산 개요 섹션을 참조하시기 바랍니다.</a:t>
+            </a:r>
+            <a:endParaRPr lang="en-US" sz="1100" dirty="0"/>
+          </a:p>
+        </p:txBody>
+      </p:sp>
+      <p:sp>
+        <p:nvSpPr>
+          <p:cNvPr id="24" name="Text 21"/>
+          <p:cNvSpPr/>
+          <p:nvPr/>
+        </p:nvSpPr>
+        <p:spPr>
+          <a:xfrm>
+            <a:off x="566928" y="6382512"/>
+            <a:ext cx="7315200" cy="219456"/>
+          </a:xfrm>
+          <a:prstGeom prst="rect">
+            <a:avLst/>
+          </a:prstGeom>
+          <a:noFill/>
+          <a:ln/>
+        </p:spPr>
+        <p:txBody>
+          <a:bodyPr wrap="square" lIns="0" tIns="0" rIns="0" bIns="0" rtlCol="0" anchor="ctr"/>
           <a:lstStyle/>
           <a:p>
             <a:pPr indent="0" marL="0">
               <a:buNone/>
             </a:pPr>
             <a:r>
-              <a:rPr lang="en-US" sz="1100" dirty="0">
-                <a:solidFill>
-                  <a:srgbClr val="10161F"/>
+              <a:rPr lang="en-US" sz="800" dirty="0">
+                <a:solidFill>
+                  <a:srgbClr val="718096"/>
                 </a:solidFill>
                 <a:latin typeface="Pretendard" pitchFamily="34" charset="0"/>
                 <a:ea typeface="Pretendard" pitchFamily="34" charset="-122"/>
                 <a:cs typeface="Pretendard" pitchFamily="34" charset="-120"/>
               </a:rPr>
-              <a:t>현장 실사 일정 조율 → 건물 컨디션 및 설비 직접 확인</a:t>
-            </a:r>
-            <a:endParaRPr lang="en-US" sz="1100" dirty="0"/>
-          </a:p>
-        </p:txBody>
-      </p:sp>
-      <p:sp>
-        <p:nvSpPr>
-          <p:cNvPr id="23" name="Shape 21"/>
-          <p:cNvSpPr/>
-          <p:nvPr/>
-        </p:nvSpPr>
-        <p:spPr>
-          <a:xfrm>
-            <a:off x="8860307" y="3035808"/>
-            <a:ext cx="182880" cy="274320"/>
-          </a:xfrm>
-          <a:prstGeom prst="rightArrow">
-            <a:avLst/>
-          </a:prstGeom>
-          <a:solidFill>
-            <a:srgbClr val="CBD5E0"/>
-          </a:solidFill>
-          <a:ln w="6350">
-            <a:solidFill>
-              <a:srgbClr val="718096"/>
-            </a:solidFill>
-            <a:prstDash val="solid"/>
-          </a:ln>
-        </p:spPr>
-      </p:sp>
-      <p:sp>
-        <p:nvSpPr>
-          <p:cNvPr id="24" name="Shape 22"/>
-          <p:cNvSpPr/>
-          <p:nvPr/>
-        </p:nvSpPr>
-        <p:spPr>
-          <a:xfrm>
-            <a:off x="9134627" y="1572768"/>
-            <a:ext cx="2490140" cy="3200400"/>
-          </a:xfrm>
-          <a:prstGeom prst="roundRect">
-            <a:avLst>
-              <a:gd name="adj" fmla="val 2203"/>
-            </a:avLst>
-          </a:prstGeom>
-          <a:solidFill>
-            <a:srgbClr val="F7FAFC"/>
-          </a:solidFill>
-          <a:ln w="6350">
-            <a:solidFill>
-              <a:srgbClr val="CBD5E0"/>
-            </a:solidFill>
-            <a:prstDash val="solid"/>
-          </a:ln>
-        </p:spPr>
-      </p:sp>
-      <p:sp>
-        <p:nvSpPr>
-          <p:cNvPr id="25" name="Shape 23"/>
-          <p:cNvSpPr/>
-          <p:nvPr/>
-        </p:nvSpPr>
-        <p:spPr>
-          <a:xfrm>
-            <a:off x="9354083" y="1792224"/>
-            <a:ext cx="438912" cy="438912"/>
-          </a:xfrm>
-          <a:prstGeom prst="ellipse">
-            <a:avLst/>
-          </a:prstGeom>
-          <a:solidFill>
-            <a:srgbClr val="B98A2E"/>
-          </a:solidFill>
-          <a:ln/>
-        </p:spPr>
-      </p:sp>
-      <p:sp>
-        <p:nvSpPr>
-          <p:cNvPr id="26" name="Text 24"/>
-          <p:cNvSpPr/>
-          <p:nvPr/>
-        </p:nvSpPr>
-        <p:spPr>
-          <a:xfrm>
-            <a:off x="9354083" y="1792224"/>
-            <a:ext cx="438912" cy="438912"/>
-          </a:xfrm>
-          <a:prstGeom prst="rect">
-            <a:avLst/>
-          </a:prstGeom>
-          <a:noFill/>
-          <a:ln/>
-        </p:spPr>
-        <p:txBody>
-          <a:bodyPr wrap="square" lIns="0" tIns="0" rIns="0" bIns="0" rtlCol="0" anchor="ctr"/>
-          <a:lstStyle/>
-          <a:p>
-            <a:pPr algn="ctr" indent="0" marL="0">
-              <a:buNone/>
-            </a:pPr>
-            <a:r>
-              <a:rPr lang="en-US" sz="1400" b="1" dirty="0">
-                <a:solidFill>
-                  <a:srgbClr val="FFFFFF"/>
-                </a:solidFill>
-                <a:latin typeface="Arial" pitchFamily="34" charset="0"/>
-                <a:ea typeface="Arial" pitchFamily="34" charset="-122"/>
-                <a:cs typeface="Arial" pitchFamily="34" charset="-120"/>
-              </a:rPr>
-              <a:t>04</a:t>
-            </a:r>
-            <a:endParaRPr lang="en-US" sz="1400" dirty="0"/>
-          </a:p>
-        </p:txBody>
-      </p:sp>
-      <p:sp>
-        <p:nvSpPr>
-          <p:cNvPr id="27" name="Text 25"/>
-          <p:cNvSpPr/>
-          <p:nvPr/>
-        </p:nvSpPr>
-        <p:spPr>
-          <a:xfrm>
-            <a:off x="9354083" y="2304288"/>
-            <a:ext cx="2051228" cy="365760"/>
-          </a:xfrm>
-          <a:prstGeom prst="rect">
-            <a:avLst/>
-          </a:prstGeom>
-          <a:noFill/>
-          <a:ln/>
-        </p:spPr>
-        <p:txBody>
-          <a:bodyPr wrap="square" rtlCol="0" anchor="ctr"/>
-          <a:lstStyle/>
-          <a:p>
-            <a:pPr indent="0" marL="0">
-              <a:buNone/>
-            </a:pPr>
-            <a:r>
-              <a:rPr lang="en-US" sz="1600" b="1" dirty="0">
-                <a:solidFill>
-                  <a:srgbClr val="10161F"/>
-                </a:solidFill>
-                <a:latin typeface="Pretendard" pitchFamily="34" charset="0"/>
-                <a:ea typeface="Pretendard" pitchFamily="34" charset="-122"/>
-                <a:cs typeface="Pretendard" pitchFamily="34" charset="-120"/>
-              </a:rPr>
-              <a:t>4단계</a:t>
-            </a:r>
-            <a:endParaRPr lang="en-US" sz="1600" dirty="0"/>
-          </a:p>
-        </p:txBody>
-      </p:sp>
-      <p:sp>
-        <p:nvSpPr>
-          <p:cNvPr id="28" name="Text 26"/>
-          <p:cNvSpPr/>
-          <p:nvPr/>
-        </p:nvSpPr>
-        <p:spPr>
-          <a:xfrm>
-            <a:off x="9354083" y="2761488"/>
-            <a:ext cx="2051228" cy="1828800"/>
-          </a:xfrm>
-          <a:prstGeom prst="rect">
-            <a:avLst/>
-          </a:prstGeom>
-          <a:noFill/>
-          <a:ln/>
-        </p:spPr>
-        <p:txBody>
-          <a:bodyPr wrap="square" rtlCol="0" anchor="t"/>
-          <a:lstStyle/>
-          <a:p>
-            <a:pPr indent="0" marL="0">
-              <a:buNone/>
-            </a:pPr>
-            <a:r>
-              <a:rPr lang="en-US" sz="1100" dirty="0">
-                <a:solidFill>
-                  <a:srgbClr val="10161F"/>
-                </a:solidFill>
-                <a:latin typeface="Pretendard" pitchFamily="34" charset="0"/>
-                <a:ea typeface="Pretendard" pitchFamily="34" charset="-122"/>
-                <a:cs typeface="Pretendard" pitchFamily="34" charset="-120"/>
-              </a:rPr>
-              <a:t>LOI(투자의향서) 제출 → 가격 협의 개시</a:t>
-            </a:r>
-            <a:endParaRPr lang="en-US" sz="1100" dirty="0"/>
-          </a:p>
-        </p:txBody>
-      </p:sp>
-      <p:sp>
-        <p:nvSpPr>
-          <p:cNvPr id="29" name="Text 27"/>
-          <p:cNvSpPr/>
-          <p:nvPr/>
-        </p:nvSpPr>
-        <p:spPr>
-          <a:xfrm>
-            <a:off x="566928" y="6382512"/>
-            <a:ext cx="7315200" cy="219456"/>
-          </a:xfrm>
-          <a:prstGeom prst="rect">
-            <a:avLst/>
-          </a:prstGeom>
-          <a:noFill/>
-          <a:ln/>
-        </p:spPr>
-        <p:txBody>
-          <a:bodyPr wrap="square" lIns="0" tIns="0" rIns="0" bIns="0" rtlCol="0" anchor="ctr"/>
-          <a:lstStyle/>
-          <a:p>
-            <a:pPr indent="0" marL="0">
-              <a:buNone/>
-            </a:pPr>
-            <a:r>
-              <a:rPr lang="en-US" sz="800" dirty="0">
-                <a:solidFill>
-                  <a:srgbClr val="718096"/>
-                </a:solidFill>
-                <a:latin typeface="Pretendard" pitchFamily="34" charset="0"/>
-                <a:ea typeface="Pretendard" pitchFamily="34" charset="-122"/>
-                <a:cs typeface="Pretendard" pitchFamily="34" charset="-120"/>
-              </a:rPr>
               <a:t>크리딜   |   </a:t>
             </a:r>
             <a:endParaRPr lang="en-US" sz="800" dirty="0"/>
@@ -10006,7 +10729,7 @@
       </p:sp>
       <p:sp>
         <p:nvSpPr>
-          <p:cNvPr id="30" name="Text 28"/>
+          <p:cNvPr id="25" name="Text 22"/>
           <p:cNvSpPr/>
           <p:nvPr/>
         </p:nvSpPr>

</xml_diff>

<commit_message>
Stage 1: fix all 64 failing tests -> 0 failed (2459/2459 pass)
</commit_message>
<xml_diff>
--- a/docs/test/stress/e2e-outputs/development_case12_yeoksam_dev_basic.pptx
+++ b/docs/test/stress/e2e-outputs/development_case12_yeoksam_dev_basic.pptx
@@ -4762,130 +4762,7 @@
       </p:sp>
       <p:sp>
         <p:nvSpPr>
-          <p:cNvPr id="10" name="Shape 8"/>
-          <p:cNvSpPr/>
-          <p:nvPr/>
-        </p:nvSpPr>
-        <p:spPr>
-          <a:xfrm>
-            <a:off x="566928" y="2999232"/>
-            <a:ext cx="11057839" cy="1280160"/>
-          </a:xfrm>
-          <a:prstGeom prst="roundRect">
-            <a:avLst>
-              <a:gd name="adj" fmla="val 4286"/>
-            </a:avLst>
-          </a:prstGeom>
-          <a:solidFill>
-            <a:srgbClr val="BEE3F8"/>
-          </a:solidFill>
-          <a:ln/>
-        </p:spPr>
-      </p:sp>
-      <p:sp>
-        <p:nvSpPr>
-          <p:cNvPr id="11" name="Shape 9"/>
-          <p:cNvSpPr/>
-          <p:nvPr/>
-        </p:nvSpPr>
-        <p:spPr>
-          <a:xfrm>
-            <a:off x="566928" y="3054096"/>
-            <a:ext cx="36576" cy="1170432"/>
-          </a:xfrm>
-          <a:prstGeom prst="rect">
-            <a:avLst/>
-          </a:prstGeom>
-          <a:solidFill>
-            <a:srgbClr val="2B6CB0"/>
-          </a:solidFill>
-          <a:ln/>
-        </p:spPr>
-      </p:sp>
-      <p:sp>
-        <p:nvSpPr>
-          <p:cNvPr id="12" name="Text 10"/>
-          <p:cNvSpPr/>
-          <p:nvPr/>
-        </p:nvSpPr>
-        <p:spPr>
-          <a:xfrm>
-            <a:off x="749808" y="3108960"/>
-            <a:ext cx="10728655" cy="201168"/>
-          </a:xfrm>
-          <a:prstGeom prst="rect">
-            <a:avLst/>
-          </a:prstGeom>
-          <a:noFill/>
-          <a:ln/>
-        </p:spPr>
-        <p:txBody>
-          <a:bodyPr wrap="square" lIns="0" tIns="0" rIns="0" bIns="0" rtlCol="0" anchor="ctr"/>
-          <a:lstStyle/>
-          <a:p>
-            <a:pPr indent="0" marL="0">
-              <a:buNone/>
-            </a:pPr>
-            <a:r>
-              <a:rPr lang="en-US" sz="1050" b="1" dirty="0">
-                <a:solidFill>
-                  <a:srgbClr val="2B6CB0"/>
-                </a:solidFill>
-                <a:latin typeface="Pretendard" pitchFamily="34" charset="0"/>
-                <a:ea typeface="Pretendard" pitchFamily="34" charset="-122"/>
-                <a:cs typeface="Pretendard" pitchFamily="34" charset="-120"/>
-              </a:rPr>
-              <a:t>신축 건축 규모 요약</a:t>
-            </a:r>
-            <a:endParaRPr lang="en-US" sz="1050" dirty="0"/>
-          </a:p>
-        </p:txBody>
-      </p:sp>
-      <p:sp>
-        <p:nvSpPr>
-          <p:cNvPr id="13" name="Text 11"/>
-          <p:cNvSpPr/>
-          <p:nvPr/>
-        </p:nvSpPr>
-        <p:spPr>
-          <a:xfrm>
-            <a:off x="749808" y="3328416"/>
-            <a:ext cx="10728655" cy="877824"/>
-          </a:xfrm>
-          <a:prstGeom prst="rect">
-            <a:avLst/>
-          </a:prstGeom>
-          <a:noFill/>
-          <a:ln/>
-        </p:spPr>
-        <p:txBody>
-          <a:bodyPr wrap="square" lIns="0" tIns="0" rIns="0" bIns="0" rtlCol="0" anchor="t"/>
-          <a:lstStyle/>
-          <a:p>
-            <a:pPr indent="0" marL="0">
-              <a:lnSpc>
-                <a:spcPct val="120000"/>
-              </a:lnSpc>
-              <a:buNone/>
-            </a:pPr>
-            <a:r>
-              <a:rPr lang="en-US" sz="930" dirty="0">
-                <a:solidFill>
-                  <a:srgbClr val="10161F"/>
-                </a:solidFill>
-                <a:latin typeface="Pretendard" pitchFamily="34" charset="0"/>
-                <a:ea typeface="Pretendard" pitchFamily="34" charset="-122"/>
-                <a:cs typeface="Pretendard" pitchFamily="34" charset="-120"/>
-              </a:rPr>
-              <a:t>{"ok":true,"mocked":true,"extractedFields":{"area_signal":"역삼","asset_type":"[건물명 비공개]","price_band":"300억","size_signal":"3000평(약 9917.4㎡)"},"extractedFacts":{"region":"역삼","exactAddressCandidate":"역삼동 742-1","assetType":"[건물명 비공개]","priceText":"300억","sizeText":"3000평(약 9917.4㎡)","currentUse":"오피스","currentUseSignal":"근린생활시설","leaseSignal":"임대중","vacancySignal":"공실없음","tenantNames":["쿠팡","네이버"],"unitRentTexts":["301호: 1500만"],"sellerMotivationText":"자산 효율화","brokerNotes":["역세권 도보 3분 이내 매물"]},"detectedSensitiveFields":["exact_address","tenant_name"],"ambiguousFields":[],"warnings":[],"areaSignal":"역삼","assetType":"[건물명 비공개]","priceBand":"300억","sizeSignal":"3000평(약 9917.4㎡)","dealType":"매각","buildingName":"역삼 [건물명 비공개]","exactAddress":"역삼동 742-1","totalFloorArea":9917.3,"buildYear":2015,"currentUseSignal":"근린생활시설","vacancySignal":"공실 없음","fitSummary":"역세권 도보 3분 이내 근생 빌딩으로 시행/사옥 매입에 최적화","cautionSummary":"주요 임차인 만기 조율 필요","hiddenFields":["exact_address","seller_motivation"],"confidence":{"areaSignal":"confirmed","assetType":"confirmed","priceBand":"ai_hypothesis","fitSummary":"ai_hypothesis"},"missingData":["sizeSignal"],"boundaryNote":"본 자료는 실거래 통계 기반 참고치입니다.","buyerType":"법인 사옥형","budgetRange":{"min":50,"max":80,"display":"50억~80억"},"preferredRegions":["강남","성수"],"assetTypes":["[건물명 비공개]","사옥용"],"purchasePurpose":"사옥용 매입","mustHave":["역세권 도보 3분 이내","주차"],"niceToHave":["테라스","루프탑"],"riskTolerance":"medium","financingNote":"자본금 50% 준비","missingQuestions":["구체적인 입주 시기가 언제인가요?","선호하는 수익률이 있나요?"],"privacyNotes":["연락처 비공개"],"fitReasons":["매수자 예산(50-80억)에 부합하는 매물입니다.","요청하신 성수/강남 권역에 해당합니다."],"cautionReasons":["요청한 용도와 달리 명도 협의가 다소 필요합니다."],"recommendedNextAction":"현장 답사 제안","kakaoMessage":"안녕하세요! 요청하신 조건에 부합하는 추천 매물이 있어 안내해 드립니다. 확인해보시고 피드백 부탁드립니다.","title":"강남 역삼역 역세권 도보 3분 이내 오피스 사옥용 빌딩 매각","shortSummary":"역삼역 도보 5분 거리의 준신축급 대형 [건물명 비공개]입니다.","dealPoints":["역세권 도보 3분 이내","사옥 최적"],"cautionPoints":["명도 조율 필요"],"hiddenInfoNotice":["보증금 및 지번은 인가 후 확인 가능"],"gateMessage":"G1 등급 등록이 필요합니다.","kakaoText":"강남 역삼역 오피스 빌딩 매각 안내입니다.","exactUnitCandidate":"101호","floor":"1층","areaSqmText":"150㎡","spaceType":"office","depositText":"5000만","monthlyRentText":"400만","maintenanceFeeText":"50만","availableFromText":"즉시입주","leaseTermMonthsText":"24","incentivesText":"렌트프리(무상임대) 2개월","restrictions":[],"landlordIdentity":"김성수","currentTenant":"스타트업","vacancyReason":"이전 확장","rentNegotiation":"협의 가능","region":"성수동","areaSqm":150,"deposit":5000,"monthlyRent":400,"maintenanceFee":50,"availableFrom":"즉시입주","leaseTermMonths":24,"incentives":{"렌트프리(무상임대)(무상임대)Months":2,"interiorSupport":"일부 인테리어 지원","freeRentDetail":"렌트프리(무상임대) 2개월 지원"},"shortSummaryLease":"성수역 도보 5분 거리 1층 리테일 상가 매물입니다."}</a:t>
-            </a:r>
-            <a:endParaRPr lang="en-US" sz="930" dirty="0"/>
-          </a:p>
-        </p:txBody>
-      </p:sp>
-      <p:sp>
-        <p:nvSpPr>
-          <p:cNvPr id="14" name="Text 12"/>
+          <p:cNvPr id="10" name="Text 8"/>
           <p:cNvSpPr/>
           <p:nvPr/>
         </p:nvSpPr>
@@ -4924,7 +4801,7 @@
       </p:sp>
       <p:sp>
         <p:nvSpPr>
-          <p:cNvPr id="15" name="Text 13"/>
+          <p:cNvPr id="11" name="Text 9"/>
           <p:cNvSpPr/>
           <p:nvPr/>
         </p:nvSpPr>
@@ -13013,130 +12890,7 @@
       </p:sp>
       <p:sp>
         <p:nvSpPr>
-          <p:cNvPr id="10" name="Shape 8"/>
-          <p:cNvSpPr/>
-          <p:nvPr/>
-        </p:nvSpPr>
-        <p:spPr>
-          <a:xfrm>
-            <a:off x="566928" y="2999232"/>
-            <a:ext cx="11057839" cy="1280160"/>
-          </a:xfrm>
-          <a:prstGeom prst="roundRect">
-            <a:avLst>
-              <a:gd name="adj" fmla="val 4286"/>
-            </a:avLst>
-          </a:prstGeom>
-          <a:solidFill>
-            <a:srgbClr val="BEE3F8"/>
-          </a:solidFill>
-          <a:ln/>
-        </p:spPr>
-      </p:sp>
-      <p:sp>
-        <p:nvSpPr>
-          <p:cNvPr id="11" name="Shape 9"/>
-          <p:cNvSpPr/>
-          <p:nvPr/>
-        </p:nvSpPr>
-        <p:spPr>
-          <a:xfrm>
-            <a:off x="566928" y="3054096"/>
-            <a:ext cx="36576" cy="1170432"/>
-          </a:xfrm>
-          <a:prstGeom prst="rect">
-            <a:avLst/>
-          </a:prstGeom>
-          <a:solidFill>
-            <a:srgbClr val="2B6CB0"/>
-          </a:solidFill>
-          <a:ln/>
-        </p:spPr>
-      </p:sp>
-      <p:sp>
-        <p:nvSpPr>
-          <p:cNvPr id="12" name="Text 10"/>
-          <p:cNvSpPr/>
-          <p:nvPr/>
-        </p:nvSpPr>
-        <p:spPr>
-          <a:xfrm>
-            <a:off x="749808" y="3108960"/>
-            <a:ext cx="10728655" cy="201168"/>
-          </a:xfrm>
-          <a:prstGeom prst="rect">
-            <a:avLst/>
-          </a:prstGeom>
-          <a:noFill/>
-          <a:ln/>
-        </p:spPr>
-        <p:txBody>
-          <a:bodyPr wrap="square" lIns="0" tIns="0" rIns="0" bIns="0" rtlCol="0" anchor="ctr"/>
-          <a:lstStyle/>
-          <a:p>
-            <a:pPr indent="0" marL="0">
-              <a:buNone/>
-            </a:pPr>
-            <a:r>
-              <a:rPr lang="en-US" sz="1050" b="1" dirty="0">
-                <a:solidFill>
-                  <a:srgbClr val="2B6CB0"/>
-                </a:solidFill>
-                <a:latin typeface="Pretendard" pitchFamily="34" charset="0"/>
-                <a:ea typeface="Pretendard" pitchFamily="34" charset="-122"/>
-                <a:cs typeface="Pretendard" pitchFamily="34" charset="-120"/>
-              </a:rPr>
-              <a:t>신축 건축 규모 요약</a:t>
-            </a:r>
-            <a:endParaRPr lang="en-US" sz="1050" dirty="0"/>
-          </a:p>
-        </p:txBody>
-      </p:sp>
-      <p:sp>
-        <p:nvSpPr>
-          <p:cNvPr id="13" name="Text 11"/>
-          <p:cNvSpPr/>
-          <p:nvPr/>
-        </p:nvSpPr>
-        <p:spPr>
-          <a:xfrm>
-            <a:off x="749808" y="3328416"/>
-            <a:ext cx="10728655" cy="877824"/>
-          </a:xfrm>
-          <a:prstGeom prst="rect">
-            <a:avLst/>
-          </a:prstGeom>
-          <a:noFill/>
-          <a:ln/>
-        </p:spPr>
-        <p:txBody>
-          <a:bodyPr wrap="square" lIns="0" tIns="0" rIns="0" bIns="0" rtlCol="0" anchor="t"/>
-          <a:lstStyle/>
-          <a:p>
-            <a:pPr indent="0" marL="0">
-              <a:lnSpc>
-                <a:spcPct val="120000"/>
-              </a:lnSpc>
-              <a:buNone/>
-            </a:pPr>
-            <a:r>
-              <a:rPr lang="en-US" sz="930" dirty="0">
-                <a:solidFill>
-                  <a:srgbClr val="10161F"/>
-                </a:solidFill>
-                <a:latin typeface="Pretendard" pitchFamily="34" charset="0"/>
-                <a:ea typeface="Pretendard" pitchFamily="34" charset="-122"/>
-                <a:cs typeface="Pretendard" pitchFamily="34" charset="-120"/>
-              </a:rPr>
-              <a:t>{"ok":true,"mocked":true,"extractedFields":{"area_signal":"역삼","asset_type":"[건물명 비공개]","price_band":"300억","size_signal":"3000평(약 9917.4㎡)"},"extractedFacts":{"region":"역삼","exactAddressCandidate":"역삼동 742-1","assetType":"[건물명 비공개]","priceText":"300억","sizeText":"3000평(약 9917.4㎡)","currentUse":"오피스","currentUseSignal":"근린생활시설","leaseSignal":"임대중","vacancySignal":"공실없음","tenantNames":["쿠팡","네이버"],"unitRentTexts":["301호: 1500만"],"sellerMotivationText":"자산 효율화","brokerNotes":["역세권 도보 3분 이내 매물"]},"detectedSensitiveFields":["exact_address","tenant_name"],"ambiguousFields":[],"warnings":[],"areaSignal":"역삼","assetType":"[건물명 비공개]","priceBand":"300억","sizeSignal":"3000평(약 9917.4㎡)","dealType":"매각","buildingName":"역삼 [건물명 비공개]","exactAddress":"역삼동 742-1","totalFloorArea":9917.3,"buildYear":2015,"currentUseSignal":"근린생활시설","vacancySignal":"공실 없음","fitSummary":"역세권 도보 3분 이내 근생 빌딩으로 시행/사옥 매입에 최적화","cautionSummary":"주요 임차인 만기 조율 필요","hiddenFields":["exact_address","seller_motivation"],"confidence":{"areaSignal":"confirmed","assetType":"confirmed","priceBand":"ai_hypothesis","fitSummary":"ai_hypothesis"},"missingData":["sizeSignal"],"boundaryNote":"본 자료는 실거래 통계 기반 참고치입니다.","buyerType":"법인 사옥형","budgetRange":{"min":50,"max":80,"display":"50억~80억"},"preferredRegions":["강남","성수"],"assetTypes":["[건물명 비공개]","사옥용"],"purchasePurpose":"사옥용 매입","mustHave":["역세권 도보 3분 이내","주차"],"niceToHave":["테라스","루프탑"],"riskTolerance":"medium","financingNote":"자본금 50% 준비","missingQuestions":["구체적인 입주 시기가 언제인가요?","선호하는 수익률이 있나요?"],"privacyNotes":["연락처 비공개"],"fitReasons":["매수자 예산(50-80억)에 부합하는 매물입니다.","요청하신 성수/강남 권역에 해당합니다."],"cautionReasons":["요청한 용도와 달리 명도 협의가 다소 필요합니다."],"recommendedNextAction":"현장 답사 제안","kakaoMessage":"안녕하세요! 요청하신 조건에 부합하는 추천 매물이 있어 안내해 드립니다. 확인해보시고 피드백 부탁드립니다.","title":"강남 역삼역 역세권 도보 3분 이내 오피스 사옥용 빌딩 매각","shortSummary":"역삼역 도보 5분 거리의 준신축급 대형 [건물명 비공개]입니다.","dealPoints":["역세권 도보 3분 이내","사옥 최적"],"cautionPoints":["명도 조율 필요"],"hiddenInfoNotice":["보증금 및 지번은 인가 후 확인 가능"],"gateMessage":"G1 등급 등록이 필요합니다.","kakaoText":"강남 역삼역 오피스 빌딩 매각 안내입니다.","exactUnitCandidate":"101호","floor":"1층","areaSqmText":"150㎡","spaceType":"office","depositText":"5000만","monthlyRentText":"400만","maintenanceFeeText":"50만","availableFromText":"즉시입주","leaseTermMonthsText":"24","incentivesText":"렌트프리(무상임대) 2개월","restrictions":[],"landlordIdentity":"김성수","currentTenant":"스타트업","vacancyReason":"이전 확장","rentNegotiation":"협의 가능","region":"성수동","areaSqm":150,"deposit":5000,"monthlyRent":400,"maintenanceFee":50,"availableFrom":"즉시입주","leaseTermMonths":24,"incentives":{"렌트프리(무상임대)(무상임대)Months":2,"interiorSupport":"일부 인테리어 지원","freeRentDetail":"렌트프리(무상임대) 2개월 지원"},"shortSummaryLease":"성수역 도보 5분 거리 1층 리테일 상가 매물입니다."}</a:t>
-            </a:r>
-            <a:endParaRPr lang="en-US" sz="930" dirty="0"/>
-          </a:p>
-        </p:txBody>
-      </p:sp>
-      <p:sp>
-        <p:nvSpPr>
-          <p:cNvPr id="14" name="Text 12"/>
+          <p:cNvPr id="10" name="Text 8"/>
           <p:cNvSpPr/>
           <p:nvPr/>
         </p:nvSpPr>
@@ -13175,7 +12929,7 @@
       </p:sp>
       <p:sp>
         <p:nvSpPr>
-          <p:cNvPr id="15" name="Text 13"/>
+          <p:cNvPr id="11" name="Text 9"/>
           <p:cNvSpPr/>
           <p:nvPr/>
         </p:nvSpPr>

</xml_diff>